<commit_message>
feat(bkm): sunum kapak başlığı kısaltıldı + her rakamlı slayda kapsam dipnotu
1. Kapak: "Sezon 2026 Kadro ve İş Hacmi Değerlendirmesi" iki satıra kırılıyor, alt satırda
   "Eylül 2026" öksüz kalıyordu → başlık "Kadro ve İş Hacmi Değerlendirmesi", alt satır
   "Sezon 2026 · Mağazalar · 2025 karşılaştırmalı · 2 Eylül 2026" (tek satır). Kapanış alt
   satırı da kısaltıldı.

2. dipnot() yardımcısı: logo bandının üstüne (y=6.02) ince kapsam notu. 12 rakamlı slaytta
   zorunlu — hangi mağazaların dahil olduğu her slaytta yazılı:
   • DIP_POS  → üç POS mağazası (FSM · Özlüce · İst. Yolu) + Heykel/Şura neden yok
   • DIP_BES  → beş mağazanın tamamı
   • DIP_KARMA → Yönetici Özeti: kadro beş mağaza, iş hacmi üç POS mağazası
   Kapsam karışıklığı hem Excel'de (köprü bloğu) hem sunumda (dipnot + kırmızı bant) kapandı.

Görsel QA yapıldı; dipnot logoya binmiyor, tablolarla çakışmıyor.

Co-Authored-By: Claude Opus 5 <noreply@anthropic.com>
</commit_message>
<xml_diff>
--- a/briefings/sezon-kadro-20260902/sunum-kadro-sezon2026.pptx
+++ b/briefings/sezon-kadro-20260902/sunum-kadro-sezon2026.pptx
@@ -5202,7 +5202,7 @@
           <a:lstStyle/>
           <a:p>
             <a:r>
-              <a:t>Sezon 2026 Kadro ve İş Hacmi Değerlendirmesi</a:t>
+              <a:t>Kadro ve İş Hacmi Değerlendirmesi</a:t>
             </a:r>
           </a:p>
         </p:txBody>
@@ -5223,7 +5223,7 @@
           <a:lstStyle/>
           <a:p>
             <a:r>
-              <a:t>Beş mağaza kadrosu · üç POS mağazası iş hacmi · 2025 karşılaştırmalı · 2 Eylül 2026</a:t>
+              <a:t>Sezon 2026 · Mağazalar · 2025 karşılaştırmalı · 2 Eylül 2026</a:t>
             </a:r>
           </a:p>
         </p:txBody>
@@ -5974,7 +5974,7 @@
                           </a:solidFill>
                           <a:latin typeface="Calibri"/>
                         </a:rPr>
-                        <a:t>Kasa</a:t>
+                        <a:t>Akademi</a:t>
                       </a:r>
                     </a:p>
                   </a:txBody>
@@ -5997,7 +5997,7 @@
                           </a:solidFill>
                           <a:latin typeface="Calibri"/>
                         </a:rPr>
-                        <a:t>+2</a:t>
+                        <a:t>+1</a:t>
                       </a:r>
                     </a:p>
                   </a:txBody>
@@ -6020,6 +6020,29 @@
                           </a:solidFill>
                           <a:latin typeface="Calibri"/>
                         </a:rPr>
+                        <a:t>0</a:t>
+                      </a:r>
+                    </a:p>
+                  </a:txBody>
+                  <a:tcPr>
+                    <a:solidFill>
+                      <a:srgbClr val="F2F2F2"/>
+                    </a:solidFill>
+                  </a:tcPr>
+                </a:tc>
+                <a:tc>
+                  <a:txBody>
+                    <a:bodyPr/>
+                    <a:lstStyle/>
+                    <a:p>
+                      <a:pPr algn="ctr"/>
+                      <a:r>
+                        <a:rPr sz="1050" b="0">
+                          <a:solidFill>
+                            <a:srgbClr val="333333"/>
+                          </a:solidFill>
+                          <a:latin typeface="Calibri"/>
+                        </a:rPr>
                         <a:t>+1</a:t>
                       </a:r>
                     </a:p>
@@ -6043,30 +6066,7 @@
                           </a:solidFill>
                           <a:latin typeface="Calibri"/>
                         </a:rPr>
-                        <a:t>-1</a:t>
-                      </a:r>
-                    </a:p>
-                  </a:txBody>
-                  <a:tcPr>
-                    <a:solidFill>
-                      <a:srgbClr val="F2F2F2"/>
-                    </a:solidFill>
-                  </a:tcPr>
-                </a:tc>
-                <a:tc>
-                  <a:txBody>
-                    <a:bodyPr/>
-                    <a:lstStyle/>
-                    <a:p>
-                      <a:pPr algn="ctr"/>
-                      <a:r>
-                        <a:rPr sz="1050" b="0">
-                          <a:solidFill>
-                            <a:srgbClr val="333333"/>
-                          </a:solidFill>
-                          <a:latin typeface="Calibri"/>
-                        </a:rPr>
-                        <a:t>—</a:t>
+                        <a:t>0</a:t>
                       </a:r>
                     </a:p>
                   </a:txBody>
@@ -6137,7 +6137,7 @@
                           </a:solidFill>
                           <a:latin typeface="Calibri"/>
                         </a:rPr>
-                        <a:t>Akademi</a:t>
+                        <a:t>Kasa</a:t>
                       </a:r>
                     </a:p>
                   </a:txBody>
@@ -6160,6 +6160,29 @@
                           </a:solidFill>
                           <a:latin typeface="Calibri"/>
                         </a:rPr>
+                        <a:t>+2</a:t>
+                      </a:r>
+                    </a:p>
+                  </a:txBody>
+                  <a:tcPr>
+                    <a:solidFill>
+                      <a:srgbClr val="FFFFFF"/>
+                    </a:solidFill>
+                  </a:tcPr>
+                </a:tc>
+                <a:tc>
+                  <a:txBody>
+                    <a:bodyPr/>
+                    <a:lstStyle/>
+                    <a:p>
+                      <a:pPr algn="ctr"/>
+                      <a:r>
+                        <a:rPr sz="1050" b="0">
+                          <a:solidFill>
+                            <a:srgbClr val="333333"/>
+                          </a:solidFill>
+                          <a:latin typeface="Calibri"/>
+                        </a:rPr>
                         <a:t>+1</a:t>
                       </a:r>
                     </a:p>
@@ -6183,7 +6206,7 @@
                           </a:solidFill>
                           <a:latin typeface="Calibri"/>
                         </a:rPr>
-                        <a:t>0</a:t>
+                        <a:t>-1</a:t>
                       </a:r>
                     </a:p>
                   </a:txBody>
@@ -6206,30 +6229,7 @@
                           </a:solidFill>
                           <a:latin typeface="Calibri"/>
                         </a:rPr>
-                        <a:t>+1</a:t>
-                      </a:r>
-                    </a:p>
-                  </a:txBody>
-                  <a:tcPr>
-                    <a:solidFill>
-                      <a:srgbClr val="FFFFFF"/>
-                    </a:solidFill>
-                  </a:tcPr>
-                </a:tc>
-                <a:tc>
-                  <a:txBody>
-                    <a:bodyPr/>
-                    <a:lstStyle/>
-                    <a:p>
-                      <a:pPr algn="ctr"/>
-                      <a:r>
-                        <a:rPr sz="1050" b="0">
-                          <a:solidFill>
-                            <a:srgbClr val="333333"/>
-                          </a:solidFill>
-                          <a:latin typeface="Calibri"/>
-                        </a:rPr>
-                        <a:t>0</a:t>
+                        <a:t>—</a:t>
                       </a:r>
                     </a:p>
                   </a:txBody>
@@ -6789,7 +6789,7 @@
                           </a:solidFill>
                           <a:latin typeface="Calibri"/>
                         </a:rPr>
-                        <a:t>Mağaza</a:t>
+                        <a:t>İdari İşler</a:t>
                       </a:r>
                     </a:p>
                   </a:txBody>
@@ -6812,6 +6812,52 @@
                           </a:solidFill>
                           <a:latin typeface="Calibri"/>
                         </a:rPr>
+                        <a:t>+1</a:t>
+                      </a:r>
+                    </a:p>
+                  </a:txBody>
+                  <a:tcPr>
+                    <a:solidFill>
+                      <a:srgbClr val="FFFFFF"/>
+                    </a:solidFill>
+                  </a:tcPr>
+                </a:tc>
+                <a:tc>
+                  <a:txBody>
+                    <a:bodyPr/>
+                    <a:lstStyle/>
+                    <a:p>
+                      <a:pPr algn="ctr"/>
+                      <a:r>
+                        <a:rPr sz="1050" b="0">
+                          <a:solidFill>
+                            <a:srgbClr val="333333"/>
+                          </a:solidFill>
+                          <a:latin typeface="Calibri"/>
+                        </a:rPr>
+                        <a:t>-1</a:t>
+                      </a:r>
+                    </a:p>
+                  </a:txBody>
+                  <a:tcPr>
+                    <a:solidFill>
+                      <a:srgbClr val="FFFFFF"/>
+                    </a:solidFill>
+                  </a:tcPr>
+                </a:tc>
+                <a:tc>
+                  <a:txBody>
+                    <a:bodyPr/>
+                    <a:lstStyle/>
+                    <a:p>
+                      <a:pPr algn="ctr"/>
+                      <a:r>
+                        <a:rPr sz="1050" b="0">
+                          <a:solidFill>
+                            <a:srgbClr val="333333"/>
+                          </a:solidFill>
+                          <a:latin typeface="Calibri"/>
+                        </a:rPr>
                         <a:t>0</a:t>
                       </a:r>
                     </a:p>
@@ -6835,53 +6881,7 @@
                           </a:solidFill>
                           <a:latin typeface="Calibri"/>
                         </a:rPr>
-                        <a:t>0</a:t>
-                      </a:r>
-                    </a:p>
-                  </a:txBody>
-                  <a:tcPr>
-                    <a:solidFill>
-                      <a:srgbClr val="FFFFFF"/>
-                    </a:solidFill>
-                  </a:tcPr>
-                </a:tc>
-                <a:tc>
-                  <a:txBody>
-                    <a:bodyPr/>
-                    <a:lstStyle/>
-                    <a:p>
-                      <a:pPr algn="ctr"/>
-                      <a:r>
-                        <a:rPr sz="1050" b="0">
-                          <a:solidFill>
-                            <a:srgbClr val="333333"/>
-                          </a:solidFill>
-                          <a:latin typeface="Calibri"/>
-                        </a:rPr>
-                        <a:t>0</a:t>
-                      </a:r>
-                    </a:p>
-                  </a:txBody>
-                  <a:tcPr>
-                    <a:solidFill>
-                      <a:srgbClr val="FFFFFF"/>
-                    </a:solidFill>
-                  </a:tcPr>
-                </a:tc>
-                <a:tc>
-                  <a:txBody>
-                    <a:bodyPr/>
-                    <a:lstStyle/>
-                    <a:p>
-                      <a:pPr algn="ctr"/>
-                      <a:r>
-                        <a:rPr sz="1050" b="0">
-                          <a:solidFill>
-                            <a:srgbClr val="333333"/>
-                          </a:solidFill>
-                          <a:latin typeface="Calibri"/>
-                        </a:rPr>
-                        <a:t>0</a:t>
+                        <a:t>—</a:t>
                       </a:r>
                     </a:p>
                   </a:txBody>
@@ -7115,7 +7115,7 @@
                           </a:solidFill>
                           <a:latin typeface="Calibri"/>
                         </a:rPr>
-                        <a:t>İdari İşler</a:t>
+                        <a:t>Mağaza</a:t>
                       </a:r>
                     </a:p>
                   </a:txBody>
@@ -7138,7 +7138,7 @@
                           </a:solidFill>
                           <a:latin typeface="Calibri"/>
                         </a:rPr>
-                        <a:t>+1</a:t>
+                        <a:t>0</a:t>
                       </a:r>
                     </a:p>
                   </a:txBody>
@@ -7161,7 +7161,7 @@
                           </a:solidFill>
                           <a:latin typeface="Calibri"/>
                         </a:rPr>
-                        <a:t>-1</a:t>
+                        <a:t>0</a:t>
                       </a:r>
                     </a:p>
                   </a:txBody>
@@ -7207,7 +7207,7 @@
                           </a:solidFill>
                           <a:latin typeface="Calibri"/>
                         </a:rPr>
-                        <a:t>—</a:t>
+                        <a:t>0</a:t>
                       </a:r>
                     </a:p>
                   </a:txBody>
@@ -7473,6 +7473,45 @@
       <p:sp>
         <p:nvSpPr>
           <p:cNvPr id="5" name="TextBox 4"/>
+          <p:cNvSpPr txBox="1"/>
+          <p:nvPr/>
+        </p:nvSpPr>
+        <p:spPr>
+          <a:xfrm>
+            <a:off x="548640" y="5504688"/>
+            <a:ext cx="7772400" cy="292608"/>
+          </a:xfrm>
+          <a:prstGeom prst="rect">
+            <a:avLst/>
+          </a:prstGeom>
+          <a:noFill/>
+        </p:spPr>
+        <p:txBody>
+          <a:bodyPr wrap="square" anchor="t">
+            <a:spAutoFit/>
+          </a:bodyPr>
+          <a:lstStyle/>
+          <a:p>
+            <a:pPr algn="l">
+              <a:lnSpc>
+                <a:spcPct val="100000"/>
+              </a:lnSpc>
+            </a:pPr>
+            <a:r>
+              <a:rPr sz="900" b="0">
+                <a:solidFill>
+                  <a:srgbClr val="9A9A9A"/>
+                </a:solidFill>
+                <a:latin typeface="Calibri"/>
+              </a:rPr>
+              <a:t>* Kapsam: beş mağazanın tamamı — FSM · Özlüce · İst. Yolu · Heykel · Şura.</a:t>
+            </a:r>
+          </a:p>
+        </p:txBody>
+      </p:sp>
+      <p:sp>
+        <p:nvSpPr>
+          <p:cNvPr id="6" name="TextBox 5"/>
           <p:cNvSpPr txBox="1"/>
           <p:nvPr/>
         </p:nvSpPr>
@@ -8535,6 +8574,45 @@
         </p:nvSpPr>
         <p:spPr>
           <a:xfrm>
+            <a:off x="548640" y="5504688"/>
+            <a:ext cx="7772400" cy="292608"/>
+          </a:xfrm>
+          <a:prstGeom prst="rect">
+            <a:avLst/>
+          </a:prstGeom>
+          <a:noFill/>
+        </p:spPr>
+        <p:txBody>
+          <a:bodyPr wrap="square" anchor="t">
+            <a:spAutoFit/>
+          </a:bodyPr>
+          <a:lstStyle/>
+          <a:p>
+            <a:pPr algn="l">
+              <a:lnSpc>
+                <a:spcPct val="100000"/>
+              </a:lnSpc>
+            </a:pPr>
+            <a:r>
+              <a:rPr sz="900" b="0">
+                <a:solidFill>
+                  <a:srgbClr val="9A9A9A"/>
+                </a:solidFill>
+                <a:latin typeface="Calibri"/>
+              </a:rPr>
+              <a:t>* Kapsam: üç POS mağazası — FSM · Özlüce · İst. Yolu. Heykel ve Şura POS raporlamasında olmadığı için iş hacmi ölçümlerine girmez.</a:t>
+            </a:r>
+          </a:p>
+        </p:txBody>
+      </p:sp>
+      <p:sp>
+        <p:nvSpPr>
+          <p:cNvPr id="8" name="TextBox 7"/>
+          <p:cNvSpPr txBox="1"/>
+          <p:nvPr/>
+        </p:nvSpPr>
+        <p:spPr>
+          <a:xfrm>
             <a:off x="8503920" y="6355080"/>
             <a:ext cx="3108960" cy="274320"/>
           </a:xfrm>
@@ -9795,6 +9873,45 @@
         </p:nvSpPr>
         <p:spPr>
           <a:xfrm>
+            <a:off x="548640" y="5504688"/>
+            <a:ext cx="7772400" cy="292608"/>
+          </a:xfrm>
+          <a:prstGeom prst="rect">
+            <a:avLst/>
+          </a:prstGeom>
+          <a:noFill/>
+        </p:spPr>
+        <p:txBody>
+          <a:bodyPr wrap="square" anchor="t">
+            <a:spAutoFit/>
+          </a:bodyPr>
+          <a:lstStyle/>
+          <a:p>
+            <a:pPr algn="l">
+              <a:lnSpc>
+                <a:spcPct val="100000"/>
+              </a:lnSpc>
+            </a:pPr>
+            <a:r>
+              <a:rPr sz="900" b="0">
+                <a:solidFill>
+                  <a:srgbClr val="9A9A9A"/>
+                </a:solidFill>
+                <a:latin typeface="Calibri"/>
+              </a:rPr>
+              <a:t>* Kapsam: üç POS mağazası — FSM · Özlüce · İst. Yolu. Heykel ve Şura POS raporlamasında olmadığı için iş hacmi ölçümlerine girmez.</a:t>
+            </a:r>
+          </a:p>
+        </p:txBody>
+      </p:sp>
+      <p:sp>
+        <p:nvSpPr>
+          <p:cNvPr id="9" name="TextBox 8"/>
+          <p:cNvSpPr txBox="1"/>
+          <p:nvPr/>
+        </p:nvSpPr>
+        <p:spPr>
+          <a:xfrm>
             <a:off x="8503920" y="6355080"/>
             <a:ext cx="3108960" cy="274320"/>
           </a:xfrm>
@@ -10655,6 +10772,45 @@
         </p:nvSpPr>
         <p:spPr>
           <a:xfrm>
+            <a:off x="548640" y="5504688"/>
+            <a:ext cx="7772400" cy="292608"/>
+          </a:xfrm>
+          <a:prstGeom prst="rect">
+            <a:avLst/>
+          </a:prstGeom>
+          <a:noFill/>
+        </p:spPr>
+        <p:txBody>
+          <a:bodyPr wrap="square" anchor="t">
+            <a:spAutoFit/>
+          </a:bodyPr>
+          <a:lstStyle/>
+          <a:p>
+            <a:pPr algn="l">
+              <a:lnSpc>
+                <a:spcPct val="100000"/>
+              </a:lnSpc>
+            </a:pPr>
+            <a:r>
+              <a:rPr sz="900" b="0">
+                <a:solidFill>
+                  <a:srgbClr val="9A9A9A"/>
+                </a:solidFill>
+                <a:latin typeface="Calibri"/>
+              </a:rPr>
+              <a:t>* Kapsam: üç POS mağazası — FSM · Özlüce · İst. Yolu. Heykel ve Şura POS raporlamasında olmadığı için iş hacmi ölçümlerine girmez.</a:t>
+            </a:r>
+          </a:p>
+        </p:txBody>
+      </p:sp>
+      <p:sp>
+        <p:nvSpPr>
+          <p:cNvPr id="24" name="TextBox 23"/>
+          <p:cNvSpPr txBox="1"/>
+          <p:nvPr/>
+        </p:nvSpPr>
+        <p:spPr>
+          <a:xfrm>
             <a:off x="8503920" y="6355080"/>
             <a:ext cx="3108960" cy="274320"/>
           </a:xfrm>
@@ -11264,6 +11420,45 @@
         </p:nvSpPr>
         <p:spPr>
           <a:xfrm>
+            <a:off x="548640" y="5504688"/>
+            <a:ext cx="7772400" cy="292608"/>
+          </a:xfrm>
+          <a:prstGeom prst="rect">
+            <a:avLst/>
+          </a:prstGeom>
+          <a:noFill/>
+        </p:spPr>
+        <p:txBody>
+          <a:bodyPr wrap="square" anchor="t">
+            <a:spAutoFit/>
+          </a:bodyPr>
+          <a:lstStyle/>
+          <a:p>
+            <a:pPr algn="l">
+              <a:lnSpc>
+                <a:spcPct val="100000"/>
+              </a:lnSpc>
+            </a:pPr>
+            <a:r>
+              <a:rPr sz="900" b="0">
+                <a:solidFill>
+                  <a:srgbClr val="9A9A9A"/>
+                </a:solidFill>
+                <a:latin typeface="Calibri"/>
+              </a:rPr>
+              <a:t>* Kapsam: beş mağazanın tamamı — FSM · Özlüce · İst. Yolu · Heykel · Şura. Tutunma ölçümü mağaza kadrosu üzerinden yapılmıştır.</a:t>
+            </a:r>
+          </a:p>
+        </p:txBody>
+      </p:sp>
+      <p:sp>
+        <p:nvSpPr>
+          <p:cNvPr id="16" name="TextBox 15"/>
+          <p:cNvSpPr txBox="1"/>
+          <p:nvPr/>
+        </p:nvSpPr>
+        <p:spPr>
+          <a:xfrm>
             <a:off x="8503920" y="6355080"/>
             <a:ext cx="3108960" cy="274320"/>
           </a:xfrm>
@@ -11364,7 +11559,7 @@
           <a:lstStyle/>
           <a:p>
             <a:r>
-              <a:t>Kadro farkı sezon öncesinde oluşmuştur · sezon dönemi kadrolu -4 · ürün adedi +%34,9 · personel başına iş +%20,6</a:t>
+              <a:t>Sezon dönemi kadrolu -4 · ürün adedi +%34,9 · personel başına iş +%20,6</a:t>
             </a:r>
           </a:p>
         </p:txBody>
@@ -14187,6 +14382,45 @@
         </p:nvSpPr>
         <p:spPr>
           <a:xfrm>
+            <a:off x="548640" y="5504688"/>
+            <a:ext cx="7772400" cy="292608"/>
+          </a:xfrm>
+          <a:prstGeom prst="rect">
+            <a:avLst/>
+          </a:prstGeom>
+          <a:noFill/>
+        </p:spPr>
+        <p:txBody>
+          <a:bodyPr wrap="square" anchor="t">
+            <a:spAutoFit/>
+          </a:bodyPr>
+          <a:lstStyle/>
+          <a:p>
+            <a:pPr algn="l">
+              <a:lnSpc>
+                <a:spcPct val="100000"/>
+              </a:lnSpc>
+            </a:pPr>
+            <a:r>
+              <a:rPr sz="900" b="0">
+                <a:solidFill>
+                  <a:srgbClr val="9A9A9A"/>
+                </a:solidFill>
+                <a:latin typeface="Calibri"/>
+              </a:rPr>
+              <a:t>* Kapsam: kadro rakamları beş mağaza (FSM · Özlüce · İst. Yolu · Heykel · Şura); iş hacmi ve personel başına rakamlar üç POS mağazası (FSM · Özlüce · İst. Yolu).</a:t>
+            </a:r>
+          </a:p>
+        </p:txBody>
+      </p:sp>
+      <p:sp>
+        <p:nvSpPr>
+          <p:cNvPr id="34" name="TextBox 33"/>
+          <p:cNvSpPr txBox="1"/>
+          <p:nvPr/>
+        </p:nvSpPr>
+        <p:spPr>
+          <a:xfrm>
             <a:off x="8503920" y="6355080"/>
             <a:ext cx="3108960" cy="274320"/>
           </a:xfrm>
@@ -15589,6 +15823,45 @@
         </p:nvSpPr>
         <p:spPr>
           <a:xfrm>
+            <a:off x="548640" y="5504688"/>
+            <a:ext cx="7772400" cy="292608"/>
+          </a:xfrm>
+          <a:prstGeom prst="rect">
+            <a:avLst/>
+          </a:prstGeom>
+          <a:noFill/>
+        </p:spPr>
+        <p:txBody>
+          <a:bodyPr wrap="square" anchor="t">
+            <a:spAutoFit/>
+          </a:bodyPr>
+          <a:lstStyle/>
+          <a:p>
+            <a:pPr algn="l">
+              <a:lnSpc>
+                <a:spcPct val="100000"/>
+              </a:lnSpc>
+            </a:pPr>
+            <a:r>
+              <a:rPr sz="900" b="0">
+                <a:solidFill>
+                  <a:srgbClr val="9A9A9A"/>
+                </a:solidFill>
+                <a:latin typeface="Calibri"/>
+              </a:rPr>
+              <a:t>* Kapsam: beş mağazanın tamamı — FSM · Özlüce · İst. Yolu · Heykel · Şura.</a:t>
+            </a:r>
+          </a:p>
+        </p:txBody>
+      </p:sp>
+      <p:sp>
+        <p:nvSpPr>
+          <p:cNvPr id="36" name="TextBox 35"/>
+          <p:cNvSpPr txBox="1"/>
+          <p:nvPr/>
+        </p:nvSpPr>
+        <p:spPr>
+          <a:xfrm>
             <a:off x="8503920" y="6355080"/>
             <a:ext cx="3108960" cy="274320"/>
           </a:xfrm>
@@ -17359,7 +17632,7 @@
         <p:spPr>
           <a:xfrm>
             <a:off x="548640" y="5285232"/>
-            <a:ext cx="11018520" cy="411480"/>
+            <a:ext cx="11018520" cy="274320"/>
           </a:xfrm>
           <a:prstGeom prst="rect">
             <a:avLst/>
@@ -17384,7 +17657,7 @@
                 </a:solidFill>
                 <a:latin typeface="Calibri"/>
               </a:rPr>
-              <a:t>Kadrolu = sezonluk dışı personel · Sezon içi = 31.08 kesimi ile 30.06 tabanı arasındaki değişim (her iki yılda da negatif: -4 ve -4) · Heykel ve Şura POS raporlamasında yok, kadro tablosunda beş mağazanın tamamı yer alır.</a:t>
+              <a:t>Kadrolu = sezonluk dışı personel · Sezon içi = 31.08 kesimi ile 30.06 tabanı arasındaki değişim (her iki yılda da negatif: -4 ve -4).</a:t>
             </a:r>
           </a:p>
         </p:txBody>
@@ -17392,6 +17665,45 @@
       <p:sp>
         <p:nvSpPr>
           <p:cNvPr id="7" name="TextBox 6"/>
+          <p:cNvSpPr txBox="1"/>
+          <p:nvPr/>
+        </p:nvSpPr>
+        <p:spPr>
+          <a:xfrm>
+            <a:off x="548640" y="5504688"/>
+            <a:ext cx="7772400" cy="292608"/>
+          </a:xfrm>
+          <a:prstGeom prst="rect">
+            <a:avLst/>
+          </a:prstGeom>
+          <a:noFill/>
+        </p:spPr>
+        <p:txBody>
+          <a:bodyPr wrap="square" anchor="t">
+            <a:spAutoFit/>
+          </a:bodyPr>
+          <a:lstStyle/>
+          <a:p>
+            <a:pPr algn="l">
+              <a:lnSpc>
+                <a:spcPct val="100000"/>
+              </a:lnSpc>
+            </a:pPr>
+            <a:r>
+              <a:rPr sz="900" b="0">
+                <a:solidFill>
+                  <a:srgbClr val="9A9A9A"/>
+                </a:solidFill>
+                <a:latin typeface="Calibri"/>
+              </a:rPr>
+              <a:t>* Kapsam: beş mağazanın tamamı — FSM · Özlüce · İst. Yolu · Heykel · Şura. İş hacmi kapsamı üç POS mağazasıdır (FSM · Özlüce · İst. Yolu).</a:t>
+            </a:r>
+          </a:p>
+        </p:txBody>
+      </p:sp>
+      <p:sp>
+        <p:nvSpPr>
+          <p:cNvPr id="8" name="TextBox 7"/>
           <p:cNvSpPr txBox="1"/>
           <p:nvPr/>
         </p:nvSpPr>
@@ -18268,6 +18580,45 @@
         </p:nvSpPr>
         <p:spPr>
           <a:xfrm>
+            <a:off x="548640" y="5504688"/>
+            <a:ext cx="7772400" cy="292608"/>
+          </a:xfrm>
+          <a:prstGeom prst="rect">
+            <a:avLst/>
+          </a:prstGeom>
+          <a:noFill/>
+        </p:spPr>
+        <p:txBody>
+          <a:bodyPr wrap="square" anchor="t">
+            <a:spAutoFit/>
+          </a:bodyPr>
+          <a:lstStyle/>
+          <a:p>
+            <a:pPr algn="l">
+              <a:lnSpc>
+                <a:spcPct val="100000"/>
+              </a:lnSpc>
+            </a:pPr>
+            <a:r>
+              <a:rPr sz="900" b="0">
+                <a:solidFill>
+                  <a:srgbClr val="9A9A9A"/>
+                </a:solidFill>
+                <a:latin typeface="Calibri"/>
+              </a:rPr>
+              <a:t>* Kapsam: üç POS mağazası — FSM · Özlüce · İst. Yolu. Heykel ve Şura POS raporlamasında olmadığı için iş hacmi ölçümlerine girmez.</a:t>
+            </a:r>
+          </a:p>
+        </p:txBody>
+      </p:sp>
+      <p:sp>
+        <p:nvSpPr>
+          <p:cNvPr id="23" name="TextBox 22"/>
+          <p:cNvSpPr txBox="1"/>
+          <p:nvPr/>
+        </p:nvSpPr>
+        <p:spPr>
+          <a:xfrm>
             <a:off x="8503920" y="6355080"/>
             <a:ext cx="3108960" cy="274320"/>
           </a:xfrm>
@@ -19038,6 +19389,45 @@
         </p:nvSpPr>
         <p:spPr>
           <a:xfrm>
+            <a:off x="548640" y="5504688"/>
+            <a:ext cx="7772400" cy="292608"/>
+          </a:xfrm>
+          <a:prstGeom prst="rect">
+            <a:avLst/>
+          </a:prstGeom>
+          <a:noFill/>
+        </p:spPr>
+        <p:txBody>
+          <a:bodyPr wrap="square" anchor="t">
+            <a:spAutoFit/>
+          </a:bodyPr>
+          <a:lstStyle/>
+          <a:p>
+            <a:pPr algn="l">
+              <a:lnSpc>
+                <a:spcPct val="100000"/>
+              </a:lnSpc>
+            </a:pPr>
+            <a:r>
+              <a:rPr sz="900" b="0">
+                <a:solidFill>
+                  <a:srgbClr val="9A9A9A"/>
+                </a:solidFill>
+                <a:latin typeface="Calibri"/>
+              </a:rPr>
+              <a:t>* Kapsam: üç POS mağazası — FSM · Özlüce · İst. Yolu. Heykel ve Şura POS raporlamasında olmadığı için iş hacmi ölçümlerine girmez.</a:t>
+            </a:r>
+          </a:p>
+        </p:txBody>
+      </p:sp>
+      <p:sp>
+        <p:nvSpPr>
+          <p:cNvPr id="21" name="TextBox 20"/>
+          <p:cNvSpPr txBox="1"/>
+          <p:nvPr/>
+        </p:nvSpPr>
+        <p:spPr>
+          <a:xfrm>
             <a:off x="8503920" y="6355080"/>
             <a:ext cx="3108960" cy="274320"/>
           </a:xfrm>
@@ -19691,6 +20081,45 @@
         </p:nvSpPr>
         <p:spPr>
           <a:xfrm>
+            <a:off x="548640" y="5504688"/>
+            <a:ext cx="7772400" cy="292608"/>
+          </a:xfrm>
+          <a:prstGeom prst="rect">
+            <a:avLst/>
+          </a:prstGeom>
+          <a:noFill/>
+        </p:spPr>
+        <p:txBody>
+          <a:bodyPr wrap="square" anchor="t">
+            <a:spAutoFit/>
+          </a:bodyPr>
+          <a:lstStyle/>
+          <a:p>
+            <a:pPr algn="l">
+              <a:lnSpc>
+                <a:spcPct val="100000"/>
+              </a:lnSpc>
+            </a:pPr>
+            <a:r>
+              <a:rPr sz="900" b="0">
+                <a:solidFill>
+                  <a:srgbClr val="9A9A9A"/>
+                </a:solidFill>
+                <a:latin typeface="Calibri"/>
+              </a:rPr>
+              <a:t>* Kapsam: üç POS mağazası — FSM · Özlüce · İst. Yolu. Heykel ve Şura POS raporlamasında olmadığı için iş hacmi ölçümlerine girmez.</a:t>
+            </a:r>
+          </a:p>
+        </p:txBody>
+      </p:sp>
+      <p:sp>
+        <p:nvSpPr>
+          <p:cNvPr id="18" name="TextBox 17"/>
+          <p:cNvSpPr txBox="1"/>
+          <p:nvPr/>
+        </p:nvSpPr>
+        <p:spPr>
+          <a:xfrm>
             <a:off x="8503920" y="6355080"/>
             <a:ext cx="3108960" cy="274320"/>
           </a:xfrm>
@@ -20233,6 +20662,45 @@
       <p:sp>
         <p:nvSpPr>
           <p:cNvPr id="14" name="TextBox 13"/>
+          <p:cNvSpPr txBox="1"/>
+          <p:nvPr/>
+        </p:nvSpPr>
+        <p:spPr>
+          <a:xfrm>
+            <a:off x="548640" y="5504688"/>
+            <a:ext cx="7772400" cy="292608"/>
+          </a:xfrm>
+          <a:prstGeom prst="rect">
+            <a:avLst/>
+          </a:prstGeom>
+          <a:noFill/>
+        </p:spPr>
+        <p:txBody>
+          <a:bodyPr wrap="square" anchor="t">
+            <a:spAutoFit/>
+          </a:bodyPr>
+          <a:lstStyle/>
+          <a:p>
+            <a:pPr algn="l">
+              <a:lnSpc>
+                <a:spcPct val="100000"/>
+              </a:lnSpc>
+            </a:pPr>
+            <a:r>
+              <a:rPr sz="900" b="0">
+                <a:solidFill>
+                  <a:srgbClr val="9A9A9A"/>
+                </a:solidFill>
+                <a:latin typeface="Calibri"/>
+              </a:rPr>
+              <a:t>* Kapsam: beş mağazanın tamamı — FSM · Özlüce · İst. Yolu · Heykel · Şura.</a:t>
+            </a:r>
+          </a:p>
+        </p:txBody>
+      </p:sp>
+      <p:sp>
+        <p:nvSpPr>
+          <p:cNvPr id="15" name="TextBox 14"/>
           <p:cNvSpPr txBox="1"/>
           <p:nvPr/>
         </p:nvSpPr>

</xml_diff>

<commit_message>
fix(bkm): kart vurgu şeridi karta yapıştırıldı (yuvarlak köşe taşması)
Kullanıcı: "hâlâ kutular çizginin altına giriyor". PNG'yi büyütüp baktım: şerit kartla aynı
x/y'de ve KARE köşeli çiziliyordu; kart yuvarlak köşeli olduğu için şeridin kare uçları
köşenin dışına taşıyor ve şerit kartın ÜSTÜNDE bağımsız bir çizgi gibi duruyordu — kart da
o çizginin altına kaçmış görünüyordu.

card(): şerit yatayda köşe yarıçapı kadar içe alındı (x+0.09, w−0.18) ve 0.03 aşağı indirildi
(y+0.03, kalınlık 0.07 → 0.06). Artık uçları yuvarlak köşeyle hizalı, karta yapışık.
Tüm kartlar ve KPI kutuları aynı fonksiyonu kullandığı için 16 slaytta birden düzeldi.

Yerleşim denetçisi: ✓ ihlal yok. Büyütülmüş kırpma ile kart üst kenarı ve KPI kutuları
görsel olarak da doğrulandı.

Co-Authored-By: Claude Opus 5 <noreply@anthropic.com>
</commit_message>
<xml_diff>
--- a/briefings/sezon-kadro-20260902/sunum-kadro-sezon2026.pptx
+++ b/briefings/sezon-kadro-20260902/sunum-kadro-sezon2026.pptx
@@ -6046,7 +6046,7 @@
                           </a:solidFill>
                           <a:latin typeface="Calibri"/>
                         </a:rPr>
-                        <a:t>Akademi</a:t>
+                        <a:t>Kasa</a:t>
                       </a:r>
                     </a:p>
                   </a:txBody>
@@ -6069,6 +6069,29 @@
                           </a:solidFill>
                           <a:latin typeface="Calibri"/>
                         </a:rPr>
+                        <a:t>+2</a:t>
+                      </a:r>
+                    </a:p>
+                  </a:txBody>
+                  <a:tcPr>
+                    <a:solidFill>
+                      <a:srgbClr val="FFFFFF"/>
+                    </a:solidFill>
+                  </a:tcPr>
+                </a:tc>
+                <a:tc>
+                  <a:txBody>
+                    <a:bodyPr/>
+                    <a:lstStyle/>
+                    <a:p>
+                      <a:pPr algn="ctr"/>
+                      <a:r>
+                        <a:rPr sz="1050" b="0">
+                          <a:solidFill>
+                            <a:srgbClr val="333333"/>
+                          </a:solidFill>
+                          <a:latin typeface="Calibri"/>
+                        </a:rPr>
                         <a:t>+1</a:t>
                       </a:r>
                     </a:p>
@@ -6092,7 +6115,7 @@
                           </a:solidFill>
                           <a:latin typeface="Calibri"/>
                         </a:rPr>
-                        <a:t>0</a:t>
+                        <a:t>-1</a:t>
                       </a:r>
                     </a:p>
                   </a:txBody>
@@ -6115,30 +6138,7 @@
                           </a:solidFill>
                           <a:latin typeface="Calibri"/>
                         </a:rPr>
-                        <a:t>+1</a:t>
-                      </a:r>
-                    </a:p>
-                  </a:txBody>
-                  <a:tcPr>
-                    <a:solidFill>
-                      <a:srgbClr val="FFFFFF"/>
-                    </a:solidFill>
-                  </a:tcPr>
-                </a:tc>
-                <a:tc>
-                  <a:txBody>
-                    <a:bodyPr/>
-                    <a:lstStyle/>
-                    <a:p>
-                      <a:pPr algn="ctr"/>
-                      <a:r>
-                        <a:rPr sz="1050" b="0">
-                          <a:solidFill>
-                            <a:srgbClr val="333333"/>
-                          </a:solidFill>
-                          <a:latin typeface="Calibri"/>
-                        </a:rPr>
-                        <a:t>0</a:t>
+                        <a:t>—</a:t>
                       </a:r>
                     </a:p>
                   </a:txBody>
@@ -6209,7 +6209,7 @@
                           </a:solidFill>
                           <a:latin typeface="Calibri"/>
                         </a:rPr>
-                        <a:t>Kasa</a:t>
+                        <a:t>Akademi</a:t>
                       </a:r>
                     </a:p>
                   </a:txBody>
@@ -6232,7 +6232,7 @@
                           </a:solidFill>
                           <a:latin typeface="Calibri"/>
                         </a:rPr>
-                        <a:t>+2</a:t>
+                        <a:t>+1</a:t>
                       </a:r>
                     </a:p>
                   </a:txBody>
@@ -6255,6 +6255,29 @@
                           </a:solidFill>
                           <a:latin typeface="Calibri"/>
                         </a:rPr>
+                        <a:t>0</a:t>
+                      </a:r>
+                    </a:p>
+                  </a:txBody>
+                  <a:tcPr>
+                    <a:solidFill>
+                      <a:srgbClr val="F2F2F2"/>
+                    </a:solidFill>
+                  </a:tcPr>
+                </a:tc>
+                <a:tc>
+                  <a:txBody>
+                    <a:bodyPr/>
+                    <a:lstStyle/>
+                    <a:p>
+                      <a:pPr algn="ctr"/>
+                      <a:r>
+                        <a:rPr sz="1050" b="0">
+                          <a:solidFill>
+                            <a:srgbClr val="333333"/>
+                          </a:solidFill>
+                          <a:latin typeface="Calibri"/>
+                        </a:rPr>
                         <a:t>+1</a:t>
                       </a:r>
                     </a:p>
@@ -6278,30 +6301,7 @@
                           </a:solidFill>
                           <a:latin typeface="Calibri"/>
                         </a:rPr>
-                        <a:t>-1</a:t>
-                      </a:r>
-                    </a:p>
-                  </a:txBody>
-                  <a:tcPr>
-                    <a:solidFill>
-                      <a:srgbClr val="F2F2F2"/>
-                    </a:solidFill>
-                  </a:tcPr>
-                </a:tc>
-                <a:tc>
-                  <a:txBody>
-                    <a:bodyPr/>
-                    <a:lstStyle/>
-                    <a:p>
-                      <a:pPr algn="ctr"/>
-                      <a:r>
-                        <a:rPr sz="1050" b="0">
-                          <a:solidFill>
-                            <a:srgbClr val="333333"/>
-                          </a:solidFill>
-                          <a:latin typeface="Calibri"/>
-                        </a:rPr>
-                        <a:t>—</a:t>
+                        <a:t>0</a:t>
                       </a:r>
                     </a:p>
                   </a:txBody>
@@ -6698,7 +6698,7 @@
                           </a:solidFill>
                           <a:latin typeface="Calibri"/>
                         </a:rPr>
-                        <a:t>Oyuncak</a:t>
+                        <a:t>Etkinlik</a:t>
                       </a:r>
                     </a:p>
                   </a:txBody>
@@ -6721,30 +6721,30 @@
                           </a:solidFill>
                           <a:latin typeface="Calibri"/>
                         </a:rPr>
+                        <a:t>0</a:t>
+                      </a:r>
+                    </a:p>
+                  </a:txBody>
+                  <a:tcPr>
+                    <a:solidFill>
+                      <a:srgbClr val="FFFFFF"/>
+                    </a:solidFill>
+                  </a:tcPr>
+                </a:tc>
+                <a:tc>
+                  <a:txBody>
+                    <a:bodyPr/>
+                    <a:lstStyle/>
+                    <a:p>
+                      <a:pPr algn="ctr"/>
+                      <a:r>
+                        <a:rPr sz="1050" b="0">
+                          <a:solidFill>
+                            <a:srgbClr val="333333"/>
+                          </a:solidFill>
+                          <a:latin typeface="Calibri"/>
+                        </a:rPr>
                         <a:t>+1</a:t>
-                      </a:r>
-                    </a:p>
-                  </a:txBody>
-                  <a:tcPr>
-                    <a:solidFill>
-                      <a:srgbClr val="FFFFFF"/>
-                    </a:solidFill>
-                  </a:tcPr>
-                </a:tc>
-                <a:tc>
-                  <a:txBody>
-                    <a:bodyPr/>
-                    <a:lstStyle/>
-                    <a:p>
-                      <a:pPr algn="ctr"/>
-                      <a:r>
-                        <a:rPr sz="1050" b="0">
-                          <a:solidFill>
-                            <a:srgbClr val="333333"/>
-                          </a:solidFill>
-                          <a:latin typeface="Calibri"/>
-                        </a:rPr>
-                        <a:t>0</a:t>
                       </a:r>
                     </a:p>
                   </a:txBody>
@@ -6861,7 +6861,7 @@
                           </a:solidFill>
                           <a:latin typeface="Calibri"/>
                         </a:rPr>
-                        <a:t>Etkinlik</a:t>
+                        <a:t>Oyuncak</a:t>
                       </a:r>
                     </a:p>
                   </a:txBody>
@@ -6884,30 +6884,30 @@
                           </a:solidFill>
                           <a:latin typeface="Calibri"/>
                         </a:rPr>
+                        <a:t>+1</a:t>
+                      </a:r>
+                    </a:p>
+                  </a:txBody>
+                  <a:tcPr>
+                    <a:solidFill>
+                      <a:srgbClr val="F2F2F2"/>
+                    </a:solidFill>
+                  </a:tcPr>
+                </a:tc>
+                <a:tc>
+                  <a:txBody>
+                    <a:bodyPr/>
+                    <a:lstStyle/>
+                    <a:p>
+                      <a:pPr algn="ctr"/>
+                      <a:r>
+                        <a:rPr sz="1050" b="0">
+                          <a:solidFill>
+                            <a:srgbClr val="333333"/>
+                          </a:solidFill>
+                          <a:latin typeface="Calibri"/>
+                        </a:rPr>
                         <a:t>0</a:t>
-                      </a:r>
-                    </a:p>
-                  </a:txBody>
-                  <a:tcPr>
-                    <a:solidFill>
-                      <a:srgbClr val="F2F2F2"/>
-                    </a:solidFill>
-                  </a:tcPr>
-                </a:tc>
-                <a:tc>
-                  <a:txBody>
-                    <a:bodyPr/>
-                    <a:lstStyle/>
-                    <a:p>
-                      <a:pPr algn="ctr"/>
-                      <a:r>
-                        <a:rPr sz="1050" b="0">
-                          <a:solidFill>
-                            <a:srgbClr val="333333"/>
-                          </a:solidFill>
-                          <a:latin typeface="Calibri"/>
-                        </a:rPr>
-                        <a:t>+1</a:t>
                       </a:r>
                     </a:p>
                   </a:txBody>
@@ -7513,7 +7513,7 @@
                           </a:solidFill>
                           <a:latin typeface="Calibri"/>
                         </a:rPr>
-                        <a:t>Muhasebe</a:t>
+                        <a:t>Ön Muhasebe</a:t>
                       </a:r>
                     </a:p>
                   </a:txBody>
@@ -7605,30 +7605,30 @@
                           </a:solidFill>
                           <a:latin typeface="Calibri"/>
                         </a:rPr>
+                        <a:t>—</a:t>
+                      </a:r>
+                    </a:p>
+                  </a:txBody>
+                  <a:tcPr>
+                    <a:solidFill>
+                      <a:srgbClr val="F2F2F2"/>
+                    </a:solidFill>
+                  </a:tcPr>
+                </a:tc>
+                <a:tc>
+                  <a:txBody>
+                    <a:bodyPr/>
+                    <a:lstStyle/>
+                    <a:p>
+                      <a:pPr algn="ctr"/>
+                      <a:r>
+                        <a:rPr sz="1050" b="1">
+                          <a:solidFill>
+                            <a:srgbClr val="333333"/>
+                          </a:solidFill>
+                          <a:latin typeface="Calibri"/>
+                        </a:rPr>
                         <a:t>-1</a:t>
-                      </a:r>
-                    </a:p>
-                  </a:txBody>
-                  <a:tcPr>
-                    <a:solidFill>
-                      <a:srgbClr val="F2F2F2"/>
-                    </a:solidFill>
-                  </a:tcPr>
-                </a:tc>
-                <a:tc>
-                  <a:txBody>
-                    <a:bodyPr/>
-                    <a:lstStyle/>
-                    <a:p>
-                      <a:pPr algn="ctr"/>
-                      <a:r>
-                        <a:rPr sz="1050" b="1">
-                          <a:solidFill>
-                            <a:srgbClr val="333333"/>
-                          </a:solidFill>
-                          <a:latin typeface="Calibri"/>
-                        </a:rPr>
-                        <a:t>—</a:t>
                       </a:r>
                     </a:p>
                   </a:txBody>
@@ -10300,8 +10300,8 @@
         </p:nvSpPr>
         <p:spPr>
           <a:xfrm>
-            <a:off x="548640" y="1371600"/>
-            <a:ext cx="3566160" cy="64008"/>
+            <a:off x="630936" y="1399032"/>
+            <a:ext cx="3401568" cy="54864"/>
           </a:xfrm>
           <a:prstGeom prst="rect">
             <a:avLst/>
@@ -10507,8 +10507,8 @@
         </p:nvSpPr>
         <p:spPr>
           <a:xfrm>
-            <a:off x="4279392" y="1371600"/>
-            <a:ext cx="3566160" cy="64008"/>
+            <a:off x="4361688" y="1399032"/>
+            <a:ext cx="3401568" cy="54864"/>
           </a:xfrm>
           <a:prstGeom prst="rect">
             <a:avLst/>
@@ -10714,8 +10714,8 @@
         </p:nvSpPr>
         <p:spPr>
           <a:xfrm>
-            <a:off x="8001000" y="1371600"/>
-            <a:ext cx="3566160" cy="64008"/>
+            <a:off x="8083296" y="1399032"/>
+            <a:ext cx="3401568" cy="54864"/>
           </a:xfrm>
           <a:prstGeom prst="rect">
             <a:avLst/>
@@ -11176,8 +11176,8 @@
         </p:nvSpPr>
         <p:spPr>
           <a:xfrm>
-            <a:off x="548640" y="1325880"/>
-            <a:ext cx="11018520" cy="64008"/>
+            <a:off x="630936" y="1353312"/>
+            <a:ext cx="10853928" cy="54864"/>
           </a:xfrm>
           <a:prstGeom prst="rect">
             <a:avLst/>
@@ -11368,8 +11368,8 @@
         </p:nvSpPr>
         <p:spPr>
           <a:xfrm>
-            <a:off x="548640" y="2404872"/>
-            <a:ext cx="11018520" cy="64008"/>
+            <a:off x="630936" y="2432303"/>
+            <a:ext cx="10853928" cy="54864"/>
           </a:xfrm>
           <a:prstGeom prst="rect">
             <a:avLst/>
@@ -11560,8 +11560,8 @@
         </p:nvSpPr>
         <p:spPr>
           <a:xfrm>
-            <a:off x="548640" y="3483863"/>
-            <a:ext cx="11018520" cy="64008"/>
+            <a:off x="630936" y="3511295"/>
+            <a:ext cx="10853928" cy="54864"/>
           </a:xfrm>
           <a:prstGeom prst="rect">
             <a:avLst/>
@@ -11752,8 +11752,8 @@
         </p:nvSpPr>
         <p:spPr>
           <a:xfrm>
-            <a:off x="548640" y="4562855"/>
-            <a:ext cx="11018520" cy="64008"/>
+            <a:off x="630936" y="4590288"/>
+            <a:ext cx="10853928" cy="54864"/>
           </a:xfrm>
           <a:prstGeom prst="rect">
             <a:avLst/>
@@ -12080,8 +12080,8 @@
         </p:nvSpPr>
         <p:spPr>
           <a:xfrm>
-            <a:off x="548640" y="1371600"/>
-            <a:ext cx="5394960" cy="64008"/>
+            <a:off x="630936" y="1399032"/>
+            <a:ext cx="5230368" cy="54864"/>
           </a:xfrm>
           <a:prstGeom prst="rect">
             <a:avLst/>
@@ -12287,8 +12287,8 @@
         </p:nvSpPr>
         <p:spPr>
           <a:xfrm>
-            <a:off x="6172200" y="1371600"/>
-            <a:ext cx="5394960" cy="64008"/>
+            <a:off x="6254496" y="1399032"/>
+            <a:ext cx="5230368" cy="54864"/>
           </a:xfrm>
           <a:prstGeom prst="rect">
             <a:avLst/>
@@ -12807,8 +12807,8 @@
         </p:nvSpPr>
         <p:spPr>
           <a:xfrm>
-            <a:off x="548640" y="1371600"/>
-            <a:ext cx="3566160" cy="64008"/>
+            <a:off x="630936" y="1399032"/>
+            <a:ext cx="3401568" cy="54864"/>
           </a:xfrm>
           <a:prstGeom prst="rect">
             <a:avLst/>
@@ -13043,8 +13043,8 @@
         </p:nvSpPr>
         <p:spPr>
           <a:xfrm>
-            <a:off x="4343400" y="1371600"/>
-            <a:ext cx="3566160" cy="64008"/>
+            <a:off x="4425696" y="1399032"/>
+            <a:ext cx="3401568" cy="54864"/>
           </a:xfrm>
           <a:prstGeom prst="rect">
             <a:avLst/>
@@ -13279,8 +13279,8 @@
         </p:nvSpPr>
         <p:spPr>
           <a:xfrm>
-            <a:off x="8138160" y="1371600"/>
-            <a:ext cx="3566160" cy="64008"/>
+            <a:off x="8220456" y="1399032"/>
+            <a:ext cx="3401568" cy="54864"/>
           </a:xfrm>
           <a:prstGeom prst="rect">
             <a:avLst/>
@@ -13515,8 +13515,8 @@
         </p:nvSpPr>
         <p:spPr>
           <a:xfrm>
-            <a:off x="548640" y="3337560"/>
-            <a:ext cx="3566160" cy="64008"/>
+            <a:off x="630936" y="3364991"/>
+            <a:ext cx="3401568" cy="54864"/>
           </a:xfrm>
           <a:prstGeom prst="rect">
             <a:avLst/>
@@ -13751,8 +13751,8 @@
         </p:nvSpPr>
         <p:spPr>
           <a:xfrm>
-            <a:off x="4343400" y="3337560"/>
-            <a:ext cx="3566160" cy="64008"/>
+            <a:off x="4425696" y="3364991"/>
+            <a:ext cx="3401568" cy="54864"/>
           </a:xfrm>
           <a:prstGeom prst="rect">
             <a:avLst/>
@@ -13987,8 +13987,8 @@
         </p:nvSpPr>
         <p:spPr>
           <a:xfrm>
-            <a:off x="8138160" y="3337560"/>
-            <a:ext cx="3566160" cy="64008"/>
+            <a:off x="8220456" y="3364991"/>
+            <a:ext cx="3401568" cy="54864"/>
           </a:xfrm>
           <a:prstGeom prst="rect">
             <a:avLst/>
@@ -14320,8 +14320,8 @@
         </p:nvSpPr>
         <p:spPr>
           <a:xfrm>
-            <a:off x="548640" y="1371600"/>
-            <a:ext cx="2651760" cy="64008"/>
+            <a:off x="630936" y="1399032"/>
+            <a:ext cx="2487168" cy="54864"/>
           </a:xfrm>
           <a:prstGeom prst="rect">
             <a:avLst/>
@@ -14527,8 +14527,8 @@
         </p:nvSpPr>
         <p:spPr>
           <a:xfrm>
-            <a:off x="3337560" y="1371600"/>
-            <a:ext cx="2651760" cy="64008"/>
+            <a:off x="3419856" y="1399032"/>
+            <a:ext cx="2487168" cy="54864"/>
           </a:xfrm>
           <a:prstGeom prst="rect">
             <a:avLst/>
@@ -14734,8 +14734,8 @@
         </p:nvSpPr>
         <p:spPr>
           <a:xfrm>
-            <a:off x="6126480" y="1371600"/>
-            <a:ext cx="2651760" cy="64008"/>
+            <a:off x="6208776" y="1399032"/>
+            <a:ext cx="2487168" cy="54864"/>
           </a:xfrm>
           <a:prstGeom prst="rect">
             <a:avLst/>
@@ -14941,8 +14941,8 @@
         </p:nvSpPr>
         <p:spPr>
           <a:xfrm>
-            <a:off x="8915400" y="1371600"/>
-            <a:ext cx="2651760" cy="64008"/>
+            <a:off x="8997696" y="1399032"/>
+            <a:ext cx="2487168" cy="54864"/>
           </a:xfrm>
           <a:prstGeom prst="rect">
             <a:avLst/>
@@ -15233,8 +15233,8 @@
         </p:nvSpPr>
         <p:spPr>
           <a:xfrm>
-            <a:off x="548640" y="4434840"/>
-            <a:ext cx="5394960" cy="64008"/>
+            <a:off x="630936" y="4462272"/>
+            <a:ext cx="5230368" cy="54864"/>
           </a:xfrm>
           <a:prstGeom prst="rect">
             <a:avLst/>
@@ -15401,8 +15401,8 @@
         </p:nvSpPr>
         <p:spPr>
           <a:xfrm>
-            <a:off x="6172200" y="4434840"/>
-            <a:ext cx="5394960" cy="64008"/>
+            <a:off x="6254496" y="4462272"/>
+            <a:ext cx="5230368" cy="54864"/>
           </a:xfrm>
           <a:prstGeom prst="rect">
             <a:avLst/>
@@ -15705,8 +15705,8 @@
         </p:nvSpPr>
         <p:spPr>
           <a:xfrm>
-            <a:off x="548640" y="1417320"/>
-            <a:ext cx="2084831" cy="64008"/>
+            <a:off x="630936" y="1444752"/>
+            <a:ext cx="1920239" cy="54864"/>
           </a:xfrm>
           <a:prstGeom prst="rect">
             <a:avLst/>
@@ -15951,8 +15951,8 @@
         </p:nvSpPr>
         <p:spPr>
           <a:xfrm>
-            <a:off x="2779776" y="1417320"/>
-            <a:ext cx="2084831" cy="64008"/>
+            <a:off x="2862072" y="1444752"/>
+            <a:ext cx="1920239" cy="54864"/>
           </a:xfrm>
           <a:prstGeom prst="rect">
             <a:avLst/>
@@ -16197,8 +16197,8 @@
         </p:nvSpPr>
         <p:spPr>
           <a:xfrm>
-            <a:off x="5010912" y="1417320"/>
-            <a:ext cx="2084831" cy="64008"/>
+            <a:off x="5093207" y="1444752"/>
+            <a:ext cx="1920239" cy="54864"/>
           </a:xfrm>
           <a:prstGeom prst="rect">
             <a:avLst/>
@@ -16443,8 +16443,8 @@
         </p:nvSpPr>
         <p:spPr>
           <a:xfrm>
-            <a:off x="7242048" y="1417320"/>
-            <a:ext cx="2084831" cy="64008"/>
+            <a:off x="7324344" y="1444752"/>
+            <a:ext cx="1920239" cy="54864"/>
           </a:xfrm>
           <a:prstGeom prst="rect">
             <a:avLst/>
@@ -16689,8 +16689,8 @@
         </p:nvSpPr>
         <p:spPr>
           <a:xfrm>
-            <a:off x="9473184" y="1417320"/>
-            <a:ext cx="2084831" cy="64008"/>
+            <a:off x="9555480" y="1444752"/>
+            <a:ext cx="1920239" cy="54864"/>
           </a:xfrm>
           <a:prstGeom prst="rect">
             <a:avLst/>
@@ -19003,8 +19003,8 @@
         </p:nvSpPr>
         <p:spPr>
           <a:xfrm>
-            <a:off x="548640" y="1371600"/>
-            <a:ext cx="3566160" cy="64008"/>
+            <a:off x="630936" y="1399032"/>
+            <a:ext cx="3401568" cy="54864"/>
           </a:xfrm>
           <a:prstGeom prst="rect">
             <a:avLst/>
@@ -19210,8 +19210,8 @@
         </p:nvSpPr>
         <p:spPr>
           <a:xfrm>
-            <a:off x="4279392" y="1371600"/>
-            <a:ext cx="3566160" cy="64008"/>
+            <a:off x="4361688" y="1399032"/>
+            <a:ext cx="3401568" cy="54864"/>
           </a:xfrm>
           <a:prstGeom prst="rect">
             <a:avLst/>
@@ -19417,8 +19417,8 @@
         </p:nvSpPr>
         <p:spPr>
           <a:xfrm>
-            <a:off x="8001000" y="1371600"/>
-            <a:ext cx="3566160" cy="64008"/>
+            <a:off x="8083296" y="1399032"/>
+            <a:ext cx="3401568" cy="54864"/>
           </a:xfrm>
           <a:prstGeom prst="rect">
             <a:avLst/>
@@ -19936,8 +19936,8 @@
         </p:nvSpPr>
         <p:spPr>
           <a:xfrm>
-            <a:off x="6583680" y="1600200"/>
-            <a:ext cx="4983480" cy="64008"/>
+            <a:off x="6665976" y="1627632"/>
+            <a:ext cx="4818888" cy="54864"/>
           </a:xfrm>
           <a:prstGeom prst="rect">
             <a:avLst/>
@@ -20143,8 +20143,8 @@
         </p:nvSpPr>
         <p:spPr>
           <a:xfrm>
-            <a:off x="6583680" y="2788920"/>
-            <a:ext cx="4983480" cy="64008"/>
+            <a:off x="6665976" y="2816351"/>
+            <a:ext cx="4818888" cy="54864"/>
           </a:xfrm>
           <a:prstGeom prst="rect">
             <a:avLst/>
@@ -20350,8 +20350,8 @@
         </p:nvSpPr>
         <p:spPr>
           <a:xfrm>
-            <a:off x="6583680" y="3977639"/>
-            <a:ext cx="4983480" cy="64008"/>
+            <a:off x="6665976" y="4005072"/>
+            <a:ext cx="4818888" cy="54864"/>
           </a:xfrm>
           <a:prstGeom prst="rect">
             <a:avLst/>
@@ -20750,8 +20750,8 @@
         </p:nvSpPr>
         <p:spPr>
           <a:xfrm>
-            <a:off x="7406640" y="1600200"/>
-            <a:ext cx="4160520" cy="64008"/>
+            <a:off x="7488936" y="1627632"/>
+            <a:ext cx="3995928" cy="54864"/>
           </a:xfrm>
           <a:prstGeom prst="rect">
             <a:avLst/>
@@ -20918,8 +20918,8 @@
         </p:nvSpPr>
         <p:spPr>
           <a:xfrm>
-            <a:off x="7406640" y="2834640"/>
-            <a:ext cx="4160520" cy="64008"/>
+            <a:off x="7488936" y="2862072"/>
+            <a:ext cx="3995928" cy="54864"/>
           </a:xfrm>
           <a:prstGeom prst="rect">
             <a:avLst/>
@@ -21086,8 +21086,8 @@
         </p:nvSpPr>
         <p:spPr>
           <a:xfrm>
-            <a:off x="7406640" y="4069080"/>
-            <a:ext cx="4160520" cy="64008"/>
+            <a:off x="7488936" y="4096512"/>
+            <a:ext cx="3995928" cy="54864"/>
           </a:xfrm>
           <a:prstGeom prst="rect">
             <a:avLst/>
@@ -21447,8 +21447,8 @@
         </p:nvSpPr>
         <p:spPr>
           <a:xfrm>
-            <a:off x="7406640" y="1463040"/>
-            <a:ext cx="4160520" cy="64008"/>
+            <a:off x="7488936" y="1490472"/>
+            <a:ext cx="3995928" cy="54864"/>
           </a:xfrm>
           <a:prstGeom prst="rect">
             <a:avLst/>
@@ -21631,8 +21631,8 @@
         </p:nvSpPr>
         <p:spPr>
           <a:xfrm>
-            <a:off x="7406640" y="3200400"/>
-            <a:ext cx="4160520" cy="64008"/>
+            <a:off x="7488936" y="3227832"/>
+            <a:ext cx="3995928" cy="54864"/>
           </a:xfrm>
           <a:prstGeom prst="rect">
             <a:avLst/>

</xml_diff>

<commit_message>
feat(bkm): bölüm bazlı norm açığı da engelli-dışı kurala getirildi
Kullanıcı: "bölüm dağılımını da çek aynı kurala getir".

Engelli bölüm dağılımı canlı ölçüldü (dört norm mağazası, 31.08 as-of): KIRTASİYE 2 · MAL KABUL 1.
Bölüm tablosunda artık operasyonel kadrolu = kadrolu − engelli; ayrı "Engelli (norm dışı)" kolonu
şeffaflık için duruyor. ETKİNLİK normda tanımlı olmadığı için tablodan çıkarılıp en alta
"norm dışı" satırı olarak (krem zemin) alındı, toplamlara girmiyor.

Etki: bölüm bazlı açık 15 → 17 (Kırtasiye ve Mal Kabul artık açıkta; Kırtasiye önce +1 fazla
görünüyordu). Fazla yalnız Yardımcı Kitap +3. Mağaza bazlı açık da operasyonel hale getirildi
(14) — "neden bölüm toplamından büyük" kutusu 17 vs 14 ile güncellendi.

Artık üç katman aynı kuralı kullanıyor: yönetici özeti (−28), mağaza detayı (kadrolu −14 ·
sezonluk −14), bölüm detayı (açık 17 · fazla 3).

Denetçi: ✓ ihlal yok.

Co-Authored-By: Claude Opus 5 <noreply@anthropic.com>
</commit_message>
<xml_diff>
--- a/briefings/sezon-kadro-20260902/sunum-kadro-sezon2026.pptx
+++ b/briefings/sezon-kadro-20260902/sunum-kadro-sezon2026.pptx
@@ -372,7 +372,7 @@
                   <c:v>574.7176999999999</c:v>
                 </c:pt>
                 <c:pt idx="1">
-                  <c:v>71.83742911999343</c:v>
+                  <c:v>71.83742912000012</c:v>
                 </c:pt>
                 <c:pt idx="2">
                   <c:v>143</c:v>
@@ -427,7 +427,7 @@
                   <c:v>775.19155</c:v>
                 </c:pt>
                 <c:pt idx="1">
-                  <c:v>122.60138084999475</c:v>
+                  <c:v>122.60138085000007</c:v>
                 </c:pt>
                 <c:pt idx="2">
                   <c:v>160</c:v>
@@ -1389,13 +1389,13 @@
                 <c:formatCode>General</c:formatCode>
                 <c:ptCount val="3"/>
                 <c:pt idx="0">
-                  <c:v>57.5586237581637</c:v>
+                  <c:v>57.55862375814158</c:v>
                 </c:pt>
                 <c:pt idx="1">
-                  <c:v>96.12850541161808</c:v>
+                  <c:v>96.12850541161207</c:v>
                 </c:pt>
                 <c:pt idx="2">
-                  <c:v>62.26752661004522</c:v>
+                  <c:v>62.26752661005723</c:v>
                 </c:pt>
               </c:numCache>
             </c:numRef>
@@ -10619,7 +10619,7 @@
         </p:nvGraphicFramePr>
         <p:xfrm>
           <a:off x="548640" y="1371600"/>
-          <a:ext cx="6949440" cy="3977639"/>
+          <a:ext cx="6858000" cy="3054096"/>
         </p:xfrm>
         <a:graphic>
           <a:graphicData uri="http://schemas.openxmlformats.org/drawingml/2006/table">
@@ -10628,14 +10628,15 @@
                 <a:tableStyleId>{5C22544A-7EE6-4342-B048-85BDC9FD1C3A}</a:tableStyleId>
               </a:tblPr>
               <a:tblGrid>
-                <a:gridCol w="1965960"/>
-                <a:gridCol w="868680"/>
-                <a:gridCol w="1234440"/>
-                <a:gridCol w="822960"/>
-                <a:gridCol w="822960"/>
-                <a:gridCol w="1234440"/>
+                <a:gridCol w="1691640"/>
+                <a:gridCol w="731520"/>
+                <a:gridCol w="1143000"/>
+                <a:gridCol w="960120"/>
+                <a:gridCol w="685800"/>
+                <a:gridCol w="685800"/>
+                <a:gridCol w="960120"/>
               </a:tblGrid>
-              <a:tr h="248602">
+              <a:tr h="310896">
                 <a:tc>
                   <a:txBody>
                     <a:bodyPr/>
@@ -10643,7 +10644,7 @@
                     <a:p>
                       <a:pPr algn="l"/>
                       <a:r>
-                        <a:rPr sz="850" b="1">
+                        <a:rPr sz="750" b="1">
                           <a:solidFill>
                             <a:srgbClr val="FFFFFF"/>
                           </a:solidFill>
@@ -10666,7 +10667,7 @@
                     <a:p>
                       <a:pPr algn="ctr"/>
                       <a:r>
-                        <a:rPr sz="850" b="1">
+                        <a:rPr sz="750" b="1">
                           <a:solidFill>
                             <a:srgbClr val="FFFFFF"/>
                           </a:solidFill>
@@ -10689,13 +10690,25 @@
                     <a:p>
                       <a:pPr algn="ctr"/>
                       <a:r>
-                        <a:rPr sz="850" b="1">
+                        <a:rPr sz="750" b="1">
                           <a:solidFill>
                             <a:srgbClr val="FFFFFF"/>
                           </a:solidFill>
                           <a:latin typeface="Calibri"/>
                         </a:rPr>
-                        <a:t>Kadrolu 31.08</a:t>
+                        <a:t>Operasyonel</a:t>
+                      </a:r>
+                    </a:p>
+                    <a:p>
+                      <a:pPr algn="ctr"/>
+                      <a:r>
+                        <a:rPr sz="750" b="1">
+                          <a:solidFill>
+                            <a:srgbClr val="FFFFFF"/>
+                          </a:solidFill>
+                          <a:latin typeface="Calibri"/>
+                        </a:rPr>
+                        <a:t>kadrolu</a:t>
                       </a:r>
                     </a:p>
                   </a:txBody>
@@ -10712,12 +10725,47 @@
                     <a:p>
                       <a:pPr algn="ctr"/>
                       <a:r>
-                        <a:rPr sz="850" b="1">
+                        <a:rPr sz="750" b="1">
                           <a:solidFill>
                             <a:srgbClr val="FFFFFF"/>
                           </a:solidFill>
                           <a:latin typeface="Calibri"/>
                         </a:rPr>
+                        <a:t>Engelli</a:t>
+                      </a:r>
+                    </a:p>
+                    <a:p>
+                      <a:pPr algn="ctr"/>
+                      <a:r>
+                        <a:rPr sz="750" b="1">
+                          <a:solidFill>
+                            <a:srgbClr val="FFFFFF"/>
+                          </a:solidFill>
+                          <a:latin typeface="Calibri"/>
+                        </a:rPr>
+                        <a:t>(norm dışı)</a:t>
+                      </a:r>
+                    </a:p>
+                  </a:txBody>
+                  <a:tcPr>
+                    <a:solidFill>
+                      <a:srgbClr val="E30622"/>
+                    </a:solidFill>
+                  </a:tcPr>
+                </a:tc>
+                <a:tc>
+                  <a:txBody>
+                    <a:bodyPr/>
+                    <a:lstStyle/>
+                    <a:p>
+                      <a:pPr algn="ctr"/>
+                      <a:r>
+                        <a:rPr sz="750" b="1">
+                          <a:solidFill>
+                            <a:srgbClr val="FFFFFF"/>
+                          </a:solidFill>
+                          <a:latin typeface="Calibri"/>
+                        </a:rPr>
                         <a:t>Açık</a:t>
                       </a:r>
                     </a:p>
@@ -10735,7 +10783,7 @@
                     <a:p>
                       <a:pPr algn="ctr"/>
                       <a:r>
-                        <a:rPr sz="850" b="1">
+                        <a:rPr sz="750" b="1">
                           <a:solidFill>
                             <a:srgbClr val="FFFFFF"/>
                           </a:solidFill>
@@ -10758,13 +10806,25 @@
                     <a:p>
                       <a:pPr algn="ctr"/>
                       <a:r>
-                        <a:rPr sz="850" b="1">
+                        <a:rPr sz="750" b="1">
                           <a:solidFill>
                             <a:srgbClr val="FFFFFF"/>
                           </a:solidFill>
                           <a:latin typeface="Calibri"/>
                         </a:rPr>
-                        <a:t>Sezonluk 31.08</a:t>
+                        <a:t>Sezonluk</a:t>
+                      </a:r>
+                    </a:p>
+                    <a:p>
+                      <a:pPr algn="ctr"/>
+                      <a:r>
+                        <a:rPr sz="750" b="1">
+                          <a:solidFill>
+                            <a:srgbClr val="FFFFFF"/>
+                          </a:solidFill>
+                          <a:latin typeface="Calibri"/>
+                        </a:rPr>
+                        <a:t>31.08</a:t>
                       </a:r>
                     </a:p>
                   </a:txBody>
@@ -10775,7 +10835,7 @@
                   </a:tcPr>
                 </a:tc>
               </a:tr>
-              <a:tr h="248602">
+              <a:tr h="182880">
                 <a:tc>
                   <a:txBody>
                     <a:bodyPr/>
@@ -10783,7 +10843,7 @@
                     <a:p>
                       <a:pPr algn="l"/>
                       <a:r>
-                        <a:rPr sz="950" b="0">
+                        <a:rPr sz="900" b="0">
                           <a:solidFill>
                             <a:srgbClr val="333333"/>
                           </a:solidFill>
@@ -10806,7 +10866,7 @@
                     <a:p>
                       <a:pPr algn="ctr"/>
                       <a:r>
-                        <a:rPr sz="950" b="0">
+                        <a:rPr sz="900" b="0">
                           <a:solidFill>
                             <a:srgbClr val="333333"/>
                           </a:solidFill>
@@ -10829,7 +10889,7 @@
                     <a:p>
                       <a:pPr algn="ctr"/>
                       <a:r>
-                        <a:rPr sz="950" b="0">
+                        <a:rPr sz="900" b="0">
                           <a:solidFill>
                             <a:srgbClr val="333333"/>
                           </a:solidFill>
@@ -10852,7 +10912,30 @@
                     <a:p>
                       <a:pPr algn="ctr"/>
                       <a:r>
-                        <a:rPr sz="950" b="1">
+                        <a:rPr sz="900" b="0">
+                          <a:solidFill>
+                            <a:srgbClr val="333333"/>
+                          </a:solidFill>
+                          <a:latin typeface="Calibri"/>
+                        </a:rPr>
+                        <a:t>—</a:t>
+                      </a:r>
+                    </a:p>
+                  </a:txBody>
+                  <a:tcPr>
+                    <a:solidFill>
+                      <a:srgbClr val="FFFFFF"/>
+                    </a:solidFill>
+                  </a:tcPr>
+                </a:tc>
+                <a:tc>
+                  <a:txBody>
+                    <a:bodyPr/>
+                    <a:lstStyle/>
+                    <a:p>
+                      <a:pPr algn="ctr"/>
+                      <a:r>
+                        <a:rPr sz="900" b="1">
                           <a:solidFill>
                             <a:srgbClr val="A6001A"/>
                           </a:solidFill>
@@ -10875,7 +10958,7 @@
                     <a:p>
                       <a:pPr algn="ctr"/>
                       <a:r>
-                        <a:rPr sz="950" b="0">
+                        <a:rPr sz="900" b="0">
                           <a:solidFill>
                             <a:srgbClr val="333333"/>
                           </a:solidFill>
@@ -10898,7 +10981,7 @@
                     <a:p>
                       <a:pPr algn="ctr"/>
                       <a:r>
-                        <a:rPr sz="950" b="0">
+                        <a:rPr sz="900" b="0">
                           <a:solidFill>
                             <a:srgbClr val="333333"/>
                           </a:solidFill>
@@ -10915,7 +10998,7 @@
                   </a:tcPr>
                 </a:tc>
               </a:tr>
-              <a:tr h="248602">
+              <a:tr h="182880">
                 <a:tc>
                   <a:txBody>
                     <a:bodyPr/>
@@ -10923,12 +11006,338 @@
                     <a:p>
                       <a:pPr algn="l"/>
                       <a:r>
-                        <a:rPr sz="950" b="0">
+                        <a:rPr sz="900" b="0">
                           <a:solidFill>
                             <a:srgbClr val="333333"/>
                           </a:solidFill>
                           <a:latin typeface="Calibri"/>
                         </a:rPr>
+                        <a:t>Mağaza</a:t>
+                      </a:r>
+                    </a:p>
+                  </a:txBody>
+                  <a:tcPr>
+                    <a:solidFill>
+                      <a:srgbClr val="FAFAFA"/>
+                    </a:solidFill>
+                  </a:tcPr>
+                </a:tc>
+                <a:tc>
+                  <a:txBody>
+                    <a:bodyPr/>
+                    <a:lstStyle/>
+                    <a:p>
+                      <a:pPr algn="ctr"/>
+                      <a:r>
+                        <a:rPr sz="900" b="0">
+                          <a:solidFill>
+                            <a:srgbClr val="333333"/>
+                          </a:solidFill>
+                          <a:latin typeface="Calibri"/>
+                        </a:rPr>
+                        <a:t>10</a:t>
+                      </a:r>
+                    </a:p>
+                  </a:txBody>
+                  <a:tcPr>
+                    <a:solidFill>
+                      <a:srgbClr val="FAFAFA"/>
+                    </a:solidFill>
+                  </a:tcPr>
+                </a:tc>
+                <a:tc>
+                  <a:txBody>
+                    <a:bodyPr/>
+                    <a:lstStyle/>
+                    <a:p>
+                      <a:pPr algn="ctr"/>
+                      <a:r>
+                        <a:rPr sz="900" b="0">
+                          <a:solidFill>
+                            <a:srgbClr val="333333"/>
+                          </a:solidFill>
+                          <a:latin typeface="Calibri"/>
+                        </a:rPr>
+                        <a:t>8</a:t>
+                      </a:r>
+                    </a:p>
+                  </a:txBody>
+                  <a:tcPr>
+                    <a:solidFill>
+                      <a:srgbClr val="FAFAFA"/>
+                    </a:solidFill>
+                  </a:tcPr>
+                </a:tc>
+                <a:tc>
+                  <a:txBody>
+                    <a:bodyPr/>
+                    <a:lstStyle/>
+                    <a:p>
+                      <a:pPr algn="ctr"/>
+                      <a:r>
+                        <a:rPr sz="900" b="0">
+                          <a:solidFill>
+                            <a:srgbClr val="333333"/>
+                          </a:solidFill>
+                          <a:latin typeface="Calibri"/>
+                        </a:rPr>
+                        <a:t>—</a:t>
+                      </a:r>
+                    </a:p>
+                  </a:txBody>
+                  <a:tcPr>
+                    <a:solidFill>
+                      <a:srgbClr val="FAFAFA"/>
+                    </a:solidFill>
+                  </a:tcPr>
+                </a:tc>
+                <a:tc>
+                  <a:txBody>
+                    <a:bodyPr/>
+                    <a:lstStyle/>
+                    <a:p>
+                      <a:pPr algn="ctr"/>
+                      <a:r>
+                        <a:rPr sz="900" b="1">
+                          <a:solidFill>
+                            <a:srgbClr val="A6001A"/>
+                          </a:solidFill>
+                          <a:latin typeface="Calibri"/>
+                        </a:rPr>
+                        <a:t>2</a:t>
+                      </a:r>
+                    </a:p>
+                  </a:txBody>
+                  <a:tcPr>
+                    <a:solidFill>
+                      <a:srgbClr val="FAFAFA"/>
+                    </a:solidFill>
+                  </a:tcPr>
+                </a:tc>
+                <a:tc>
+                  <a:txBody>
+                    <a:bodyPr/>
+                    <a:lstStyle/>
+                    <a:p>
+                      <a:pPr algn="ctr"/>
+                      <a:r>
+                        <a:rPr sz="900" b="0">
+                          <a:solidFill>
+                            <a:srgbClr val="333333"/>
+                          </a:solidFill>
+                          <a:latin typeface="Calibri"/>
+                        </a:rPr>
+                        <a:t>—</a:t>
+                      </a:r>
+                    </a:p>
+                  </a:txBody>
+                  <a:tcPr>
+                    <a:solidFill>
+                      <a:srgbClr val="FAFAFA"/>
+                    </a:solidFill>
+                  </a:tcPr>
+                </a:tc>
+                <a:tc>
+                  <a:txBody>
+                    <a:bodyPr/>
+                    <a:lstStyle/>
+                    <a:p>
+                      <a:pPr algn="ctr"/>
+                      <a:r>
+                        <a:rPr sz="900" b="0">
+                          <a:solidFill>
+                            <a:srgbClr val="333333"/>
+                          </a:solidFill>
+                          <a:latin typeface="Calibri"/>
+                        </a:rPr>
+                        <a:t>—</a:t>
+                      </a:r>
+                    </a:p>
+                  </a:txBody>
+                  <a:tcPr>
+                    <a:solidFill>
+                      <a:srgbClr val="FAFAFA"/>
+                    </a:solidFill>
+                  </a:tcPr>
+                </a:tc>
+              </a:tr>
+              <a:tr h="182880">
+                <a:tc>
+                  <a:txBody>
+                    <a:bodyPr/>
+                    <a:lstStyle/>
+                    <a:p>
+                      <a:pPr algn="l"/>
+                      <a:r>
+                        <a:rPr sz="900" b="0">
+                          <a:solidFill>
+                            <a:srgbClr val="333333"/>
+                          </a:solidFill>
+                          <a:latin typeface="Calibri"/>
+                        </a:rPr>
+                        <a:t>İdari İşler</a:t>
+                      </a:r>
+                    </a:p>
+                  </a:txBody>
+                  <a:tcPr>
+                    <a:solidFill>
+                      <a:srgbClr val="FFFFFF"/>
+                    </a:solidFill>
+                  </a:tcPr>
+                </a:tc>
+                <a:tc>
+                  <a:txBody>
+                    <a:bodyPr/>
+                    <a:lstStyle/>
+                    <a:p>
+                      <a:pPr algn="ctr"/>
+                      <a:r>
+                        <a:rPr sz="900" b="0">
+                          <a:solidFill>
+                            <a:srgbClr val="333333"/>
+                          </a:solidFill>
+                          <a:latin typeface="Calibri"/>
+                        </a:rPr>
+                        <a:t>8</a:t>
+                      </a:r>
+                    </a:p>
+                  </a:txBody>
+                  <a:tcPr>
+                    <a:solidFill>
+                      <a:srgbClr val="FFFFFF"/>
+                    </a:solidFill>
+                  </a:tcPr>
+                </a:tc>
+                <a:tc>
+                  <a:txBody>
+                    <a:bodyPr/>
+                    <a:lstStyle/>
+                    <a:p>
+                      <a:pPr algn="ctr"/>
+                      <a:r>
+                        <a:rPr sz="900" b="0">
+                          <a:solidFill>
+                            <a:srgbClr val="333333"/>
+                          </a:solidFill>
+                          <a:latin typeface="Calibri"/>
+                        </a:rPr>
+                        <a:t>6</a:t>
+                      </a:r>
+                    </a:p>
+                  </a:txBody>
+                  <a:tcPr>
+                    <a:solidFill>
+                      <a:srgbClr val="FFFFFF"/>
+                    </a:solidFill>
+                  </a:tcPr>
+                </a:tc>
+                <a:tc>
+                  <a:txBody>
+                    <a:bodyPr/>
+                    <a:lstStyle/>
+                    <a:p>
+                      <a:pPr algn="ctr"/>
+                      <a:r>
+                        <a:rPr sz="900" b="0">
+                          <a:solidFill>
+                            <a:srgbClr val="333333"/>
+                          </a:solidFill>
+                          <a:latin typeface="Calibri"/>
+                        </a:rPr>
+                        <a:t>—</a:t>
+                      </a:r>
+                    </a:p>
+                  </a:txBody>
+                  <a:tcPr>
+                    <a:solidFill>
+                      <a:srgbClr val="FFFFFF"/>
+                    </a:solidFill>
+                  </a:tcPr>
+                </a:tc>
+                <a:tc>
+                  <a:txBody>
+                    <a:bodyPr/>
+                    <a:lstStyle/>
+                    <a:p>
+                      <a:pPr algn="ctr"/>
+                      <a:r>
+                        <a:rPr sz="900" b="1">
+                          <a:solidFill>
+                            <a:srgbClr val="A6001A"/>
+                          </a:solidFill>
+                          <a:latin typeface="Calibri"/>
+                        </a:rPr>
+                        <a:t>2</a:t>
+                      </a:r>
+                    </a:p>
+                  </a:txBody>
+                  <a:tcPr>
+                    <a:solidFill>
+                      <a:srgbClr val="FFFFFF"/>
+                    </a:solidFill>
+                  </a:tcPr>
+                </a:tc>
+                <a:tc>
+                  <a:txBody>
+                    <a:bodyPr/>
+                    <a:lstStyle/>
+                    <a:p>
+                      <a:pPr algn="ctr"/>
+                      <a:r>
+                        <a:rPr sz="900" b="0">
+                          <a:solidFill>
+                            <a:srgbClr val="333333"/>
+                          </a:solidFill>
+                          <a:latin typeface="Calibri"/>
+                        </a:rPr>
+                        <a:t>—</a:t>
+                      </a:r>
+                    </a:p>
+                  </a:txBody>
+                  <a:tcPr>
+                    <a:solidFill>
+                      <a:srgbClr val="FFFFFF"/>
+                    </a:solidFill>
+                  </a:tcPr>
+                </a:tc>
+                <a:tc>
+                  <a:txBody>
+                    <a:bodyPr/>
+                    <a:lstStyle/>
+                    <a:p>
+                      <a:pPr algn="ctr"/>
+                      <a:r>
+                        <a:rPr sz="900" b="0">
+                          <a:solidFill>
+                            <a:srgbClr val="333333"/>
+                          </a:solidFill>
+                          <a:latin typeface="Calibri"/>
+                        </a:rPr>
+                        <a:t>—</a:t>
+                      </a:r>
+                    </a:p>
+                  </a:txBody>
+                  <a:tcPr>
+                    <a:solidFill>
+                      <a:srgbClr val="FFFFFF"/>
+                    </a:solidFill>
+                  </a:tcPr>
+                </a:tc>
+              </a:tr>
+              <a:tr h="182880">
+                <a:tc>
+                  <a:txBody>
+                    <a:bodyPr/>
+                    <a:lstStyle/>
+                    <a:p>
+                      <a:pPr algn="l"/>
+                      <a:r>
+                        <a:rPr sz="900" b="0">
+                          <a:solidFill>
+                            <a:srgbClr val="333333"/>
+                          </a:solidFill>
+                          <a:latin typeface="Calibri"/>
+                        </a:rPr>
                         <a:t>Kültür</a:t>
                       </a:r>
                     </a:p>
@@ -10946,7 +11355,7 @@
                     <a:p>
                       <a:pPr algn="ctr"/>
                       <a:r>
-                        <a:rPr sz="950" b="0">
+                        <a:rPr sz="900" b="0">
                           <a:solidFill>
                             <a:srgbClr val="333333"/>
                           </a:solidFill>
@@ -10969,7 +11378,7 @@
                     <a:p>
                       <a:pPr algn="ctr"/>
                       <a:r>
-                        <a:rPr sz="950" b="0">
+                        <a:rPr sz="900" b="0">
                           <a:solidFill>
                             <a:srgbClr val="333333"/>
                           </a:solidFill>
@@ -10992,7 +11401,30 @@
                     <a:p>
                       <a:pPr algn="ctr"/>
                       <a:r>
-                        <a:rPr sz="950" b="1">
+                        <a:rPr sz="900" b="0">
+                          <a:solidFill>
+                            <a:srgbClr val="333333"/>
+                          </a:solidFill>
+                          <a:latin typeface="Calibri"/>
+                        </a:rPr>
+                        <a:t>—</a:t>
+                      </a:r>
+                    </a:p>
+                  </a:txBody>
+                  <a:tcPr>
+                    <a:solidFill>
+                      <a:srgbClr val="FAFAFA"/>
+                    </a:solidFill>
+                  </a:tcPr>
+                </a:tc>
+                <a:tc>
+                  <a:txBody>
+                    <a:bodyPr/>
+                    <a:lstStyle/>
+                    <a:p>
+                      <a:pPr algn="ctr"/>
+                      <a:r>
+                        <a:rPr sz="900" b="1">
                           <a:solidFill>
                             <a:srgbClr val="A6001A"/>
                           </a:solidFill>
@@ -11015,7 +11447,7 @@
                     <a:p>
                       <a:pPr algn="ctr"/>
                       <a:r>
-                        <a:rPr sz="950" b="0">
+                        <a:rPr sz="900" b="0">
                           <a:solidFill>
                             <a:srgbClr val="333333"/>
                           </a:solidFill>
@@ -11038,7 +11470,7 @@
                     <a:p>
                       <a:pPr algn="ctr"/>
                       <a:r>
-                        <a:rPr sz="950" b="0">
+                        <a:rPr sz="900" b="0">
                           <a:solidFill>
                             <a:srgbClr val="333333"/>
                           </a:solidFill>
@@ -11055,7 +11487,7 @@
                   </a:tcPr>
                 </a:tc>
               </a:tr>
-              <a:tr h="248602">
+              <a:tr h="182880">
                 <a:tc>
                   <a:txBody>
                     <a:bodyPr/>
@@ -11063,13 +11495,13 @@
                     <a:p>
                       <a:pPr algn="l"/>
                       <a:r>
-                        <a:rPr sz="950" b="0">
+                        <a:rPr sz="900" b="0">
                           <a:solidFill>
                             <a:srgbClr val="333333"/>
                           </a:solidFill>
                           <a:latin typeface="Calibri"/>
                         </a:rPr>
-                        <a:t>Mağaza</a:t>
+                        <a:t>Kasa</a:t>
                       </a:r>
                     </a:p>
                   </a:txBody>
@@ -11086,12 +11518,338 @@
                     <a:p>
                       <a:pPr algn="ctr"/>
                       <a:r>
-                        <a:rPr sz="950" b="0">
+                        <a:rPr sz="900" b="0">
                           <a:solidFill>
                             <a:srgbClr val="333333"/>
                           </a:solidFill>
                           <a:latin typeface="Calibri"/>
                         </a:rPr>
+                        <a:t>16</a:t>
+                      </a:r>
+                    </a:p>
+                  </a:txBody>
+                  <a:tcPr>
+                    <a:solidFill>
+                      <a:srgbClr val="FFFFFF"/>
+                    </a:solidFill>
+                  </a:tcPr>
+                </a:tc>
+                <a:tc>
+                  <a:txBody>
+                    <a:bodyPr/>
+                    <a:lstStyle/>
+                    <a:p>
+                      <a:pPr algn="ctr"/>
+                      <a:r>
+                        <a:rPr sz="900" b="0">
+                          <a:solidFill>
+                            <a:srgbClr val="333333"/>
+                          </a:solidFill>
+                          <a:latin typeface="Calibri"/>
+                        </a:rPr>
+                        <a:t>15</a:t>
+                      </a:r>
+                    </a:p>
+                  </a:txBody>
+                  <a:tcPr>
+                    <a:solidFill>
+                      <a:srgbClr val="FFFFFF"/>
+                    </a:solidFill>
+                  </a:tcPr>
+                </a:tc>
+                <a:tc>
+                  <a:txBody>
+                    <a:bodyPr/>
+                    <a:lstStyle/>
+                    <a:p>
+                      <a:pPr algn="ctr"/>
+                      <a:r>
+                        <a:rPr sz="900" b="0">
+                          <a:solidFill>
+                            <a:srgbClr val="333333"/>
+                          </a:solidFill>
+                          <a:latin typeface="Calibri"/>
+                        </a:rPr>
+                        <a:t>—</a:t>
+                      </a:r>
+                    </a:p>
+                  </a:txBody>
+                  <a:tcPr>
+                    <a:solidFill>
+                      <a:srgbClr val="FFFFFF"/>
+                    </a:solidFill>
+                  </a:tcPr>
+                </a:tc>
+                <a:tc>
+                  <a:txBody>
+                    <a:bodyPr/>
+                    <a:lstStyle/>
+                    <a:p>
+                      <a:pPr algn="ctr"/>
+                      <a:r>
+                        <a:rPr sz="900" b="1">
+                          <a:solidFill>
+                            <a:srgbClr val="A6001A"/>
+                          </a:solidFill>
+                          <a:latin typeface="Calibri"/>
+                        </a:rPr>
+                        <a:t>1</a:t>
+                      </a:r>
+                    </a:p>
+                  </a:txBody>
+                  <a:tcPr>
+                    <a:solidFill>
+                      <a:srgbClr val="FFFFFF"/>
+                    </a:solidFill>
+                  </a:tcPr>
+                </a:tc>
+                <a:tc>
+                  <a:txBody>
+                    <a:bodyPr/>
+                    <a:lstStyle/>
+                    <a:p>
+                      <a:pPr algn="ctr"/>
+                      <a:r>
+                        <a:rPr sz="900" b="0">
+                          <a:solidFill>
+                            <a:srgbClr val="333333"/>
+                          </a:solidFill>
+                          <a:latin typeface="Calibri"/>
+                        </a:rPr>
+                        <a:t>—</a:t>
+                      </a:r>
+                    </a:p>
+                  </a:txBody>
+                  <a:tcPr>
+                    <a:solidFill>
+                      <a:srgbClr val="FFFFFF"/>
+                    </a:solidFill>
+                  </a:tcPr>
+                </a:tc>
+                <a:tc>
+                  <a:txBody>
+                    <a:bodyPr/>
+                    <a:lstStyle/>
+                    <a:p>
+                      <a:pPr algn="ctr"/>
+                      <a:r>
+                        <a:rPr sz="900" b="0">
+                          <a:solidFill>
+                            <a:srgbClr val="333333"/>
+                          </a:solidFill>
+                          <a:latin typeface="Calibri"/>
+                        </a:rPr>
+                        <a:t>9</a:t>
+                      </a:r>
+                    </a:p>
+                  </a:txBody>
+                  <a:tcPr>
+                    <a:solidFill>
+                      <a:srgbClr val="FFFFFF"/>
+                    </a:solidFill>
+                  </a:tcPr>
+                </a:tc>
+              </a:tr>
+              <a:tr h="182880">
+                <a:tc>
+                  <a:txBody>
+                    <a:bodyPr/>
+                    <a:lstStyle/>
+                    <a:p>
+                      <a:pPr algn="l"/>
+                      <a:r>
+                        <a:rPr sz="900" b="0">
+                          <a:solidFill>
+                            <a:srgbClr val="333333"/>
+                          </a:solidFill>
+                          <a:latin typeface="Calibri"/>
+                        </a:rPr>
+                        <a:t>Muhasebe</a:t>
+                      </a:r>
+                    </a:p>
+                  </a:txBody>
+                  <a:tcPr>
+                    <a:solidFill>
+                      <a:srgbClr val="FAFAFA"/>
+                    </a:solidFill>
+                  </a:tcPr>
+                </a:tc>
+                <a:tc>
+                  <a:txBody>
+                    <a:bodyPr/>
+                    <a:lstStyle/>
+                    <a:p>
+                      <a:pPr algn="ctr"/>
+                      <a:r>
+                        <a:rPr sz="900" b="0">
+                          <a:solidFill>
+                            <a:srgbClr val="333333"/>
+                          </a:solidFill>
+                          <a:latin typeface="Calibri"/>
+                        </a:rPr>
+                        <a:t>1</a:t>
+                      </a:r>
+                    </a:p>
+                  </a:txBody>
+                  <a:tcPr>
+                    <a:solidFill>
+                      <a:srgbClr val="FAFAFA"/>
+                    </a:solidFill>
+                  </a:tcPr>
+                </a:tc>
+                <a:tc>
+                  <a:txBody>
+                    <a:bodyPr/>
+                    <a:lstStyle/>
+                    <a:p>
+                      <a:pPr algn="ctr"/>
+                      <a:r>
+                        <a:rPr sz="900" b="0">
+                          <a:solidFill>
+                            <a:srgbClr val="333333"/>
+                          </a:solidFill>
+                          <a:latin typeface="Calibri"/>
+                        </a:rPr>
+                        <a:t>0</a:t>
+                      </a:r>
+                    </a:p>
+                  </a:txBody>
+                  <a:tcPr>
+                    <a:solidFill>
+                      <a:srgbClr val="FAFAFA"/>
+                    </a:solidFill>
+                  </a:tcPr>
+                </a:tc>
+                <a:tc>
+                  <a:txBody>
+                    <a:bodyPr/>
+                    <a:lstStyle/>
+                    <a:p>
+                      <a:pPr algn="ctr"/>
+                      <a:r>
+                        <a:rPr sz="900" b="0">
+                          <a:solidFill>
+                            <a:srgbClr val="333333"/>
+                          </a:solidFill>
+                          <a:latin typeface="Calibri"/>
+                        </a:rPr>
+                        <a:t>—</a:t>
+                      </a:r>
+                    </a:p>
+                  </a:txBody>
+                  <a:tcPr>
+                    <a:solidFill>
+                      <a:srgbClr val="FAFAFA"/>
+                    </a:solidFill>
+                  </a:tcPr>
+                </a:tc>
+                <a:tc>
+                  <a:txBody>
+                    <a:bodyPr/>
+                    <a:lstStyle/>
+                    <a:p>
+                      <a:pPr algn="ctr"/>
+                      <a:r>
+                        <a:rPr sz="900" b="1">
+                          <a:solidFill>
+                            <a:srgbClr val="A6001A"/>
+                          </a:solidFill>
+                          <a:latin typeface="Calibri"/>
+                        </a:rPr>
+                        <a:t>1</a:t>
+                      </a:r>
+                    </a:p>
+                  </a:txBody>
+                  <a:tcPr>
+                    <a:solidFill>
+                      <a:srgbClr val="FAFAFA"/>
+                    </a:solidFill>
+                  </a:tcPr>
+                </a:tc>
+                <a:tc>
+                  <a:txBody>
+                    <a:bodyPr/>
+                    <a:lstStyle/>
+                    <a:p>
+                      <a:pPr algn="ctr"/>
+                      <a:r>
+                        <a:rPr sz="900" b="0">
+                          <a:solidFill>
+                            <a:srgbClr val="333333"/>
+                          </a:solidFill>
+                          <a:latin typeface="Calibri"/>
+                        </a:rPr>
+                        <a:t>—</a:t>
+                      </a:r>
+                    </a:p>
+                  </a:txBody>
+                  <a:tcPr>
+                    <a:solidFill>
+                      <a:srgbClr val="FAFAFA"/>
+                    </a:solidFill>
+                  </a:tcPr>
+                </a:tc>
+                <a:tc>
+                  <a:txBody>
+                    <a:bodyPr/>
+                    <a:lstStyle/>
+                    <a:p>
+                      <a:pPr algn="ctr"/>
+                      <a:r>
+                        <a:rPr sz="900" b="0">
+                          <a:solidFill>
+                            <a:srgbClr val="333333"/>
+                          </a:solidFill>
+                          <a:latin typeface="Calibri"/>
+                        </a:rPr>
+                        <a:t>—</a:t>
+                      </a:r>
+                    </a:p>
+                  </a:txBody>
+                  <a:tcPr>
+                    <a:solidFill>
+                      <a:srgbClr val="FAFAFA"/>
+                    </a:solidFill>
+                  </a:tcPr>
+                </a:tc>
+              </a:tr>
+              <a:tr h="182880">
+                <a:tc>
+                  <a:txBody>
+                    <a:bodyPr/>
+                    <a:lstStyle/>
+                    <a:p>
+                      <a:pPr algn="l"/>
+                      <a:r>
+                        <a:rPr sz="900" b="0">
+                          <a:solidFill>
+                            <a:srgbClr val="333333"/>
+                          </a:solidFill>
+                          <a:latin typeface="Calibri"/>
+                        </a:rPr>
+                        <a:t>Akademi</a:t>
+                      </a:r>
+                    </a:p>
+                  </a:txBody>
+                  <a:tcPr>
+                    <a:solidFill>
+                      <a:srgbClr val="FFFFFF"/>
+                    </a:solidFill>
+                  </a:tcPr>
+                </a:tc>
+                <a:tc>
+                  <a:txBody>
+                    <a:bodyPr/>
+                    <a:lstStyle/>
+                    <a:p>
+                      <a:pPr algn="ctr"/>
+                      <a:r>
+                        <a:rPr sz="900" b="0">
+                          <a:solidFill>
+                            <a:srgbClr val="333333"/>
+                          </a:solidFill>
+                          <a:latin typeface="Calibri"/>
+                        </a:rPr>
                         <a:t>10</a:t>
                       </a:r>
                     </a:p>
@@ -11109,13 +11867,13 @@
                     <a:p>
                       <a:pPr algn="ctr"/>
                       <a:r>
-                        <a:rPr sz="950" b="0">
+                        <a:rPr sz="900" b="0">
                           <a:solidFill>
                             <a:srgbClr val="333333"/>
                           </a:solidFill>
                           <a:latin typeface="Calibri"/>
                         </a:rPr>
-                        <a:t>8</a:t>
+                        <a:t>9</a:t>
                       </a:r>
                     </a:p>
                   </a:txBody>
@@ -11132,18 +11890,927 @@
                     <a:p>
                       <a:pPr algn="ctr"/>
                       <a:r>
-                        <a:rPr sz="950" b="1">
+                        <a:rPr sz="900" b="0">
+                          <a:solidFill>
+                            <a:srgbClr val="333333"/>
+                          </a:solidFill>
+                          <a:latin typeface="Calibri"/>
+                        </a:rPr>
+                        <a:t>—</a:t>
+                      </a:r>
+                    </a:p>
+                  </a:txBody>
+                  <a:tcPr>
+                    <a:solidFill>
+                      <a:srgbClr val="FFFFFF"/>
+                    </a:solidFill>
+                  </a:tcPr>
+                </a:tc>
+                <a:tc>
+                  <a:txBody>
+                    <a:bodyPr/>
+                    <a:lstStyle/>
+                    <a:p>
+                      <a:pPr algn="ctr"/>
+                      <a:r>
+                        <a:rPr sz="900" b="1">
                           <a:solidFill>
                             <a:srgbClr val="A6001A"/>
                           </a:solidFill>
                           <a:latin typeface="Calibri"/>
                         </a:rPr>
+                        <a:t>1</a:t>
+                      </a:r>
+                    </a:p>
+                  </a:txBody>
+                  <a:tcPr>
+                    <a:solidFill>
+                      <a:srgbClr val="FFFFFF"/>
+                    </a:solidFill>
+                  </a:tcPr>
+                </a:tc>
+                <a:tc>
+                  <a:txBody>
+                    <a:bodyPr/>
+                    <a:lstStyle/>
+                    <a:p>
+                      <a:pPr algn="ctr"/>
+                      <a:r>
+                        <a:rPr sz="900" b="0">
+                          <a:solidFill>
+                            <a:srgbClr val="333333"/>
+                          </a:solidFill>
+                          <a:latin typeface="Calibri"/>
+                        </a:rPr>
+                        <a:t>—</a:t>
+                      </a:r>
+                    </a:p>
+                  </a:txBody>
+                  <a:tcPr>
+                    <a:solidFill>
+                      <a:srgbClr val="FFFFFF"/>
+                    </a:solidFill>
+                  </a:tcPr>
+                </a:tc>
+                <a:tc>
+                  <a:txBody>
+                    <a:bodyPr/>
+                    <a:lstStyle/>
+                    <a:p>
+                      <a:pPr algn="ctr"/>
+                      <a:r>
+                        <a:rPr sz="900" b="0">
+                          <a:solidFill>
+                            <a:srgbClr val="333333"/>
+                          </a:solidFill>
+                          <a:latin typeface="Calibri"/>
+                        </a:rPr>
+                        <a:t>—</a:t>
+                      </a:r>
+                    </a:p>
+                  </a:txBody>
+                  <a:tcPr>
+                    <a:solidFill>
+                      <a:srgbClr val="FFFFFF"/>
+                    </a:solidFill>
+                  </a:tcPr>
+                </a:tc>
+              </a:tr>
+              <a:tr h="182880">
+                <a:tc>
+                  <a:txBody>
+                    <a:bodyPr/>
+                    <a:lstStyle/>
+                    <a:p>
+                      <a:pPr algn="l"/>
+                      <a:r>
+                        <a:rPr sz="900" b="0">
+                          <a:solidFill>
+                            <a:srgbClr val="333333"/>
+                          </a:solidFill>
+                          <a:latin typeface="Calibri"/>
+                        </a:rPr>
+                        <a:t>Oyun Alanı</a:t>
+                      </a:r>
+                    </a:p>
+                  </a:txBody>
+                  <a:tcPr>
+                    <a:solidFill>
+                      <a:srgbClr val="FAFAFA"/>
+                    </a:solidFill>
+                  </a:tcPr>
+                </a:tc>
+                <a:tc>
+                  <a:txBody>
+                    <a:bodyPr/>
+                    <a:lstStyle/>
+                    <a:p>
+                      <a:pPr algn="ctr"/>
+                      <a:r>
+                        <a:rPr sz="900" b="0">
+                          <a:solidFill>
+                            <a:srgbClr val="333333"/>
+                          </a:solidFill>
+                          <a:latin typeface="Calibri"/>
+                        </a:rPr>
+                        <a:t>1</a:t>
+                      </a:r>
+                    </a:p>
+                  </a:txBody>
+                  <a:tcPr>
+                    <a:solidFill>
+                      <a:srgbClr val="FAFAFA"/>
+                    </a:solidFill>
+                  </a:tcPr>
+                </a:tc>
+                <a:tc>
+                  <a:txBody>
+                    <a:bodyPr/>
+                    <a:lstStyle/>
+                    <a:p>
+                      <a:pPr algn="ctr"/>
+                      <a:r>
+                        <a:rPr sz="900" b="0">
+                          <a:solidFill>
+                            <a:srgbClr val="333333"/>
+                          </a:solidFill>
+                          <a:latin typeface="Calibri"/>
+                        </a:rPr>
+                        <a:t>0</a:t>
+                      </a:r>
+                    </a:p>
+                  </a:txBody>
+                  <a:tcPr>
+                    <a:solidFill>
+                      <a:srgbClr val="FAFAFA"/>
+                    </a:solidFill>
+                  </a:tcPr>
+                </a:tc>
+                <a:tc>
+                  <a:txBody>
+                    <a:bodyPr/>
+                    <a:lstStyle/>
+                    <a:p>
+                      <a:pPr algn="ctr"/>
+                      <a:r>
+                        <a:rPr sz="900" b="0">
+                          <a:solidFill>
+                            <a:srgbClr val="333333"/>
+                          </a:solidFill>
+                          <a:latin typeface="Calibri"/>
+                        </a:rPr>
+                        <a:t>—</a:t>
+                      </a:r>
+                    </a:p>
+                  </a:txBody>
+                  <a:tcPr>
+                    <a:solidFill>
+                      <a:srgbClr val="FAFAFA"/>
+                    </a:solidFill>
+                  </a:tcPr>
+                </a:tc>
+                <a:tc>
+                  <a:txBody>
+                    <a:bodyPr/>
+                    <a:lstStyle/>
+                    <a:p>
+                      <a:pPr algn="ctr"/>
+                      <a:r>
+                        <a:rPr sz="900" b="1">
+                          <a:solidFill>
+                            <a:srgbClr val="A6001A"/>
+                          </a:solidFill>
+                          <a:latin typeface="Calibri"/>
+                        </a:rPr>
+                        <a:t>1</a:t>
+                      </a:r>
+                    </a:p>
+                  </a:txBody>
+                  <a:tcPr>
+                    <a:solidFill>
+                      <a:srgbClr val="FAFAFA"/>
+                    </a:solidFill>
+                  </a:tcPr>
+                </a:tc>
+                <a:tc>
+                  <a:txBody>
+                    <a:bodyPr/>
+                    <a:lstStyle/>
+                    <a:p>
+                      <a:pPr algn="ctr"/>
+                      <a:r>
+                        <a:rPr sz="900" b="0">
+                          <a:solidFill>
+                            <a:srgbClr val="333333"/>
+                          </a:solidFill>
+                          <a:latin typeface="Calibri"/>
+                        </a:rPr>
+                        <a:t>—</a:t>
+                      </a:r>
+                    </a:p>
+                  </a:txBody>
+                  <a:tcPr>
+                    <a:solidFill>
+                      <a:srgbClr val="FAFAFA"/>
+                    </a:solidFill>
+                  </a:tcPr>
+                </a:tc>
+                <a:tc>
+                  <a:txBody>
+                    <a:bodyPr/>
+                    <a:lstStyle/>
+                    <a:p>
+                      <a:pPr algn="ctr"/>
+                      <a:r>
+                        <a:rPr sz="900" b="0">
+                          <a:solidFill>
+                            <a:srgbClr val="333333"/>
+                          </a:solidFill>
+                          <a:latin typeface="Calibri"/>
+                        </a:rPr>
+                        <a:t>—</a:t>
+                      </a:r>
+                    </a:p>
+                  </a:txBody>
+                  <a:tcPr>
+                    <a:solidFill>
+                      <a:srgbClr val="FAFAFA"/>
+                    </a:solidFill>
+                  </a:tcPr>
+                </a:tc>
+              </a:tr>
+              <a:tr h="182880">
+                <a:tc>
+                  <a:txBody>
+                    <a:bodyPr/>
+                    <a:lstStyle/>
+                    <a:p>
+                      <a:pPr algn="l"/>
+                      <a:r>
+                        <a:rPr sz="900" b="0">
+                          <a:solidFill>
+                            <a:srgbClr val="333333"/>
+                          </a:solidFill>
+                          <a:latin typeface="Calibri"/>
+                        </a:rPr>
+                        <a:t>Mal Kabul</a:t>
+                      </a:r>
+                    </a:p>
+                  </a:txBody>
+                  <a:tcPr>
+                    <a:solidFill>
+                      <a:srgbClr val="FFFFFF"/>
+                    </a:solidFill>
+                  </a:tcPr>
+                </a:tc>
+                <a:tc>
+                  <a:txBody>
+                    <a:bodyPr/>
+                    <a:lstStyle/>
+                    <a:p>
+                      <a:pPr algn="ctr"/>
+                      <a:r>
+                        <a:rPr sz="900" b="0">
+                          <a:solidFill>
+                            <a:srgbClr val="333333"/>
+                          </a:solidFill>
+                          <a:latin typeface="Calibri"/>
+                        </a:rPr>
+                        <a:t>6</a:t>
+                      </a:r>
+                    </a:p>
+                  </a:txBody>
+                  <a:tcPr>
+                    <a:solidFill>
+                      <a:srgbClr val="FFFFFF"/>
+                    </a:solidFill>
+                  </a:tcPr>
+                </a:tc>
+                <a:tc>
+                  <a:txBody>
+                    <a:bodyPr/>
+                    <a:lstStyle/>
+                    <a:p>
+                      <a:pPr algn="ctr"/>
+                      <a:r>
+                        <a:rPr sz="900" b="0">
+                          <a:solidFill>
+                            <a:srgbClr val="333333"/>
+                          </a:solidFill>
+                          <a:latin typeface="Calibri"/>
+                        </a:rPr>
+                        <a:t>5</a:t>
+                      </a:r>
+                    </a:p>
+                  </a:txBody>
+                  <a:tcPr>
+                    <a:solidFill>
+                      <a:srgbClr val="FFFFFF"/>
+                    </a:solidFill>
+                  </a:tcPr>
+                </a:tc>
+                <a:tc>
+                  <a:txBody>
+                    <a:bodyPr/>
+                    <a:lstStyle/>
+                    <a:p>
+                      <a:pPr algn="ctr"/>
+                      <a:r>
+                        <a:rPr sz="900" b="0">
+                          <a:solidFill>
+                            <a:srgbClr val="333333"/>
+                          </a:solidFill>
+                          <a:latin typeface="Calibri"/>
+                        </a:rPr>
+                        <a:t>1</a:t>
+                      </a:r>
+                    </a:p>
+                  </a:txBody>
+                  <a:tcPr>
+                    <a:solidFill>
+                      <a:srgbClr val="FFFFFF"/>
+                    </a:solidFill>
+                  </a:tcPr>
+                </a:tc>
+                <a:tc>
+                  <a:txBody>
+                    <a:bodyPr/>
+                    <a:lstStyle/>
+                    <a:p>
+                      <a:pPr algn="ctr"/>
+                      <a:r>
+                        <a:rPr sz="900" b="1">
+                          <a:solidFill>
+                            <a:srgbClr val="A6001A"/>
+                          </a:solidFill>
+                          <a:latin typeface="Calibri"/>
+                        </a:rPr>
+                        <a:t>1</a:t>
+                      </a:r>
+                    </a:p>
+                  </a:txBody>
+                  <a:tcPr>
+                    <a:solidFill>
+                      <a:srgbClr val="FFFFFF"/>
+                    </a:solidFill>
+                  </a:tcPr>
+                </a:tc>
+                <a:tc>
+                  <a:txBody>
+                    <a:bodyPr/>
+                    <a:lstStyle/>
+                    <a:p>
+                      <a:pPr algn="ctr"/>
+                      <a:r>
+                        <a:rPr sz="900" b="0">
+                          <a:solidFill>
+                            <a:srgbClr val="333333"/>
+                          </a:solidFill>
+                          <a:latin typeface="Calibri"/>
+                        </a:rPr>
+                        <a:t>—</a:t>
+                      </a:r>
+                    </a:p>
+                  </a:txBody>
+                  <a:tcPr>
+                    <a:solidFill>
+                      <a:srgbClr val="FFFFFF"/>
+                    </a:solidFill>
+                  </a:tcPr>
+                </a:tc>
+                <a:tc>
+                  <a:txBody>
+                    <a:bodyPr/>
+                    <a:lstStyle/>
+                    <a:p>
+                      <a:pPr algn="ctr"/>
+                      <a:r>
+                        <a:rPr sz="900" b="0">
+                          <a:solidFill>
+                            <a:srgbClr val="333333"/>
+                          </a:solidFill>
+                          <a:latin typeface="Calibri"/>
+                        </a:rPr>
+                        <a:t>1</a:t>
+                      </a:r>
+                    </a:p>
+                  </a:txBody>
+                  <a:tcPr>
+                    <a:solidFill>
+                      <a:srgbClr val="FFFFFF"/>
+                    </a:solidFill>
+                  </a:tcPr>
+                </a:tc>
+              </a:tr>
+              <a:tr h="182880">
+                <a:tc>
+                  <a:txBody>
+                    <a:bodyPr/>
+                    <a:lstStyle/>
+                    <a:p>
+                      <a:pPr algn="l"/>
+                      <a:r>
+                        <a:rPr sz="900" b="0">
+                          <a:solidFill>
+                            <a:srgbClr val="333333"/>
+                          </a:solidFill>
+                          <a:latin typeface="Calibri"/>
+                        </a:rPr>
+                        <a:t>Oyuncak</a:t>
+                      </a:r>
+                    </a:p>
+                  </a:txBody>
+                  <a:tcPr>
+                    <a:solidFill>
+                      <a:srgbClr val="FAFAFA"/>
+                    </a:solidFill>
+                  </a:tcPr>
+                </a:tc>
+                <a:tc>
+                  <a:txBody>
+                    <a:bodyPr/>
+                    <a:lstStyle/>
+                    <a:p>
+                      <a:pPr algn="ctr"/>
+                      <a:r>
+                        <a:rPr sz="900" b="0">
+                          <a:solidFill>
+                            <a:srgbClr val="333333"/>
+                          </a:solidFill>
+                          <a:latin typeface="Calibri"/>
+                        </a:rPr>
+                        <a:t>10</a:t>
+                      </a:r>
+                    </a:p>
+                  </a:txBody>
+                  <a:tcPr>
+                    <a:solidFill>
+                      <a:srgbClr val="FAFAFA"/>
+                    </a:solidFill>
+                  </a:tcPr>
+                </a:tc>
+                <a:tc>
+                  <a:txBody>
+                    <a:bodyPr/>
+                    <a:lstStyle/>
+                    <a:p>
+                      <a:pPr algn="ctr"/>
+                      <a:r>
+                        <a:rPr sz="900" b="0">
+                          <a:solidFill>
+                            <a:srgbClr val="333333"/>
+                          </a:solidFill>
+                          <a:latin typeface="Calibri"/>
+                        </a:rPr>
+                        <a:t>10</a:t>
+                      </a:r>
+                    </a:p>
+                  </a:txBody>
+                  <a:tcPr>
+                    <a:solidFill>
+                      <a:srgbClr val="FAFAFA"/>
+                    </a:solidFill>
+                  </a:tcPr>
+                </a:tc>
+                <a:tc>
+                  <a:txBody>
+                    <a:bodyPr/>
+                    <a:lstStyle/>
+                    <a:p>
+                      <a:pPr algn="ctr"/>
+                      <a:r>
+                        <a:rPr sz="900" b="0">
+                          <a:solidFill>
+                            <a:srgbClr val="333333"/>
+                          </a:solidFill>
+                          <a:latin typeface="Calibri"/>
+                        </a:rPr>
+                        <a:t>—</a:t>
+                      </a:r>
+                    </a:p>
+                  </a:txBody>
+                  <a:tcPr>
+                    <a:solidFill>
+                      <a:srgbClr val="FAFAFA"/>
+                    </a:solidFill>
+                  </a:tcPr>
+                </a:tc>
+                <a:tc>
+                  <a:txBody>
+                    <a:bodyPr/>
+                    <a:lstStyle/>
+                    <a:p>
+                      <a:pPr algn="ctr"/>
+                      <a:r>
+                        <a:rPr sz="900" b="1">
+                          <a:solidFill>
+                            <a:srgbClr val="A6001A"/>
+                          </a:solidFill>
+                          <a:latin typeface="Calibri"/>
+                        </a:rPr>
+                        <a:t>—</a:t>
+                      </a:r>
+                    </a:p>
+                  </a:txBody>
+                  <a:tcPr>
+                    <a:solidFill>
+                      <a:srgbClr val="FAFAFA"/>
+                    </a:solidFill>
+                  </a:tcPr>
+                </a:tc>
+                <a:tc>
+                  <a:txBody>
+                    <a:bodyPr/>
+                    <a:lstStyle/>
+                    <a:p>
+                      <a:pPr algn="ctr"/>
+                      <a:r>
+                        <a:rPr sz="900" b="0">
+                          <a:solidFill>
+                            <a:srgbClr val="333333"/>
+                          </a:solidFill>
+                          <a:latin typeface="Calibri"/>
+                        </a:rPr>
+                        <a:t>—</a:t>
+                      </a:r>
+                    </a:p>
+                  </a:txBody>
+                  <a:tcPr>
+                    <a:solidFill>
+                      <a:srgbClr val="FAFAFA"/>
+                    </a:solidFill>
+                  </a:tcPr>
+                </a:tc>
+                <a:tc>
+                  <a:txBody>
+                    <a:bodyPr/>
+                    <a:lstStyle/>
+                    <a:p>
+                      <a:pPr algn="ctr"/>
+                      <a:r>
+                        <a:rPr sz="900" b="0">
+                          <a:solidFill>
+                            <a:srgbClr val="333333"/>
+                          </a:solidFill>
+                          <a:latin typeface="Calibri"/>
+                        </a:rPr>
+                        <a:t>—</a:t>
+                      </a:r>
+                    </a:p>
+                  </a:txBody>
+                  <a:tcPr>
+                    <a:solidFill>
+                      <a:srgbClr val="FAFAFA"/>
+                    </a:solidFill>
+                  </a:tcPr>
+                </a:tc>
+              </a:tr>
+              <a:tr h="182880">
+                <a:tc>
+                  <a:txBody>
+                    <a:bodyPr/>
+                    <a:lstStyle/>
+                    <a:p>
+                      <a:pPr algn="l"/>
+                      <a:r>
+                        <a:rPr sz="900" b="0">
+                          <a:solidFill>
+                            <a:srgbClr val="333333"/>
+                          </a:solidFill>
+                          <a:latin typeface="Calibri"/>
+                        </a:rPr>
+                        <a:t>Yardımcı Kitap</a:t>
+                      </a:r>
+                    </a:p>
+                  </a:txBody>
+                  <a:tcPr>
+                    <a:solidFill>
+                      <a:srgbClr val="FFFFFF"/>
+                    </a:solidFill>
+                  </a:tcPr>
+                </a:tc>
+                <a:tc>
+                  <a:txBody>
+                    <a:bodyPr/>
+                    <a:lstStyle/>
+                    <a:p>
+                      <a:pPr algn="ctr"/>
+                      <a:r>
+                        <a:rPr sz="900" b="0">
+                          <a:solidFill>
+                            <a:srgbClr val="333333"/>
+                          </a:solidFill>
+                          <a:latin typeface="Calibri"/>
+                        </a:rPr>
+                        <a:t>18</a:t>
+                      </a:r>
+                    </a:p>
+                  </a:txBody>
+                  <a:tcPr>
+                    <a:solidFill>
+                      <a:srgbClr val="FFFFFF"/>
+                    </a:solidFill>
+                  </a:tcPr>
+                </a:tc>
+                <a:tc>
+                  <a:txBody>
+                    <a:bodyPr/>
+                    <a:lstStyle/>
+                    <a:p>
+                      <a:pPr algn="ctr"/>
+                      <a:r>
+                        <a:rPr sz="900" b="0">
+                          <a:solidFill>
+                            <a:srgbClr val="333333"/>
+                          </a:solidFill>
+                          <a:latin typeface="Calibri"/>
+                        </a:rPr>
+                        <a:t>21</a:t>
+                      </a:r>
+                    </a:p>
+                  </a:txBody>
+                  <a:tcPr>
+                    <a:solidFill>
+                      <a:srgbClr val="FFFFFF"/>
+                    </a:solidFill>
+                  </a:tcPr>
+                </a:tc>
+                <a:tc>
+                  <a:txBody>
+                    <a:bodyPr/>
+                    <a:lstStyle/>
+                    <a:p>
+                      <a:pPr algn="ctr"/>
+                      <a:r>
+                        <a:rPr sz="900" b="0">
+                          <a:solidFill>
+                            <a:srgbClr val="333333"/>
+                          </a:solidFill>
+                          <a:latin typeface="Calibri"/>
+                        </a:rPr>
+                        <a:t>—</a:t>
+                      </a:r>
+                    </a:p>
+                  </a:txBody>
+                  <a:tcPr>
+                    <a:solidFill>
+                      <a:srgbClr val="FFFFFF"/>
+                    </a:solidFill>
+                  </a:tcPr>
+                </a:tc>
+                <a:tc>
+                  <a:txBody>
+                    <a:bodyPr/>
+                    <a:lstStyle/>
+                    <a:p>
+                      <a:pPr algn="ctr"/>
+                      <a:r>
+                        <a:rPr sz="900" b="1">
+                          <a:solidFill>
+                            <a:srgbClr val="A6001A"/>
+                          </a:solidFill>
+                          <a:latin typeface="Calibri"/>
+                        </a:rPr>
+                        <a:t>—</a:t>
+                      </a:r>
+                    </a:p>
+                  </a:txBody>
+                  <a:tcPr>
+                    <a:solidFill>
+                      <a:srgbClr val="FFFFFF"/>
+                    </a:solidFill>
+                  </a:tcPr>
+                </a:tc>
+                <a:tc>
+                  <a:txBody>
+                    <a:bodyPr/>
+                    <a:lstStyle/>
+                    <a:p>
+                      <a:pPr algn="ctr"/>
+                      <a:r>
+                        <a:rPr sz="900" b="0">
+                          <a:solidFill>
+                            <a:srgbClr val="333333"/>
+                          </a:solidFill>
+                          <a:latin typeface="Calibri"/>
+                        </a:rPr>
+                        <a:t>3</a:t>
+                      </a:r>
+                    </a:p>
+                  </a:txBody>
+                  <a:tcPr>
+                    <a:solidFill>
+                      <a:srgbClr val="FFFFFF"/>
+                    </a:solidFill>
+                  </a:tcPr>
+                </a:tc>
+                <a:tc>
+                  <a:txBody>
+                    <a:bodyPr/>
+                    <a:lstStyle/>
+                    <a:p>
+                      <a:pPr algn="ctr"/>
+                      <a:r>
+                        <a:rPr sz="900" b="0">
+                          <a:solidFill>
+                            <a:srgbClr val="333333"/>
+                          </a:solidFill>
+                          <a:latin typeface="Calibri"/>
+                        </a:rPr>
+                        <a:t>15</a:t>
+                      </a:r>
+                    </a:p>
+                  </a:txBody>
+                  <a:tcPr>
+                    <a:solidFill>
+                      <a:srgbClr val="FFFFFF"/>
+                    </a:solidFill>
+                  </a:tcPr>
+                </a:tc>
+              </a:tr>
+              <a:tr h="182880">
+                <a:tc>
+                  <a:txBody>
+                    <a:bodyPr/>
+                    <a:lstStyle/>
+                    <a:p>
+                      <a:pPr algn="l"/>
+                      <a:r>
+                        <a:rPr sz="900" b="0">
+                          <a:solidFill>
+                            <a:srgbClr val="333333"/>
+                          </a:solidFill>
+                          <a:latin typeface="Calibri"/>
+                        </a:rPr>
+                        <a:t>Kırtasiye</a:t>
+                      </a:r>
+                    </a:p>
+                  </a:txBody>
+                  <a:tcPr>
+                    <a:solidFill>
+                      <a:srgbClr val="FAFAFA"/>
+                    </a:solidFill>
+                  </a:tcPr>
+                </a:tc>
+                <a:tc>
+                  <a:txBody>
+                    <a:bodyPr/>
+                    <a:lstStyle/>
+                    <a:p>
+                      <a:pPr algn="ctr"/>
+                      <a:r>
+                        <a:rPr sz="900" b="0">
+                          <a:solidFill>
+                            <a:srgbClr val="333333"/>
+                          </a:solidFill>
+                          <a:latin typeface="Calibri"/>
+                        </a:rPr>
+                        <a:t>24</a:t>
+                      </a:r>
+                    </a:p>
+                  </a:txBody>
+                  <a:tcPr>
+                    <a:solidFill>
+                      <a:srgbClr val="FAFAFA"/>
+                    </a:solidFill>
+                  </a:tcPr>
+                </a:tc>
+                <a:tc>
+                  <a:txBody>
+                    <a:bodyPr/>
+                    <a:lstStyle/>
+                    <a:p>
+                      <a:pPr algn="ctr"/>
+                      <a:r>
+                        <a:rPr sz="900" b="0">
+                          <a:solidFill>
+                            <a:srgbClr val="333333"/>
+                          </a:solidFill>
+                          <a:latin typeface="Calibri"/>
+                        </a:rPr>
+                        <a:t>23</a:t>
+                      </a:r>
+                    </a:p>
+                  </a:txBody>
+                  <a:tcPr>
+                    <a:solidFill>
+                      <a:srgbClr val="FAFAFA"/>
+                    </a:solidFill>
+                  </a:tcPr>
+                </a:tc>
+                <a:tc>
+                  <a:txBody>
+                    <a:bodyPr/>
+                    <a:lstStyle/>
+                    <a:p>
+                      <a:pPr algn="ctr"/>
+                      <a:r>
+                        <a:rPr sz="900" b="0">
+                          <a:solidFill>
+                            <a:srgbClr val="333333"/>
+                          </a:solidFill>
+                          <a:latin typeface="Calibri"/>
+                        </a:rPr>
                         <a:t>2</a:t>
                       </a:r>
                     </a:p>
                   </a:txBody>
                   <a:tcPr>
                     <a:solidFill>
+                      <a:srgbClr val="FAFAFA"/>
+                    </a:solidFill>
+                  </a:tcPr>
+                </a:tc>
+                <a:tc>
+                  <a:txBody>
+                    <a:bodyPr/>
+                    <a:lstStyle/>
+                    <a:p>
+                      <a:pPr algn="ctr"/>
+                      <a:r>
+                        <a:rPr sz="900" b="1">
+                          <a:solidFill>
+                            <a:srgbClr val="A6001A"/>
+                          </a:solidFill>
+                          <a:latin typeface="Calibri"/>
+                        </a:rPr>
+                        <a:t>1</a:t>
+                      </a:r>
+                    </a:p>
+                  </a:txBody>
+                  <a:tcPr>
+                    <a:solidFill>
+                      <a:srgbClr val="FAFAFA"/>
+                    </a:solidFill>
+                  </a:tcPr>
+                </a:tc>
+                <a:tc>
+                  <a:txBody>
+                    <a:bodyPr/>
+                    <a:lstStyle/>
+                    <a:p>
+                      <a:pPr algn="ctr"/>
+                      <a:r>
+                        <a:rPr sz="900" b="0">
+                          <a:solidFill>
+                            <a:srgbClr val="333333"/>
+                          </a:solidFill>
+                          <a:latin typeface="Calibri"/>
+                        </a:rPr>
+                        <a:t>—</a:t>
+                      </a:r>
+                    </a:p>
+                  </a:txBody>
+                  <a:tcPr>
+                    <a:solidFill>
+                      <a:srgbClr val="FAFAFA"/>
+                    </a:solidFill>
+                  </a:tcPr>
+                </a:tc>
+                <a:tc>
+                  <a:txBody>
+                    <a:bodyPr/>
+                    <a:lstStyle/>
+                    <a:p>
+                      <a:pPr algn="ctr"/>
+                      <a:r>
+                        <a:rPr sz="900" b="0">
+                          <a:solidFill>
+                            <a:srgbClr val="333333"/>
+                          </a:solidFill>
+                          <a:latin typeface="Calibri"/>
+                        </a:rPr>
+                        <a:t>22</a:t>
+                      </a:r>
+                    </a:p>
+                  </a:txBody>
+                  <a:tcPr>
+                    <a:solidFill>
+                      <a:srgbClr val="FAFAFA"/>
+                    </a:solidFill>
+                  </a:tcPr>
+                </a:tc>
+              </a:tr>
+              <a:tr h="182880">
+                <a:tc>
+                  <a:txBody>
+                    <a:bodyPr/>
+                    <a:lstStyle/>
+                    <a:p>
+                      <a:pPr algn="l"/>
+                      <a:r>
+                        <a:rPr sz="900" b="0">
+                          <a:solidFill>
+                            <a:srgbClr val="333333"/>
+                          </a:solidFill>
+                          <a:latin typeface="Calibri"/>
+                        </a:rPr>
+                        <a:t>Kıyafet</a:t>
+                      </a:r>
+                    </a:p>
+                  </a:txBody>
+                  <a:tcPr>
+                    <a:solidFill>
                       <a:srgbClr val="FFFFFF"/>
                     </a:solidFill>
                   </a:tcPr>
@@ -11155,12 +12822,58 @@
                     <a:p>
                       <a:pPr algn="ctr"/>
                       <a:r>
-                        <a:rPr sz="950" b="0">
+                        <a:rPr sz="900" b="0">
                           <a:solidFill>
                             <a:srgbClr val="333333"/>
                           </a:solidFill>
                           <a:latin typeface="Calibri"/>
                         </a:rPr>
+                        <a:t>0</a:t>
+                      </a:r>
+                    </a:p>
+                  </a:txBody>
+                  <a:tcPr>
+                    <a:solidFill>
+                      <a:srgbClr val="FFFFFF"/>
+                    </a:solidFill>
+                  </a:tcPr>
+                </a:tc>
+                <a:tc>
+                  <a:txBody>
+                    <a:bodyPr/>
+                    <a:lstStyle/>
+                    <a:p>
+                      <a:pPr algn="ctr"/>
+                      <a:r>
+                        <a:rPr sz="900" b="0">
+                          <a:solidFill>
+                            <a:srgbClr val="333333"/>
+                          </a:solidFill>
+                          <a:latin typeface="Calibri"/>
+                        </a:rPr>
+                        <a:t>0</a:t>
+                      </a:r>
+                    </a:p>
+                  </a:txBody>
+                  <a:tcPr>
+                    <a:solidFill>
+                      <a:srgbClr val="FFFFFF"/>
+                    </a:solidFill>
+                  </a:tcPr>
+                </a:tc>
+                <a:tc>
+                  <a:txBody>
+                    <a:bodyPr/>
+                    <a:lstStyle/>
+                    <a:p>
+                      <a:pPr algn="ctr"/>
+                      <a:r>
+                        <a:rPr sz="900" b="0">
+                          <a:solidFill>
+                            <a:srgbClr val="333333"/>
+                          </a:solidFill>
+                          <a:latin typeface="Calibri"/>
+                        </a:rPr>
                         <a:t>—</a:t>
                       </a:r>
                     </a:p>
@@ -11178,7 +12891,30 @@
                     <a:p>
                       <a:pPr algn="ctr"/>
                       <a:r>
-                        <a:rPr sz="950" b="0">
+                        <a:rPr sz="900" b="1">
+                          <a:solidFill>
+                            <a:srgbClr val="A6001A"/>
+                          </a:solidFill>
+                          <a:latin typeface="Calibri"/>
+                        </a:rPr>
+                        <a:t>—</a:t>
+                      </a:r>
+                    </a:p>
+                  </a:txBody>
+                  <a:tcPr>
+                    <a:solidFill>
+                      <a:srgbClr val="FFFFFF"/>
+                    </a:solidFill>
+                  </a:tcPr>
+                </a:tc>
+                <a:tc>
+                  <a:txBody>
+                    <a:bodyPr/>
+                    <a:lstStyle/>
+                    <a:p>
+                      <a:pPr algn="ctr"/>
+                      <a:r>
+                        <a:rPr sz="900" b="0">
                           <a:solidFill>
                             <a:srgbClr val="333333"/>
                           </a:solidFill>
@@ -11194,8 +12930,31 @@
                     </a:solidFill>
                   </a:tcPr>
                 </a:tc>
+                <a:tc>
+                  <a:txBody>
+                    <a:bodyPr/>
+                    <a:lstStyle/>
+                    <a:p>
+                      <a:pPr algn="ctr"/>
+                      <a:r>
+                        <a:rPr sz="900" b="0">
+                          <a:solidFill>
+                            <a:srgbClr val="333333"/>
+                          </a:solidFill>
+                          <a:latin typeface="Calibri"/>
+                        </a:rPr>
+                        <a:t>4</a:t>
+                      </a:r>
+                    </a:p>
+                  </a:txBody>
+                  <a:tcPr>
+                    <a:solidFill>
+                      <a:srgbClr val="FFFFFF"/>
+                    </a:solidFill>
+                  </a:tcPr>
+                </a:tc>
               </a:tr>
-              <a:tr h="248602">
+              <a:tr h="182880">
                 <a:tc>
                   <a:txBody>
                     <a:bodyPr/>
@@ -11203,1674 +12962,320 @@
                     <a:p>
                       <a:pPr algn="l"/>
                       <a:r>
-                        <a:rPr sz="950" b="0">
+                        <a:rPr sz="900" b="1">
                           <a:solidFill>
                             <a:srgbClr val="333333"/>
                           </a:solidFill>
                           <a:latin typeface="Calibri"/>
                         </a:rPr>
-                        <a:t>İdari İşler</a:t>
-                      </a:r>
-                    </a:p>
-                  </a:txBody>
-                  <a:tcPr>
-                    <a:solidFill>
-                      <a:srgbClr val="FAFAFA"/>
-                    </a:solidFill>
-                  </a:tcPr>
-                </a:tc>
-                <a:tc>
-                  <a:txBody>
-                    <a:bodyPr/>
-                    <a:lstStyle/>
-                    <a:p>
-                      <a:pPr algn="ctr"/>
-                      <a:r>
-                        <a:rPr sz="950" b="0">
+                        <a:t>TOPLAM</a:t>
+                      </a:r>
+                    </a:p>
+                  </a:txBody>
+                  <a:tcPr>
+                    <a:solidFill>
+                      <a:srgbClr val="F2F2F2"/>
+                    </a:solidFill>
+                  </a:tcPr>
+                </a:tc>
+                <a:tc>
+                  <a:txBody>
+                    <a:bodyPr/>
+                    <a:lstStyle/>
+                    <a:p>
+                      <a:pPr algn="ctr"/>
+                      <a:r>
+                        <a:rPr sz="900" b="1">
                           <a:solidFill>
                             <a:srgbClr val="333333"/>
                           </a:solidFill>
                           <a:latin typeface="Calibri"/>
                         </a:rPr>
-                        <a:t>8</a:t>
-                      </a:r>
-                    </a:p>
-                  </a:txBody>
-                  <a:tcPr>
-                    <a:solidFill>
-                      <a:srgbClr val="FAFAFA"/>
-                    </a:solidFill>
-                  </a:tcPr>
-                </a:tc>
-                <a:tc>
-                  <a:txBody>
-                    <a:bodyPr/>
-                    <a:lstStyle/>
-                    <a:p>
-                      <a:pPr algn="ctr"/>
-                      <a:r>
-                        <a:rPr sz="950" b="0">
+                        <a:t>145</a:t>
+                      </a:r>
+                    </a:p>
+                  </a:txBody>
+                  <a:tcPr>
+                    <a:solidFill>
+                      <a:srgbClr val="F2F2F2"/>
+                    </a:solidFill>
+                  </a:tcPr>
+                </a:tc>
+                <a:tc>
+                  <a:txBody>
+                    <a:bodyPr/>
+                    <a:lstStyle/>
+                    <a:p>
+                      <a:pPr algn="ctr"/>
+                      <a:r>
+                        <a:rPr sz="900" b="1">
                           <a:solidFill>
                             <a:srgbClr val="333333"/>
                           </a:solidFill>
                           <a:latin typeface="Calibri"/>
                         </a:rPr>
-                        <a:t>6</a:t>
-                      </a:r>
-                    </a:p>
-                  </a:txBody>
-                  <a:tcPr>
-                    <a:solidFill>
-                      <a:srgbClr val="FAFAFA"/>
-                    </a:solidFill>
-                  </a:tcPr>
-                </a:tc>
-                <a:tc>
-                  <a:txBody>
-                    <a:bodyPr/>
-                    <a:lstStyle/>
-                    <a:p>
-                      <a:pPr algn="ctr"/>
-                      <a:r>
-                        <a:rPr sz="950" b="1">
+                        <a:t>131</a:t>
+                      </a:r>
+                    </a:p>
+                  </a:txBody>
+                  <a:tcPr>
+                    <a:solidFill>
+                      <a:srgbClr val="F2F2F2"/>
+                    </a:solidFill>
+                  </a:tcPr>
+                </a:tc>
+                <a:tc>
+                  <a:txBody>
+                    <a:bodyPr/>
+                    <a:lstStyle/>
+                    <a:p>
+                      <a:pPr algn="ctr"/>
+                      <a:r>
+                        <a:rPr sz="900" b="1">
+                          <a:solidFill>
+                            <a:srgbClr val="333333"/>
+                          </a:solidFill>
+                          <a:latin typeface="Calibri"/>
+                        </a:rPr>
+                        <a:t>3</a:t>
+                      </a:r>
+                    </a:p>
+                  </a:txBody>
+                  <a:tcPr>
+                    <a:solidFill>
+                      <a:srgbClr val="F2F2F2"/>
+                    </a:solidFill>
+                  </a:tcPr>
+                </a:tc>
+                <a:tc>
+                  <a:txBody>
+                    <a:bodyPr/>
+                    <a:lstStyle/>
+                    <a:p>
+                      <a:pPr algn="ctr"/>
+                      <a:r>
+                        <a:rPr sz="900" b="1">
                           <a:solidFill>
                             <a:srgbClr val="A6001A"/>
                           </a:solidFill>
                           <a:latin typeface="Calibri"/>
                         </a:rPr>
-                        <a:t>2</a:t>
-                      </a:r>
-                    </a:p>
-                  </a:txBody>
-                  <a:tcPr>
-                    <a:solidFill>
-                      <a:srgbClr val="FAFAFA"/>
-                    </a:solidFill>
-                  </a:tcPr>
-                </a:tc>
-                <a:tc>
-                  <a:txBody>
-                    <a:bodyPr/>
-                    <a:lstStyle/>
-                    <a:p>
-                      <a:pPr algn="ctr"/>
-                      <a:r>
-                        <a:rPr sz="950" b="0">
+                        <a:t>17</a:t>
+                      </a:r>
+                    </a:p>
+                  </a:txBody>
+                  <a:tcPr>
+                    <a:solidFill>
+                      <a:srgbClr val="F2F2F2"/>
+                    </a:solidFill>
+                  </a:tcPr>
+                </a:tc>
+                <a:tc>
+                  <a:txBody>
+                    <a:bodyPr/>
+                    <a:lstStyle/>
+                    <a:p>
+                      <a:pPr algn="ctr"/>
+                      <a:r>
+                        <a:rPr sz="900" b="1">
                           <a:solidFill>
                             <a:srgbClr val="333333"/>
                           </a:solidFill>
                           <a:latin typeface="Calibri"/>
                         </a:rPr>
+                        <a:t>3</a:t>
+                      </a:r>
+                    </a:p>
+                  </a:txBody>
+                  <a:tcPr>
+                    <a:solidFill>
+                      <a:srgbClr val="F2F2F2"/>
+                    </a:solidFill>
+                  </a:tcPr>
+                </a:tc>
+                <a:tc>
+                  <a:txBody>
+                    <a:bodyPr/>
+                    <a:lstStyle/>
+                    <a:p>
+                      <a:pPr algn="ctr"/>
+                      <a:r>
+                        <a:rPr sz="900" b="1">
+                          <a:solidFill>
+                            <a:srgbClr val="333333"/>
+                          </a:solidFill>
+                          <a:latin typeface="Calibri"/>
+                        </a:rPr>
+                        <a:t>58</a:t>
+                      </a:r>
+                    </a:p>
+                  </a:txBody>
+                  <a:tcPr>
+                    <a:solidFill>
+                      <a:srgbClr val="F2F2F2"/>
+                    </a:solidFill>
+                  </a:tcPr>
+                </a:tc>
+              </a:tr>
+              <a:tr h="182880">
+                <a:tc>
+                  <a:txBody>
+                    <a:bodyPr/>
+                    <a:lstStyle/>
+                    <a:p>
+                      <a:pPr algn="l"/>
+                      <a:r>
+                        <a:rPr sz="900" b="0">
+                          <a:solidFill>
+                            <a:srgbClr val="333333"/>
+                          </a:solidFill>
+                          <a:latin typeface="Calibri"/>
+                        </a:rPr>
+                        <a:t>Etkinlik (norm dışı)</a:t>
+                      </a:r>
+                    </a:p>
+                  </a:txBody>
+                  <a:tcPr>
+                    <a:solidFill>
+                      <a:srgbClr val="FFF6E6"/>
+                    </a:solidFill>
+                  </a:tcPr>
+                </a:tc>
+                <a:tc>
+                  <a:txBody>
+                    <a:bodyPr/>
+                    <a:lstStyle/>
+                    <a:p>
+                      <a:pPr algn="ctr"/>
+                      <a:r>
+                        <a:rPr sz="900" b="0">
+                          <a:solidFill>
+                            <a:srgbClr val="333333"/>
+                          </a:solidFill>
+                          <a:latin typeface="Calibri"/>
+                        </a:rPr>
                         <a:t>—</a:t>
                       </a:r>
                     </a:p>
                   </a:txBody>
                   <a:tcPr>
                     <a:solidFill>
-                      <a:srgbClr val="FAFAFA"/>
-                    </a:solidFill>
-                  </a:tcPr>
-                </a:tc>
-                <a:tc>
-                  <a:txBody>
-                    <a:bodyPr/>
-                    <a:lstStyle/>
-                    <a:p>
-                      <a:pPr algn="ctr"/>
-                      <a:r>
-                        <a:rPr sz="950" b="0">
+                      <a:srgbClr val="FFF6E6"/>
+                    </a:solidFill>
+                  </a:tcPr>
+                </a:tc>
+                <a:tc>
+                  <a:txBody>
+                    <a:bodyPr/>
+                    <a:lstStyle/>
+                    <a:p>
+                      <a:pPr algn="ctr"/>
+                      <a:r>
+                        <a:rPr sz="900" b="0">
                           <a:solidFill>
                             <a:srgbClr val="333333"/>
                           </a:solidFill>
                           <a:latin typeface="Calibri"/>
                         </a:rPr>
+                        <a:t>3</a:t>
+                      </a:r>
+                    </a:p>
+                  </a:txBody>
+                  <a:tcPr>
+                    <a:solidFill>
+                      <a:srgbClr val="FFF6E6"/>
+                    </a:solidFill>
+                  </a:tcPr>
+                </a:tc>
+                <a:tc>
+                  <a:txBody>
+                    <a:bodyPr/>
+                    <a:lstStyle/>
+                    <a:p>
+                      <a:pPr algn="ctr"/>
+                      <a:r>
+                        <a:rPr sz="900" b="0">
+                          <a:solidFill>
+                            <a:srgbClr val="333333"/>
+                          </a:solidFill>
+                          <a:latin typeface="Calibri"/>
+                        </a:rPr>
                         <a:t>—</a:t>
                       </a:r>
                     </a:p>
                   </a:txBody>
                   <a:tcPr>
                     <a:solidFill>
-                      <a:srgbClr val="FAFAFA"/>
-                    </a:solidFill>
-                  </a:tcPr>
-                </a:tc>
-              </a:tr>
-              <a:tr h="248602">
-                <a:tc>
-                  <a:txBody>
-                    <a:bodyPr/>
-                    <a:lstStyle/>
-                    <a:p>
-                      <a:pPr algn="l"/>
-                      <a:r>
-                        <a:rPr sz="950" b="0">
+                      <a:srgbClr val="FFF6E6"/>
+                    </a:solidFill>
+                  </a:tcPr>
+                </a:tc>
+                <a:tc>
+                  <a:txBody>
+                    <a:bodyPr/>
+                    <a:lstStyle/>
+                    <a:p>
+                      <a:pPr algn="ctr"/>
+                      <a:r>
+                        <a:rPr sz="900" b="1">
+                          <a:solidFill>
+                            <a:srgbClr val="A6001A"/>
+                          </a:solidFill>
+                          <a:latin typeface="Calibri"/>
+                        </a:rPr>
+                        <a:t>—</a:t>
+                      </a:r>
+                    </a:p>
+                  </a:txBody>
+                  <a:tcPr>
+                    <a:solidFill>
+                      <a:srgbClr val="FFF6E6"/>
+                    </a:solidFill>
+                  </a:tcPr>
+                </a:tc>
+                <a:tc>
+                  <a:txBody>
+                    <a:bodyPr/>
+                    <a:lstStyle/>
+                    <a:p>
+                      <a:pPr algn="ctr"/>
+                      <a:r>
+                        <a:rPr sz="900" b="0">
                           <a:solidFill>
                             <a:srgbClr val="333333"/>
                           </a:solidFill>
                           <a:latin typeface="Calibri"/>
                         </a:rPr>
-                        <a:t>Kasa</a:t>
-                      </a:r>
-                    </a:p>
-                  </a:txBody>
-                  <a:tcPr>
-                    <a:solidFill>
-                      <a:srgbClr val="FFFFFF"/>
-                    </a:solidFill>
-                  </a:tcPr>
-                </a:tc>
-                <a:tc>
-                  <a:txBody>
-                    <a:bodyPr/>
-                    <a:lstStyle/>
-                    <a:p>
-                      <a:pPr algn="ctr"/>
-                      <a:r>
-                        <a:rPr sz="950" b="0">
+                        <a:t>—</a:t>
+                      </a:r>
+                    </a:p>
+                  </a:txBody>
+                  <a:tcPr>
+                    <a:solidFill>
+                      <a:srgbClr val="FFF6E6"/>
+                    </a:solidFill>
+                  </a:tcPr>
+                </a:tc>
+                <a:tc>
+                  <a:txBody>
+                    <a:bodyPr/>
+                    <a:lstStyle/>
+                    <a:p>
+                      <a:pPr algn="ctr"/>
+                      <a:r>
+                        <a:rPr sz="900" b="0">
                           <a:solidFill>
                             <a:srgbClr val="333333"/>
                           </a:solidFill>
                           <a:latin typeface="Calibri"/>
                         </a:rPr>
-                        <a:t>16</a:t>
-                      </a:r>
-                    </a:p>
-                  </a:txBody>
-                  <a:tcPr>
-                    <a:solidFill>
-                      <a:srgbClr val="FFFFFF"/>
-                    </a:solidFill>
-                  </a:tcPr>
-                </a:tc>
-                <a:tc>
-                  <a:txBody>
-                    <a:bodyPr/>
-                    <a:lstStyle/>
-                    <a:p>
-                      <a:pPr algn="ctr"/>
-                      <a:r>
-                        <a:rPr sz="950" b="0">
-                          <a:solidFill>
-                            <a:srgbClr val="333333"/>
-                          </a:solidFill>
-                          <a:latin typeface="Calibri"/>
-                        </a:rPr>
-                        <a:t>15</a:t>
-                      </a:r>
-                    </a:p>
-                  </a:txBody>
-                  <a:tcPr>
-                    <a:solidFill>
-                      <a:srgbClr val="FFFFFF"/>
-                    </a:solidFill>
-                  </a:tcPr>
-                </a:tc>
-                <a:tc>
-                  <a:txBody>
-                    <a:bodyPr/>
-                    <a:lstStyle/>
-                    <a:p>
-                      <a:pPr algn="ctr"/>
-                      <a:r>
-                        <a:rPr sz="950" b="1">
-                          <a:solidFill>
-                            <a:srgbClr val="A6001A"/>
-                          </a:solidFill>
-                          <a:latin typeface="Calibri"/>
-                        </a:rPr>
-                        <a:t>1</a:t>
-                      </a:r>
-                    </a:p>
-                  </a:txBody>
-                  <a:tcPr>
-                    <a:solidFill>
-                      <a:srgbClr val="FFFFFF"/>
-                    </a:solidFill>
-                  </a:tcPr>
-                </a:tc>
-                <a:tc>
-                  <a:txBody>
-                    <a:bodyPr/>
-                    <a:lstStyle/>
-                    <a:p>
-                      <a:pPr algn="ctr"/>
-                      <a:r>
-                        <a:rPr sz="950" b="0">
-                          <a:solidFill>
-                            <a:srgbClr val="333333"/>
-                          </a:solidFill>
-                          <a:latin typeface="Calibri"/>
-                        </a:rPr>
                         <a:t>—</a:t>
                       </a:r>
                     </a:p>
                   </a:txBody>
                   <a:tcPr>
                     <a:solidFill>
-                      <a:srgbClr val="FFFFFF"/>
-                    </a:solidFill>
-                  </a:tcPr>
-                </a:tc>
-                <a:tc>
-                  <a:txBody>
-                    <a:bodyPr/>
-                    <a:lstStyle/>
-                    <a:p>
-                      <a:pPr algn="ctr"/>
-                      <a:r>
-                        <a:rPr sz="950" b="0">
-                          <a:solidFill>
-                            <a:srgbClr val="333333"/>
-                          </a:solidFill>
-                          <a:latin typeface="Calibri"/>
-                        </a:rPr>
-                        <a:t>9</a:t>
-                      </a:r>
-                    </a:p>
-                  </a:txBody>
-                  <a:tcPr>
-                    <a:solidFill>
-                      <a:srgbClr val="FFFFFF"/>
-                    </a:solidFill>
-                  </a:tcPr>
-                </a:tc>
-              </a:tr>
-              <a:tr h="248602">
-                <a:tc>
-                  <a:txBody>
-                    <a:bodyPr/>
-                    <a:lstStyle/>
-                    <a:p>
-                      <a:pPr algn="l"/>
-                      <a:r>
-                        <a:rPr sz="950" b="0">
-                          <a:solidFill>
-                            <a:srgbClr val="333333"/>
-                          </a:solidFill>
-                          <a:latin typeface="Calibri"/>
-                        </a:rPr>
-                        <a:t>Muhasebe</a:t>
-                      </a:r>
-                    </a:p>
-                  </a:txBody>
-                  <a:tcPr>
-                    <a:solidFill>
-                      <a:srgbClr val="FAFAFA"/>
-                    </a:solidFill>
-                  </a:tcPr>
-                </a:tc>
-                <a:tc>
-                  <a:txBody>
-                    <a:bodyPr/>
-                    <a:lstStyle/>
-                    <a:p>
-                      <a:pPr algn="ctr"/>
-                      <a:r>
-                        <a:rPr sz="950" b="0">
-                          <a:solidFill>
-                            <a:srgbClr val="333333"/>
-                          </a:solidFill>
-                          <a:latin typeface="Calibri"/>
-                        </a:rPr>
-                        <a:t>1</a:t>
-                      </a:r>
-                    </a:p>
-                  </a:txBody>
-                  <a:tcPr>
-                    <a:solidFill>
-                      <a:srgbClr val="FAFAFA"/>
-                    </a:solidFill>
-                  </a:tcPr>
-                </a:tc>
-                <a:tc>
-                  <a:txBody>
-                    <a:bodyPr/>
-                    <a:lstStyle/>
-                    <a:p>
-                      <a:pPr algn="ctr"/>
-                      <a:r>
-                        <a:rPr sz="950" b="0">
-                          <a:solidFill>
-                            <a:srgbClr val="333333"/>
-                          </a:solidFill>
-                          <a:latin typeface="Calibri"/>
-                        </a:rPr>
-                        <a:t>0</a:t>
-                      </a:r>
-                    </a:p>
-                  </a:txBody>
-                  <a:tcPr>
-                    <a:solidFill>
-                      <a:srgbClr val="FAFAFA"/>
-                    </a:solidFill>
-                  </a:tcPr>
-                </a:tc>
-                <a:tc>
-                  <a:txBody>
-                    <a:bodyPr/>
-                    <a:lstStyle/>
-                    <a:p>
-                      <a:pPr algn="ctr"/>
-                      <a:r>
-                        <a:rPr sz="950" b="1">
-                          <a:solidFill>
-                            <a:srgbClr val="A6001A"/>
-                          </a:solidFill>
-                          <a:latin typeface="Calibri"/>
-                        </a:rPr>
-                        <a:t>1</a:t>
-                      </a:r>
-                    </a:p>
-                  </a:txBody>
-                  <a:tcPr>
-                    <a:solidFill>
-                      <a:srgbClr val="FAFAFA"/>
-                    </a:solidFill>
-                  </a:tcPr>
-                </a:tc>
-                <a:tc>
-                  <a:txBody>
-                    <a:bodyPr/>
-                    <a:lstStyle/>
-                    <a:p>
-                      <a:pPr algn="ctr"/>
-                      <a:r>
-                        <a:rPr sz="950" b="0">
-                          <a:solidFill>
-                            <a:srgbClr val="333333"/>
-                          </a:solidFill>
-                          <a:latin typeface="Calibri"/>
-                        </a:rPr>
-                        <a:t>—</a:t>
-                      </a:r>
-                    </a:p>
-                  </a:txBody>
-                  <a:tcPr>
-                    <a:solidFill>
-                      <a:srgbClr val="FAFAFA"/>
-                    </a:solidFill>
-                  </a:tcPr>
-                </a:tc>
-                <a:tc>
-                  <a:txBody>
-                    <a:bodyPr/>
-                    <a:lstStyle/>
-                    <a:p>
-                      <a:pPr algn="ctr"/>
-                      <a:r>
-                        <a:rPr sz="950" b="0">
-                          <a:solidFill>
-                            <a:srgbClr val="333333"/>
-                          </a:solidFill>
-                          <a:latin typeface="Calibri"/>
-                        </a:rPr>
-                        <a:t>—</a:t>
-                      </a:r>
-                    </a:p>
-                  </a:txBody>
-                  <a:tcPr>
-                    <a:solidFill>
-                      <a:srgbClr val="FAFAFA"/>
-                    </a:solidFill>
-                  </a:tcPr>
-                </a:tc>
-              </a:tr>
-              <a:tr h="248602">
-                <a:tc>
-                  <a:txBody>
-                    <a:bodyPr/>
-                    <a:lstStyle/>
-                    <a:p>
-                      <a:pPr algn="l"/>
-                      <a:r>
-                        <a:rPr sz="950" b="0">
-                          <a:solidFill>
-                            <a:srgbClr val="333333"/>
-                          </a:solidFill>
-                          <a:latin typeface="Calibri"/>
-                        </a:rPr>
-                        <a:t>Oyun Alanı</a:t>
-                      </a:r>
-                    </a:p>
-                  </a:txBody>
-                  <a:tcPr>
-                    <a:solidFill>
-                      <a:srgbClr val="FFFFFF"/>
-                    </a:solidFill>
-                  </a:tcPr>
-                </a:tc>
-                <a:tc>
-                  <a:txBody>
-                    <a:bodyPr/>
-                    <a:lstStyle/>
-                    <a:p>
-                      <a:pPr algn="ctr"/>
-                      <a:r>
-                        <a:rPr sz="950" b="0">
-                          <a:solidFill>
-                            <a:srgbClr val="333333"/>
-                          </a:solidFill>
-                          <a:latin typeface="Calibri"/>
-                        </a:rPr>
-                        <a:t>1</a:t>
-                      </a:r>
-                    </a:p>
-                  </a:txBody>
-                  <a:tcPr>
-                    <a:solidFill>
-                      <a:srgbClr val="FFFFFF"/>
-                    </a:solidFill>
-                  </a:tcPr>
-                </a:tc>
-                <a:tc>
-                  <a:txBody>
-                    <a:bodyPr/>
-                    <a:lstStyle/>
-                    <a:p>
-                      <a:pPr algn="ctr"/>
-                      <a:r>
-                        <a:rPr sz="950" b="0">
-                          <a:solidFill>
-                            <a:srgbClr val="333333"/>
-                          </a:solidFill>
-                          <a:latin typeface="Calibri"/>
-                        </a:rPr>
-                        <a:t>0</a:t>
-                      </a:r>
-                    </a:p>
-                  </a:txBody>
-                  <a:tcPr>
-                    <a:solidFill>
-                      <a:srgbClr val="FFFFFF"/>
-                    </a:solidFill>
-                  </a:tcPr>
-                </a:tc>
-                <a:tc>
-                  <a:txBody>
-                    <a:bodyPr/>
-                    <a:lstStyle/>
-                    <a:p>
-                      <a:pPr algn="ctr"/>
-                      <a:r>
-                        <a:rPr sz="950" b="1">
-                          <a:solidFill>
-                            <a:srgbClr val="A6001A"/>
-                          </a:solidFill>
-                          <a:latin typeface="Calibri"/>
-                        </a:rPr>
-                        <a:t>1</a:t>
-                      </a:r>
-                    </a:p>
-                  </a:txBody>
-                  <a:tcPr>
-                    <a:solidFill>
-                      <a:srgbClr val="FFFFFF"/>
-                    </a:solidFill>
-                  </a:tcPr>
-                </a:tc>
-                <a:tc>
-                  <a:txBody>
-                    <a:bodyPr/>
-                    <a:lstStyle/>
-                    <a:p>
-                      <a:pPr algn="ctr"/>
-                      <a:r>
-                        <a:rPr sz="950" b="0">
-                          <a:solidFill>
-                            <a:srgbClr val="333333"/>
-                          </a:solidFill>
-                          <a:latin typeface="Calibri"/>
-                        </a:rPr>
-                        <a:t>—</a:t>
-                      </a:r>
-                    </a:p>
-                  </a:txBody>
-                  <a:tcPr>
-                    <a:solidFill>
-                      <a:srgbClr val="FFFFFF"/>
-                    </a:solidFill>
-                  </a:tcPr>
-                </a:tc>
-                <a:tc>
-                  <a:txBody>
-                    <a:bodyPr/>
-                    <a:lstStyle/>
-                    <a:p>
-                      <a:pPr algn="ctr"/>
-                      <a:r>
-                        <a:rPr sz="950" b="0">
-                          <a:solidFill>
-                            <a:srgbClr val="333333"/>
-                          </a:solidFill>
-                          <a:latin typeface="Calibri"/>
-                        </a:rPr>
-                        <a:t>—</a:t>
-                      </a:r>
-                    </a:p>
-                  </a:txBody>
-                  <a:tcPr>
-                    <a:solidFill>
-                      <a:srgbClr val="FFFFFF"/>
-                    </a:solidFill>
-                  </a:tcPr>
-                </a:tc>
-              </a:tr>
-              <a:tr h="248602">
-                <a:tc>
-                  <a:txBody>
-                    <a:bodyPr/>
-                    <a:lstStyle/>
-                    <a:p>
-                      <a:pPr algn="l"/>
-                      <a:r>
-                        <a:rPr sz="950" b="0">
-                          <a:solidFill>
-                            <a:srgbClr val="333333"/>
-                          </a:solidFill>
-                          <a:latin typeface="Calibri"/>
-                        </a:rPr>
-                        <a:t>Akademi</a:t>
-                      </a:r>
-                    </a:p>
-                  </a:txBody>
-                  <a:tcPr>
-                    <a:solidFill>
-                      <a:srgbClr val="FAFAFA"/>
-                    </a:solidFill>
-                  </a:tcPr>
-                </a:tc>
-                <a:tc>
-                  <a:txBody>
-                    <a:bodyPr/>
-                    <a:lstStyle/>
-                    <a:p>
-                      <a:pPr algn="ctr"/>
-                      <a:r>
-                        <a:rPr sz="950" b="0">
-                          <a:solidFill>
-                            <a:srgbClr val="333333"/>
-                          </a:solidFill>
-                          <a:latin typeface="Calibri"/>
-                        </a:rPr>
-                        <a:t>10</a:t>
-                      </a:r>
-                    </a:p>
-                  </a:txBody>
-                  <a:tcPr>
-                    <a:solidFill>
-                      <a:srgbClr val="FAFAFA"/>
-                    </a:solidFill>
-                  </a:tcPr>
-                </a:tc>
-                <a:tc>
-                  <a:txBody>
-                    <a:bodyPr/>
-                    <a:lstStyle/>
-                    <a:p>
-                      <a:pPr algn="ctr"/>
-                      <a:r>
-                        <a:rPr sz="950" b="0">
-                          <a:solidFill>
-                            <a:srgbClr val="333333"/>
-                          </a:solidFill>
-                          <a:latin typeface="Calibri"/>
-                        </a:rPr>
-                        <a:t>9</a:t>
-                      </a:r>
-                    </a:p>
-                  </a:txBody>
-                  <a:tcPr>
-                    <a:solidFill>
-                      <a:srgbClr val="FAFAFA"/>
-                    </a:solidFill>
-                  </a:tcPr>
-                </a:tc>
-                <a:tc>
-                  <a:txBody>
-                    <a:bodyPr/>
-                    <a:lstStyle/>
-                    <a:p>
-                      <a:pPr algn="ctr"/>
-                      <a:r>
-                        <a:rPr sz="950" b="1">
-                          <a:solidFill>
-                            <a:srgbClr val="A6001A"/>
-                          </a:solidFill>
-                          <a:latin typeface="Calibri"/>
-                        </a:rPr>
-                        <a:t>1</a:t>
-                      </a:r>
-                    </a:p>
-                  </a:txBody>
-                  <a:tcPr>
-                    <a:solidFill>
-                      <a:srgbClr val="FAFAFA"/>
-                    </a:solidFill>
-                  </a:tcPr>
-                </a:tc>
-                <a:tc>
-                  <a:txBody>
-                    <a:bodyPr/>
-                    <a:lstStyle/>
-                    <a:p>
-                      <a:pPr algn="ctr"/>
-                      <a:r>
-                        <a:rPr sz="950" b="0">
-                          <a:solidFill>
-                            <a:srgbClr val="333333"/>
-                          </a:solidFill>
-                          <a:latin typeface="Calibri"/>
-                        </a:rPr>
-                        <a:t>—</a:t>
-                      </a:r>
-                    </a:p>
-                  </a:txBody>
-                  <a:tcPr>
-                    <a:solidFill>
-                      <a:srgbClr val="FAFAFA"/>
-                    </a:solidFill>
-                  </a:tcPr>
-                </a:tc>
-                <a:tc>
-                  <a:txBody>
-                    <a:bodyPr/>
-                    <a:lstStyle/>
-                    <a:p>
-                      <a:pPr algn="ctr"/>
-                      <a:r>
-                        <a:rPr sz="950" b="0">
-                          <a:solidFill>
-                            <a:srgbClr val="333333"/>
-                          </a:solidFill>
-                          <a:latin typeface="Calibri"/>
-                        </a:rPr>
-                        <a:t>—</a:t>
-                      </a:r>
-                    </a:p>
-                  </a:txBody>
-                  <a:tcPr>
-                    <a:solidFill>
-                      <a:srgbClr val="FAFAFA"/>
-                    </a:solidFill>
-                  </a:tcPr>
-                </a:tc>
-              </a:tr>
-              <a:tr h="248602">
-                <a:tc>
-                  <a:txBody>
-                    <a:bodyPr/>
-                    <a:lstStyle/>
-                    <a:p>
-                      <a:pPr algn="l"/>
-                      <a:r>
-                        <a:rPr sz="950" b="0">
-                          <a:solidFill>
-                            <a:srgbClr val="333333"/>
-                          </a:solidFill>
-                          <a:latin typeface="Calibri"/>
-                        </a:rPr>
-                        <a:t>Kıyafet</a:t>
-                      </a:r>
-                    </a:p>
-                  </a:txBody>
-                  <a:tcPr>
-                    <a:solidFill>
-                      <a:srgbClr val="FFFFFF"/>
-                    </a:solidFill>
-                  </a:tcPr>
-                </a:tc>
-                <a:tc>
-                  <a:txBody>
-                    <a:bodyPr/>
-                    <a:lstStyle/>
-                    <a:p>
-                      <a:pPr algn="ctr"/>
-                      <a:r>
-                        <a:rPr sz="950" b="0">
-                          <a:solidFill>
-                            <a:srgbClr val="333333"/>
-                          </a:solidFill>
-                          <a:latin typeface="Calibri"/>
-                        </a:rPr>
-                        <a:t>0</a:t>
-                      </a:r>
-                    </a:p>
-                  </a:txBody>
-                  <a:tcPr>
-                    <a:solidFill>
-                      <a:srgbClr val="FFFFFF"/>
-                    </a:solidFill>
-                  </a:tcPr>
-                </a:tc>
-                <a:tc>
-                  <a:txBody>
-                    <a:bodyPr/>
-                    <a:lstStyle/>
-                    <a:p>
-                      <a:pPr algn="ctr"/>
-                      <a:r>
-                        <a:rPr sz="950" b="0">
-                          <a:solidFill>
-                            <a:srgbClr val="333333"/>
-                          </a:solidFill>
-                          <a:latin typeface="Calibri"/>
-                        </a:rPr>
-                        <a:t>0</a:t>
-                      </a:r>
-                    </a:p>
-                  </a:txBody>
-                  <a:tcPr>
-                    <a:solidFill>
-                      <a:srgbClr val="FFFFFF"/>
-                    </a:solidFill>
-                  </a:tcPr>
-                </a:tc>
-                <a:tc>
-                  <a:txBody>
-                    <a:bodyPr/>
-                    <a:lstStyle/>
-                    <a:p>
-                      <a:pPr algn="ctr"/>
-                      <a:r>
-                        <a:rPr sz="950" b="1">
-                          <a:solidFill>
-                            <a:srgbClr val="A6001A"/>
-                          </a:solidFill>
-                          <a:latin typeface="Calibri"/>
-                        </a:rPr>
-                        <a:t>—</a:t>
-                      </a:r>
-                    </a:p>
-                  </a:txBody>
-                  <a:tcPr>
-                    <a:solidFill>
-                      <a:srgbClr val="FFFFFF"/>
-                    </a:solidFill>
-                  </a:tcPr>
-                </a:tc>
-                <a:tc>
-                  <a:txBody>
-                    <a:bodyPr/>
-                    <a:lstStyle/>
-                    <a:p>
-                      <a:pPr algn="ctr"/>
-                      <a:r>
-                        <a:rPr sz="950" b="0">
-                          <a:solidFill>
-                            <a:srgbClr val="333333"/>
-                          </a:solidFill>
-                          <a:latin typeface="Calibri"/>
-                        </a:rPr>
-                        <a:t>—</a:t>
-                      </a:r>
-                    </a:p>
-                  </a:txBody>
-                  <a:tcPr>
-                    <a:solidFill>
-                      <a:srgbClr val="FFFFFF"/>
-                    </a:solidFill>
-                  </a:tcPr>
-                </a:tc>
-                <a:tc>
-                  <a:txBody>
-                    <a:bodyPr/>
-                    <a:lstStyle/>
-                    <a:p>
-                      <a:pPr algn="ctr"/>
-                      <a:r>
-                        <a:rPr sz="950" b="0">
-                          <a:solidFill>
-                            <a:srgbClr val="333333"/>
-                          </a:solidFill>
-                          <a:latin typeface="Calibri"/>
-                        </a:rPr>
-                        <a:t>4</a:t>
-                      </a:r>
-                    </a:p>
-                  </a:txBody>
-                  <a:tcPr>
-                    <a:solidFill>
-                      <a:srgbClr val="FFFFFF"/>
-                    </a:solidFill>
-                  </a:tcPr>
-                </a:tc>
-              </a:tr>
-              <a:tr h="248602">
-                <a:tc>
-                  <a:txBody>
-                    <a:bodyPr/>
-                    <a:lstStyle/>
-                    <a:p>
-                      <a:pPr algn="l"/>
-                      <a:r>
-                        <a:rPr sz="950" b="0">
-                          <a:solidFill>
-                            <a:srgbClr val="333333"/>
-                          </a:solidFill>
-                          <a:latin typeface="Calibri"/>
-                        </a:rPr>
-                        <a:t>Kırtasiye</a:t>
-                      </a:r>
-                    </a:p>
-                  </a:txBody>
-                  <a:tcPr>
-                    <a:solidFill>
-                      <a:srgbClr val="FAFAFA"/>
-                    </a:solidFill>
-                  </a:tcPr>
-                </a:tc>
-                <a:tc>
-                  <a:txBody>
-                    <a:bodyPr/>
-                    <a:lstStyle/>
-                    <a:p>
-                      <a:pPr algn="ctr"/>
-                      <a:r>
-                        <a:rPr sz="950" b="0">
-                          <a:solidFill>
-                            <a:srgbClr val="333333"/>
-                          </a:solidFill>
-                          <a:latin typeface="Calibri"/>
-                        </a:rPr>
-                        <a:t>24</a:t>
-                      </a:r>
-                    </a:p>
-                  </a:txBody>
-                  <a:tcPr>
-                    <a:solidFill>
-                      <a:srgbClr val="FAFAFA"/>
-                    </a:solidFill>
-                  </a:tcPr>
-                </a:tc>
-                <a:tc>
-                  <a:txBody>
-                    <a:bodyPr/>
-                    <a:lstStyle/>
-                    <a:p>
-                      <a:pPr algn="ctr"/>
-                      <a:r>
-                        <a:rPr sz="950" b="0">
-                          <a:solidFill>
-                            <a:srgbClr val="333333"/>
-                          </a:solidFill>
-                          <a:latin typeface="Calibri"/>
-                        </a:rPr>
-                        <a:t>25</a:t>
-                      </a:r>
-                    </a:p>
-                  </a:txBody>
-                  <a:tcPr>
-                    <a:solidFill>
-                      <a:srgbClr val="FAFAFA"/>
-                    </a:solidFill>
-                  </a:tcPr>
-                </a:tc>
-                <a:tc>
-                  <a:txBody>
-                    <a:bodyPr/>
-                    <a:lstStyle/>
-                    <a:p>
-                      <a:pPr algn="ctr"/>
-                      <a:r>
-                        <a:rPr sz="950" b="1">
-                          <a:solidFill>
-                            <a:srgbClr val="A6001A"/>
-                          </a:solidFill>
-                          <a:latin typeface="Calibri"/>
-                        </a:rPr>
-                        <a:t>—</a:t>
-                      </a:r>
-                    </a:p>
-                  </a:txBody>
-                  <a:tcPr>
-                    <a:solidFill>
-                      <a:srgbClr val="FAFAFA"/>
-                    </a:solidFill>
-                  </a:tcPr>
-                </a:tc>
-                <a:tc>
-                  <a:txBody>
-                    <a:bodyPr/>
-                    <a:lstStyle/>
-                    <a:p>
-                      <a:pPr algn="ctr"/>
-                      <a:r>
-                        <a:rPr sz="950" b="0">
-                          <a:solidFill>
-                            <a:srgbClr val="333333"/>
-                          </a:solidFill>
-                          <a:latin typeface="Calibri"/>
-                        </a:rPr>
-                        <a:t>1</a:t>
-                      </a:r>
-                    </a:p>
-                  </a:txBody>
-                  <a:tcPr>
-                    <a:solidFill>
-                      <a:srgbClr val="FAFAFA"/>
-                    </a:solidFill>
-                  </a:tcPr>
-                </a:tc>
-                <a:tc>
-                  <a:txBody>
-                    <a:bodyPr/>
-                    <a:lstStyle/>
-                    <a:p>
-                      <a:pPr algn="ctr"/>
-                      <a:r>
-                        <a:rPr sz="950" b="0">
-                          <a:solidFill>
-                            <a:srgbClr val="333333"/>
-                          </a:solidFill>
-                          <a:latin typeface="Calibri"/>
-                        </a:rPr>
-                        <a:t>22</a:t>
-                      </a:r>
-                    </a:p>
-                  </a:txBody>
-                  <a:tcPr>
-                    <a:solidFill>
-                      <a:srgbClr val="FAFAFA"/>
-                    </a:solidFill>
-                  </a:tcPr>
-                </a:tc>
-              </a:tr>
-              <a:tr h="248602">
-                <a:tc>
-                  <a:txBody>
-                    <a:bodyPr/>
-                    <a:lstStyle/>
-                    <a:p>
-                      <a:pPr algn="l"/>
-                      <a:r>
-                        <a:rPr sz="950" b="0">
-                          <a:solidFill>
-                            <a:srgbClr val="333333"/>
-                          </a:solidFill>
-                          <a:latin typeface="Calibri"/>
-                        </a:rPr>
-                        <a:t>Mal Kabul</a:t>
-                      </a:r>
-                    </a:p>
-                  </a:txBody>
-                  <a:tcPr>
-                    <a:solidFill>
-                      <a:srgbClr val="FFFFFF"/>
-                    </a:solidFill>
-                  </a:tcPr>
-                </a:tc>
-                <a:tc>
-                  <a:txBody>
-                    <a:bodyPr/>
-                    <a:lstStyle/>
-                    <a:p>
-                      <a:pPr algn="ctr"/>
-                      <a:r>
-                        <a:rPr sz="950" b="0">
-                          <a:solidFill>
-                            <a:srgbClr val="333333"/>
-                          </a:solidFill>
-                          <a:latin typeface="Calibri"/>
-                        </a:rPr>
-                        <a:t>6</a:t>
-                      </a:r>
-                    </a:p>
-                  </a:txBody>
-                  <a:tcPr>
-                    <a:solidFill>
-                      <a:srgbClr val="FFFFFF"/>
-                    </a:solidFill>
-                  </a:tcPr>
-                </a:tc>
-                <a:tc>
-                  <a:txBody>
-                    <a:bodyPr/>
-                    <a:lstStyle/>
-                    <a:p>
-                      <a:pPr algn="ctr"/>
-                      <a:r>
-                        <a:rPr sz="950" b="0">
-                          <a:solidFill>
-                            <a:srgbClr val="333333"/>
-                          </a:solidFill>
-                          <a:latin typeface="Calibri"/>
-                        </a:rPr>
-                        <a:t>6</a:t>
-                      </a:r>
-                    </a:p>
-                  </a:txBody>
-                  <a:tcPr>
-                    <a:solidFill>
-                      <a:srgbClr val="FFFFFF"/>
-                    </a:solidFill>
-                  </a:tcPr>
-                </a:tc>
-                <a:tc>
-                  <a:txBody>
-                    <a:bodyPr/>
-                    <a:lstStyle/>
-                    <a:p>
-                      <a:pPr algn="ctr"/>
-                      <a:r>
-                        <a:rPr sz="950" b="1">
-                          <a:solidFill>
-                            <a:srgbClr val="A6001A"/>
-                          </a:solidFill>
-                          <a:latin typeface="Calibri"/>
-                        </a:rPr>
-                        <a:t>—</a:t>
-                      </a:r>
-                    </a:p>
-                  </a:txBody>
-                  <a:tcPr>
-                    <a:solidFill>
-                      <a:srgbClr val="FFFFFF"/>
-                    </a:solidFill>
-                  </a:tcPr>
-                </a:tc>
-                <a:tc>
-                  <a:txBody>
-                    <a:bodyPr/>
-                    <a:lstStyle/>
-                    <a:p>
-                      <a:pPr algn="ctr"/>
-                      <a:r>
-                        <a:rPr sz="950" b="0">
-                          <a:solidFill>
-                            <a:srgbClr val="333333"/>
-                          </a:solidFill>
-                          <a:latin typeface="Calibri"/>
-                        </a:rPr>
-                        <a:t>—</a:t>
-                      </a:r>
-                    </a:p>
-                  </a:txBody>
-                  <a:tcPr>
-                    <a:solidFill>
-                      <a:srgbClr val="FFFFFF"/>
-                    </a:solidFill>
-                  </a:tcPr>
-                </a:tc>
-                <a:tc>
-                  <a:txBody>
-                    <a:bodyPr/>
-                    <a:lstStyle/>
-                    <a:p>
-                      <a:pPr algn="ctr"/>
-                      <a:r>
-                        <a:rPr sz="950" b="0">
-                          <a:solidFill>
-                            <a:srgbClr val="333333"/>
-                          </a:solidFill>
-                          <a:latin typeface="Calibri"/>
-                        </a:rPr>
-                        <a:t>1</a:t>
-                      </a:r>
-                    </a:p>
-                  </a:txBody>
-                  <a:tcPr>
-                    <a:solidFill>
-                      <a:srgbClr val="FFFFFF"/>
-                    </a:solidFill>
-                  </a:tcPr>
-                </a:tc>
-              </a:tr>
-              <a:tr h="248602">
-                <a:tc>
-                  <a:txBody>
-                    <a:bodyPr/>
-                    <a:lstStyle/>
-                    <a:p>
-                      <a:pPr algn="l"/>
-                      <a:r>
-                        <a:rPr sz="950" b="0">
-                          <a:solidFill>
-                            <a:srgbClr val="333333"/>
-                          </a:solidFill>
-                          <a:latin typeface="Calibri"/>
-                        </a:rPr>
-                        <a:t>Yardımcı Kitap</a:t>
-                      </a:r>
-                    </a:p>
-                  </a:txBody>
-                  <a:tcPr>
-                    <a:solidFill>
-                      <a:srgbClr val="FAFAFA"/>
-                    </a:solidFill>
-                  </a:tcPr>
-                </a:tc>
-                <a:tc>
-                  <a:txBody>
-                    <a:bodyPr/>
-                    <a:lstStyle/>
-                    <a:p>
-                      <a:pPr algn="ctr"/>
-                      <a:r>
-                        <a:rPr sz="950" b="0">
-                          <a:solidFill>
-                            <a:srgbClr val="333333"/>
-                          </a:solidFill>
-                          <a:latin typeface="Calibri"/>
-                        </a:rPr>
-                        <a:t>18</a:t>
-                      </a:r>
-                    </a:p>
-                  </a:txBody>
-                  <a:tcPr>
-                    <a:solidFill>
-                      <a:srgbClr val="FAFAFA"/>
-                    </a:solidFill>
-                  </a:tcPr>
-                </a:tc>
-                <a:tc>
-                  <a:txBody>
-                    <a:bodyPr/>
-                    <a:lstStyle/>
-                    <a:p>
-                      <a:pPr algn="ctr"/>
-                      <a:r>
-                        <a:rPr sz="950" b="0">
-                          <a:solidFill>
-                            <a:srgbClr val="333333"/>
-                          </a:solidFill>
-                          <a:latin typeface="Calibri"/>
-                        </a:rPr>
-                        <a:t>21</a:t>
-                      </a:r>
-                    </a:p>
-                  </a:txBody>
-                  <a:tcPr>
-                    <a:solidFill>
-                      <a:srgbClr val="FAFAFA"/>
-                    </a:solidFill>
-                  </a:tcPr>
-                </a:tc>
-                <a:tc>
-                  <a:txBody>
-                    <a:bodyPr/>
-                    <a:lstStyle/>
-                    <a:p>
-                      <a:pPr algn="ctr"/>
-                      <a:r>
-                        <a:rPr sz="950" b="1">
-                          <a:solidFill>
-                            <a:srgbClr val="A6001A"/>
-                          </a:solidFill>
-                          <a:latin typeface="Calibri"/>
-                        </a:rPr>
-                        <a:t>—</a:t>
-                      </a:r>
-                    </a:p>
-                  </a:txBody>
-                  <a:tcPr>
-                    <a:solidFill>
-                      <a:srgbClr val="FAFAFA"/>
-                    </a:solidFill>
-                  </a:tcPr>
-                </a:tc>
-                <a:tc>
-                  <a:txBody>
-                    <a:bodyPr/>
-                    <a:lstStyle/>
-                    <a:p>
-                      <a:pPr algn="ctr"/>
-                      <a:r>
-                        <a:rPr sz="950" b="0">
-                          <a:solidFill>
-                            <a:srgbClr val="333333"/>
-                          </a:solidFill>
-                          <a:latin typeface="Calibri"/>
-                        </a:rPr>
-                        <a:t>3</a:t>
-                      </a:r>
-                    </a:p>
-                  </a:txBody>
-                  <a:tcPr>
-                    <a:solidFill>
-                      <a:srgbClr val="FAFAFA"/>
-                    </a:solidFill>
-                  </a:tcPr>
-                </a:tc>
-                <a:tc>
-                  <a:txBody>
-                    <a:bodyPr/>
-                    <a:lstStyle/>
-                    <a:p>
-                      <a:pPr algn="ctr"/>
-                      <a:r>
-                        <a:rPr sz="950" b="0">
-                          <a:solidFill>
-                            <a:srgbClr val="333333"/>
-                          </a:solidFill>
-                          <a:latin typeface="Calibri"/>
-                        </a:rPr>
-                        <a:t>15</a:t>
-                      </a:r>
-                    </a:p>
-                  </a:txBody>
-                  <a:tcPr>
-                    <a:solidFill>
-                      <a:srgbClr val="FAFAFA"/>
-                    </a:solidFill>
-                  </a:tcPr>
-                </a:tc>
-              </a:tr>
-              <a:tr h="248602">
-                <a:tc>
-                  <a:txBody>
-                    <a:bodyPr/>
-                    <a:lstStyle/>
-                    <a:p>
-                      <a:pPr algn="l"/>
-                      <a:r>
-                        <a:rPr sz="950" b="0">
-                          <a:solidFill>
-                            <a:srgbClr val="333333"/>
-                          </a:solidFill>
-                          <a:latin typeface="Calibri"/>
-                        </a:rPr>
-                        <a:t>Etkinlik</a:t>
-                      </a:r>
-                    </a:p>
-                  </a:txBody>
-                  <a:tcPr>
-                    <a:solidFill>
-                      <a:srgbClr val="FFFFFF"/>
-                    </a:solidFill>
-                  </a:tcPr>
-                </a:tc>
-                <a:tc>
-                  <a:txBody>
-                    <a:bodyPr/>
-                    <a:lstStyle/>
-                    <a:p>
-                      <a:pPr algn="ctr"/>
-                      <a:r>
-                        <a:rPr sz="950" b="0">
-                          <a:solidFill>
-                            <a:srgbClr val="333333"/>
-                          </a:solidFill>
-                          <a:latin typeface="Calibri"/>
-                        </a:rPr>
-                        <a:t>0</a:t>
-                      </a:r>
-                    </a:p>
-                  </a:txBody>
-                  <a:tcPr>
-                    <a:solidFill>
-                      <a:srgbClr val="FFFFFF"/>
-                    </a:solidFill>
-                  </a:tcPr>
-                </a:tc>
-                <a:tc>
-                  <a:txBody>
-                    <a:bodyPr/>
-                    <a:lstStyle/>
-                    <a:p>
-                      <a:pPr algn="ctr"/>
-                      <a:r>
-                        <a:rPr sz="950" b="0">
-                          <a:solidFill>
-                            <a:srgbClr val="333333"/>
-                          </a:solidFill>
-                          <a:latin typeface="Calibri"/>
-                        </a:rPr>
-                        <a:t>3</a:t>
-                      </a:r>
-                    </a:p>
-                  </a:txBody>
-                  <a:tcPr>
-                    <a:solidFill>
-                      <a:srgbClr val="FFFFFF"/>
-                    </a:solidFill>
-                  </a:tcPr>
-                </a:tc>
-                <a:tc>
-                  <a:txBody>
-                    <a:bodyPr/>
-                    <a:lstStyle/>
-                    <a:p>
-                      <a:pPr algn="ctr"/>
-                      <a:r>
-                        <a:rPr sz="950" b="1">
-                          <a:solidFill>
-                            <a:srgbClr val="A6001A"/>
-                          </a:solidFill>
-                          <a:latin typeface="Calibri"/>
-                        </a:rPr>
-                        <a:t>—</a:t>
-                      </a:r>
-                    </a:p>
-                  </a:txBody>
-                  <a:tcPr>
-                    <a:solidFill>
-                      <a:srgbClr val="FFFFFF"/>
-                    </a:solidFill>
-                  </a:tcPr>
-                </a:tc>
-                <a:tc>
-                  <a:txBody>
-                    <a:bodyPr/>
-                    <a:lstStyle/>
-                    <a:p>
-                      <a:pPr algn="ctr"/>
-                      <a:r>
-                        <a:rPr sz="950" b="0">
-                          <a:solidFill>
-                            <a:srgbClr val="333333"/>
-                          </a:solidFill>
-                          <a:latin typeface="Calibri"/>
-                        </a:rPr>
-                        <a:t>3</a:t>
-                      </a:r>
-                    </a:p>
-                  </a:txBody>
-                  <a:tcPr>
-                    <a:solidFill>
-                      <a:srgbClr val="FFFFFF"/>
-                    </a:solidFill>
-                  </a:tcPr>
-                </a:tc>
-                <a:tc>
-                  <a:txBody>
-                    <a:bodyPr/>
-                    <a:lstStyle/>
-                    <a:p>
-                      <a:pPr algn="ctr"/>
-                      <a:r>
-                        <a:rPr sz="950" b="0">
-                          <a:solidFill>
-                            <a:srgbClr val="333333"/>
-                          </a:solidFill>
-                          <a:latin typeface="Calibri"/>
-                        </a:rPr>
-                        <a:t>—</a:t>
-                      </a:r>
-                    </a:p>
-                  </a:txBody>
-                  <a:tcPr>
-                    <a:solidFill>
-                      <a:srgbClr val="FFFFFF"/>
-                    </a:solidFill>
-                  </a:tcPr>
-                </a:tc>
-              </a:tr>
-              <a:tr h="248602">
-                <a:tc>
-                  <a:txBody>
-                    <a:bodyPr/>
-                    <a:lstStyle/>
-                    <a:p>
-                      <a:pPr algn="l"/>
-                      <a:r>
-                        <a:rPr sz="950" b="0">
-                          <a:solidFill>
-                            <a:srgbClr val="333333"/>
-                          </a:solidFill>
-                          <a:latin typeface="Calibri"/>
-                        </a:rPr>
-                        <a:t>Oyuncak</a:t>
-                      </a:r>
-                    </a:p>
-                  </a:txBody>
-                  <a:tcPr>
-                    <a:solidFill>
-                      <a:srgbClr val="FAFAFA"/>
-                    </a:solidFill>
-                  </a:tcPr>
-                </a:tc>
-                <a:tc>
-                  <a:txBody>
-                    <a:bodyPr/>
-                    <a:lstStyle/>
-                    <a:p>
-                      <a:pPr algn="ctr"/>
-                      <a:r>
-                        <a:rPr sz="950" b="0">
-                          <a:solidFill>
-                            <a:srgbClr val="333333"/>
-                          </a:solidFill>
-                          <a:latin typeface="Calibri"/>
-                        </a:rPr>
-                        <a:t>10</a:t>
-                      </a:r>
-                    </a:p>
-                  </a:txBody>
-                  <a:tcPr>
-                    <a:solidFill>
-                      <a:srgbClr val="FAFAFA"/>
-                    </a:solidFill>
-                  </a:tcPr>
-                </a:tc>
-                <a:tc>
-                  <a:txBody>
-                    <a:bodyPr/>
-                    <a:lstStyle/>
-                    <a:p>
-                      <a:pPr algn="ctr"/>
-                      <a:r>
-                        <a:rPr sz="950" b="0">
-                          <a:solidFill>
-                            <a:srgbClr val="333333"/>
-                          </a:solidFill>
-                          <a:latin typeface="Calibri"/>
-                        </a:rPr>
-                        <a:t>10</a:t>
-                      </a:r>
-                    </a:p>
-                  </a:txBody>
-                  <a:tcPr>
-                    <a:solidFill>
-                      <a:srgbClr val="FAFAFA"/>
-                    </a:solidFill>
-                  </a:tcPr>
-                </a:tc>
-                <a:tc>
-                  <a:txBody>
-                    <a:bodyPr/>
-                    <a:lstStyle/>
-                    <a:p>
-                      <a:pPr algn="ctr"/>
-                      <a:r>
-                        <a:rPr sz="950" b="1">
-                          <a:solidFill>
-                            <a:srgbClr val="A6001A"/>
-                          </a:solidFill>
-                          <a:latin typeface="Calibri"/>
-                        </a:rPr>
-                        <a:t>—</a:t>
-                      </a:r>
-                    </a:p>
-                  </a:txBody>
-                  <a:tcPr>
-                    <a:solidFill>
-                      <a:srgbClr val="FAFAFA"/>
-                    </a:solidFill>
-                  </a:tcPr>
-                </a:tc>
-                <a:tc>
-                  <a:txBody>
-                    <a:bodyPr/>
-                    <a:lstStyle/>
-                    <a:p>
-                      <a:pPr algn="ctr"/>
-                      <a:r>
-                        <a:rPr sz="950" b="0">
-                          <a:solidFill>
-                            <a:srgbClr val="333333"/>
-                          </a:solidFill>
-                          <a:latin typeface="Calibri"/>
-                        </a:rPr>
-                        <a:t>—</a:t>
-                      </a:r>
-                    </a:p>
-                  </a:txBody>
-                  <a:tcPr>
-                    <a:solidFill>
-                      <a:srgbClr val="FAFAFA"/>
-                    </a:solidFill>
-                  </a:tcPr>
-                </a:tc>
-                <a:tc>
-                  <a:txBody>
-                    <a:bodyPr/>
-                    <a:lstStyle/>
-                    <a:p>
-                      <a:pPr algn="ctr"/>
-                      <a:r>
-                        <a:rPr sz="950" b="0">
-                          <a:solidFill>
-                            <a:srgbClr val="333333"/>
-                          </a:solidFill>
-                          <a:latin typeface="Calibri"/>
-                        </a:rPr>
-                        <a:t>—</a:t>
-                      </a:r>
-                    </a:p>
-                  </a:txBody>
-                  <a:tcPr>
-                    <a:solidFill>
-                      <a:srgbClr val="FAFAFA"/>
-                    </a:solidFill>
-                  </a:tcPr>
-                </a:tc>
-              </a:tr>
-              <a:tr h="248609">
-                <a:tc>
-                  <a:txBody>
-                    <a:bodyPr/>
-                    <a:lstStyle/>
-                    <a:p>
-                      <a:pPr algn="l"/>
-                      <a:r>
-                        <a:rPr sz="950" b="1">
-                          <a:solidFill>
-                            <a:srgbClr val="333333"/>
-                          </a:solidFill>
-                          <a:latin typeface="Calibri"/>
-                        </a:rPr>
-                        <a:t>TOPLAM</a:t>
-                      </a:r>
-                    </a:p>
-                  </a:txBody>
-                  <a:tcPr>
-                    <a:solidFill>
-                      <a:srgbClr val="F2F2F2"/>
-                    </a:solidFill>
-                  </a:tcPr>
-                </a:tc>
-                <a:tc>
-                  <a:txBody>
-                    <a:bodyPr/>
-                    <a:lstStyle/>
-                    <a:p>
-                      <a:pPr algn="ctr"/>
-                      <a:r>
-                        <a:rPr sz="950" b="1">
-                          <a:solidFill>
-                            <a:srgbClr val="333333"/>
-                          </a:solidFill>
-                          <a:latin typeface="Calibri"/>
-                        </a:rPr>
-                        <a:t>145</a:t>
-                      </a:r>
-                    </a:p>
-                  </a:txBody>
-                  <a:tcPr>
-                    <a:solidFill>
-                      <a:srgbClr val="F2F2F2"/>
-                    </a:solidFill>
-                  </a:tcPr>
-                </a:tc>
-                <a:tc>
-                  <a:txBody>
-                    <a:bodyPr/>
-                    <a:lstStyle/>
-                    <a:p>
-                      <a:pPr algn="ctr"/>
-                      <a:r>
-                        <a:rPr sz="950" b="1">
-                          <a:solidFill>
-                            <a:srgbClr val="333333"/>
-                          </a:solidFill>
-                          <a:latin typeface="Calibri"/>
-                        </a:rPr>
-                        <a:t>137</a:t>
-                      </a:r>
-                    </a:p>
-                  </a:txBody>
-                  <a:tcPr>
-                    <a:solidFill>
-                      <a:srgbClr val="F2F2F2"/>
-                    </a:solidFill>
-                  </a:tcPr>
-                </a:tc>
-                <a:tc>
-                  <a:txBody>
-                    <a:bodyPr/>
-                    <a:lstStyle/>
-                    <a:p>
-                      <a:pPr algn="ctr"/>
-                      <a:r>
-                        <a:rPr sz="950" b="1">
-                          <a:solidFill>
-                            <a:srgbClr val="A6001A"/>
-                          </a:solidFill>
-                          <a:latin typeface="Calibri"/>
-                        </a:rPr>
-                        <a:t>15</a:t>
-                      </a:r>
-                    </a:p>
-                  </a:txBody>
-                  <a:tcPr>
-                    <a:solidFill>
-                      <a:srgbClr val="F2F2F2"/>
-                    </a:solidFill>
-                  </a:tcPr>
-                </a:tc>
-                <a:tc>
-                  <a:txBody>
-                    <a:bodyPr/>
-                    <a:lstStyle/>
-                    <a:p>
-                      <a:pPr algn="ctr"/>
-                      <a:r>
-                        <a:rPr sz="950" b="1">
-                          <a:solidFill>
-                            <a:srgbClr val="333333"/>
-                          </a:solidFill>
-                          <a:latin typeface="Calibri"/>
-                        </a:rPr>
-                        <a:t>7</a:t>
-                      </a:r>
-                    </a:p>
-                  </a:txBody>
-                  <a:tcPr>
-                    <a:solidFill>
-                      <a:srgbClr val="F2F2F2"/>
-                    </a:solidFill>
-                  </a:tcPr>
-                </a:tc>
-                <a:tc>
-                  <a:txBody>
-                    <a:bodyPr/>
-                    <a:lstStyle/>
-                    <a:p>
-                      <a:pPr algn="ctr"/>
-                      <a:r>
-                        <a:rPr sz="950" b="1">
-                          <a:solidFill>
-                            <a:srgbClr val="333333"/>
-                          </a:solidFill>
-                          <a:latin typeface="Calibri"/>
-                        </a:rPr>
-                        <a:t>58</a:t>
-                      </a:r>
-                    </a:p>
-                  </a:txBody>
-                  <a:tcPr>
-                    <a:solidFill>
-                      <a:srgbClr val="F2F2F2"/>
+                      <a:srgbClr val="FFF6E6"/>
                     </a:solidFill>
                   </a:tcPr>
                 </a:tc>
@@ -13067,9 +13472,9 @@
                 <a:latin typeface="Calibri"/>
               </a:rPr>
               <a:t>Çocuk  5 kişi
-Kültür  2 kişi
 Mağaza  2 kişi
-İdari İşler  2 kişi</a:t>
+İdari İşler  2 kişi
+Kültür  2 kişi</a:t>
             </a:r>
           </a:p>
         </p:txBody>
@@ -13170,7 +13575,7 @@
                 </a:solidFill>
                 <a:latin typeface="Calibri"/>
               </a:rPr>
-              <a:t>Bölüm bazında açık 15 kişi, mağaza bazında 11. Aradaki fark, bir mağazada bir bölümün fazlasının başka bölümün açığını maskelemesinden gelir. Gerçek ihtiyaç bölüm bazında okunur.</a:t>
+              <a:t>Bölüm bazında açık 17 kişi, mağaza bazında 14. Aradaki fark, bir mağazada bir bölümün fazlasının başka bölümün açığını maskelemesinden gelir. Gerçek ihtiyaç bölüm bazında okunur.</a:t>
             </a:r>
           </a:p>
         </p:txBody>
@@ -13209,7 +13614,7 @@
                 </a:solidFill>
                 <a:latin typeface="Calibri"/>
               </a:rPr>
-              <a:t>* Kapsam: norm tablosundaki dört mağaza (Şura yok) · Norm 11.08.2026 tarihli · ETKİNLİK zaten ayrı bölüm satırı (normda 0) · ⚠ ENGELLİ bu tabloda düşülmedi: bölüm dağılımı ölçülmemiştir, bu yüzden ilgili bölümlerin açığı toplamda 3 kişiye kadar daha büyük olabilir · Mağaza toplamı ve operasyonel kıyas için 'Norm Kadro — Mağaza Detayı' slaytına bakılır.</a:t>
+              <a:t>* Norm = engelli DIŞINDAKİ personel (yönetim kararı) — engelli bölüm bazında da DÜŞÜLDÜ: Kırtasiye 2 · Mal Kabul 1 · ETKİNLİK normda tanımlı olmadığı için norm dışı satır olarak en altta · Kapsam: norm tablosundaki dört mağaza (Şura yok) · Norm 11.08.2026 tarihli · Gerçek sayılar 31.08 as-of.</a:t>
             </a:r>
           </a:p>
         </p:txBody>

</xml_diff>

<commit_message>
chore(bkm): deste nötr tonlu sürümle güncellendi (PowerPoint kapandı, dosya kilidi çözüldü)
Co-Authored-By: Claude Opus 5 <noreply@anthropic.com>
</commit_message>
<xml_diff>
--- a/briefings/sezon-kadro-20260902/sunum-kadro-sezon2026.pptx
+++ b/briefings/sezon-kadro-20260902/sunum-kadro-sezon2026.pptx
@@ -11809,7 +11809,7 @@
                 </a:solidFill>
                 <a:latin typeface="Calibri"/>
               </a:rPr>
-              <a:t>** YÖNETİM KARARI: engelli ve etkinlik kadrosu NORM DIŞIDIR — norm doluluğuna sayılmaz, mağaza satırlarından düşülmüştür. Heykel ve Şura'da engelli kadro yoktur (ayrı tüzel kişilik, 50 çalışan altı → 4857/30 yükümlülüğü doğmaz).</a:t>
+              <a:t>** Yönetim kararı: engelli ve etkinlik kadrosu norm dışıdır; norm doluluğuna sayılmaz, mağaza satırlarından düşülmüştür. Heykel ve Şura'da engelli kadro yoktur (ayrı tüzel kişilik, 50 çalışan altı → 4857/30 yükümlülüğü doğmaz).</a:t>
             </a:r>
           </a:p>
         </p:txBody>
@@ -11894,7 +11894,7 @@
                 </a:solidFill>
                 <a:latin typeface="Calibri"/>
               </a:rPr>
-              <a:t>Norm 217 kişi, fiilen çalışan 189 kişi → -28 KİŞİ EKSİK (kadrolu -14 · sezonluk -14).</a:t>
+              <a:t>Norm 217 kişi · fiilen çalışan 189 kişi · fark -28 kişi (kadrolu -14 · sezonluk -14).</a:t>
             </a:r>
           </a:p>
         </p:txBody>
@@ -18248,7 +18248,7 @@
                 </a:solidFill>
                 <a:latin typeface="Calibri"/>
               </a:rPr>
-              <a:t>Alım tercih değil, zorunluluktu</a:t>
+              <a:t>Kadro artmasaydı ne olurdu?</a:t>
             </a:r>
           </a:p>
           <a:p>
@@ -18264,7 +18264,7 @@
                 </a:solidFill>
                 <a:latin typeface="Calibri"/>
               </a:rPr>
-              <a:t>Kadro 2025 seviyesinde kalsaydı, aynı işi çıkarmak 2.984 saat ek fazla mesai isterdi. Kişi başına yılda 465 saat eder; yasal sınır 270 saat, yani sınır aşılırdı. Bugünkü fazla mesai 84 saat ve sınırın içinde. Ama sınıra yaklaşan kişi sayısı 1'den 2'ye çıktı; kadro hâlâ dar.</a:t>
+              <a:t>Kadro 2025 seviyesinde kalsaydı, aynı işi çıkarmak 2.984 saat ek fazla mesai isterdi. Kişi başına yılda 465 saat eder; yasal sınır 270 saat. Bugünkü fazla mesai 84 saat, sınırın içinde. Sınıra yaklaşan kişi sayısı 1'den 2'ye çıktı.</a:t>
             </a:r>
           </a:p>
         </p:txBody>
@@ -23667,7 +23667,7 @@
                 </a:solidFill>
                 <a:latin typeface="Calibri"/>
               </a:rPr>
-              <a:t>Tersi oldu: Sınav Okulları küçüldü. Ocak–Ağustos satışı 136,2 → 105,6 milyon TL (−%22,4). Mağaza +%54,9 büyüdü. Büyümenin tamamı raftan geldi.</a:t>
+              <a:t>Sınav Okulları küçüldü: Ocak–Ağustos satışı 136,2 → 105,6 milyon TL (−%22,4). Mağaza tarafı +%54,9 büyüdü; büyüme mağaza satışından geldi.</a:t>
             </a:r>
           </a:p>
         </p:txBody>
@@ -23859,7 +23859,7 @@
                 </a:solidFill>
                 <a:latin typeface="Calibri"/>
               </a:rPr>
-              <a:t>Kısmen doğru: aynı ürünlerde fiyatlar %19,8 arttı. Bu yüzden ciroya değil ADEDE bakıyoruz: ürün adedi +%34,9 ve adede zam karışmaz.</a:t>
+              <a:t>Aynı ürünlerde fiyatlar %19,8 arttı. Bu yüzden ciroya değil adede bakıyoruz: ürün adedi +%34,9; adede zam karışmaz.</a:t>
             </a:r>
           </a:p>
         </p:txBody>
@@ -24243,7 +24243,7 @@
                 </a:solidFill>
                 <a:latin typeface="Calibri"/>
               </a:rPr>
-              <a:t>Hayır: takvime göre 2026 alımı ortalama 2,5 gün DAHA GEÇ. Temmuz ve öncesi alım 6 kişiden 2'ye indi. Artış 1–14 Ağustos'ta; o iki haftada ürün adedi +%25,1 büyüdü. Alım işi takip etti.</a:t>
+              <a:t>Takvime göre 2026 alımı ortalama 2,5 gün daha geç. Temmuz ve öncesi alım 6 kişiden 2'ye indi. Artış 1–14 Ağustos'ta; o iki haftada ürün adedi +%25,1 büyüdü. Alım işi takip etti.</a:t>
             </a:r>
           </a:p>
         </p:txBody>
@@ -25378,7 +25378,7 @@
                 </a:solidFill>
                 <a:latin typeface="Calibri"/>
               </a:rPr>
-              <a:t>NORMA GÖRE</a:t>
+              <a:t>NORM İLE FARK</a:t>
             </a:r>
           </a:p>
         </p:txBody>
@@ -25541,7 +25541,7 @@
                 </a:solidFill>
                 <a:latin typeface="Calibri"/>
               </a:rPr>
-              <a:t>Kadro fazlası yok. 31 Ağustos'ta personel sayısı, şirketin kendi norm tablosunun 28 KİŞİ ALTINDA.</a:t>
+              <a:t>31 Ağustos'ta çalışan personel 189 kişi; norm tablosundaki karşılığı 217 kişi. Aradaki fark 28 kişi.</a:t>
             </a:r>
           </a:p>
         </p:txBody>
@@ -25733,7 +25733,7 @@
                 </a:solidFill>
                 <a:latin typeface="Calibri"/>
               </a:rPr>
-              <a:t>ürün adedi +%34,9 (574.656 → 775.032) · ciro +%70,6 · hem de eksik kadroyla</a:t>
+              <a:t>ürün adedi +%34,9 (574.656 → 775.032) · ciro +%70,6</a:t>
             </a:r>
           </a:p>
         </p:txBody>
@@ -25772,7 +25772,7 @@
                 </a:solidFill>
                 <a:latin typeface="Calibri"/>
               </a:rPr>
-              <a:t>Fark sezondan ÖNCE oluştu: 30 Haziran'da 139 → 153 (+14). Sezon içinde kadrolu -4 kişi. Personel başına iş +%20,5.</a:t>
+              <a:t>Fark sezondan önce oluştu: 30 Haziran'da 139 → 153 (+14). Sezon içinde kadrolu -4 kişi. Personel başına iş +%20,5.</a:t>
             </a:r>
           </a:p>
         </p:txBody>
@@ -26625,7 +26625,7 @@
           <a:lstStyle/>
           <a:p>
             <a:r>
-              <a:t>Norma göre -28 kişi eksik · kadrolu −4 · ürün adedi +%34,9 · personel başına iş +%20,5</a:t>
+              <a:t>Norm tablosuna göre fark -28 kişi · kadrolu −4 · ürün adedi +%34,9 · personel başına iş +%20,5</a:t>
             </a:r>
           </a:p>
         </p:txBody>
@@ -27977,7 +27977,7 @@
                 </a:solidFill>
                 <a:latin typeface="Calibri"/>
               </a:rPr>
-              <a:t>Sezon döneminde kadro artışı yoktur.</a:t>
+              <a:t>Sezon döneminde kadrolu personel artmadı</a:t>
             </a:r>
           </a:p>
           <a:p>
@@ -32484,7 +32484,7 @@
                 </a:solidFill>
                 <a:latin typeface="Calibri"/>
               </a:rPr>
-              <a:t>O yıl FSM kasada 0, Özlüce kasada 1 kişi vardı — eksik kadroyla çalışma.</a:t>
+              <a:t>O yıl FSM kasada 0, Özlüce kasada 1 kişi çalışıyordu.</a:t>
             </a:r>
           </a:p>
         </p:txBody>
@@ -33282,7 +33282,7 @@
                 </a:solidFill>
                 <a:latin typeface="Calibri"/>
               </a:rPr>
-              <a:t>31 Ağustos'ta kadrolu +14 kişilik artışın tamamı satış ve kasa bölümlerinde; yönetim kadrosunda değişim yoktur.</a:t>
+              <a:t>31 Ağustos'ta kadrolu +14 kişilik artışın tamamı satış ve kasa bölümlerinde; yönetim kadrosu değişmedi.</a:t>
             </a:r>
           </a:p>
         </p:txBody>

</xml_diff>